<commit_message>
Refuter fixes on the deck; video scripts narrated by the students
Deck (outline, generator, pptx, artifact slides): weekday names dropped
(they were a year off), 74 → 67 prompts over three days, the first
autonomous attributed to Asim via Ben, the intake-resume prompt no
longer claimed as called out from over the robot and quoted in full,
the "offers two options" line now says Gemini changed both numbers
anyway, "one-line fix" → "a few lines", the where-it-goes-wrong note
no longer claims every row happened, RAM figure dropped, Ben's quote
flagged as his summary for sign-off. Scrimmage date no longer asserted.

Video scripts: Tom, Sophi and Sadiqah narrate; Ben and Asim are quoted,
not heard. Episodes 0, 6 and 9 rewritten out of first person.

Co-Authored-By: Claude Fable 5.1 <noreply@anthropic.com>
Claude-Session: https://claude.ai/code/session_01RMpvKd2BDz6WMMLBDDy1nT
</commit_message>
<xml_diff>
--- a/slides/kickoff.pptx
+++ b/slides/kickoff.pptx
@@ -693,7 +693,7 @@
           <a:p>
             <a:r>
               <a:rPr lang="en-US" dirty="0"/>
-              <a:t>Read the vague one and ask the room what Gemini would have to guess. Then the specific one: everything it would have guessed is now stated. The third one is verbatim, called out from over the robot — no code words at all, it describes a sequence — and that's why it was a one-line fix in Intake.java. This is the slide for the mechanical kids in the room.</a:t>
+              <a:t>Read the vague one and ask the room what Gemini would have to guess. Then the specific one: everything it would have guessed is now stated. The third one is verbatim from the Sep 19 session — no code words at all, it describes a sequence — and that's why the fix was a few lines in Intake.java. This is the slide for the mechanical kids in the room.</a:t>
             </a:r>
             <a:endParaRPr lang="en-US" dirty="0"/>
           </a:p>
@@ -869,7 +869,7 @@
           <a:p>
             <a:r>
               <a:rPr lang="en-US" dirty="0"/>
-              <a:t>Every one of these happened on the mentor robot; the italic ones are the actual prompts. The pattern: when it's wrong, the description was missing something. Say the missing thing. The fake-gamepad row is the one Ben cares most about: the auto worked, but it was tied to the TeleOp button map because nobody said an auto was coming.</a:t>
+              <a:t>The italic rows and the fake-gamepad row happened on the mentor robot. The compile-error and over-30-seconds rows are the ones you'll hit first that the mentors got lucky on — their delayed auto adds up to 30.7 s on paper and the field timer let it finish. The pattern: when it's wrong, the description was missing something. Say the missing thing. The fake-gamepad row is the one Ben cares most about: the auto worked, but it was tied to the TeleOp button map because nobody said an auto was coming.</a:t>
             </a:r>
             <a:endParaRPr lang="en-US" dirty="0"/>
           </a:p>
@@ -1397,7 +1397,7 @@
           <a:p>
             <a:r>
               <a:rPr lang="en-US" dirty="0"/>
-              <a:t>Tell this as a story, not a list. Be precise about who did what, because coaches will ask: Ben described the architecture on night one and got the first TeleOp and the first autonomous. From then on it was a pair — Asim at the robot deciding what to change, Ben at the keyboard typing it — and for eight prompts Asim at the keyboard himself: tank drive, the strafe fix, the spitting-balls pair, a whole experimental autonomous with three rounds of tuning. The point for the room: the person who understands the robot drives the prompt, whoever's hands are on the keys. Two things make the experiment honest, and say both: Ben CAN write Java, so choosing to describe instead of type was a choice; Asim can't, and made most of the changes anyway. The quotes are verbatim, typos and all. The screenshot is the 'spitting balls out' prompt exactly as typed, with Gemini's answer. If there's time, play docs/video/scrimmage-match3-auto.mp4 from the laptop here.</a:t>
+              <a:t>Tell this as a story, not a list. Be precise about who did what, because coaches will ask: Ben described the architecture on night one and built the TeleOp out over the first two days — the shooter startup sequence, the pulsed feed, the LEDs. The first autonomous was Asim's design, called out at the robot while Ben typed, and from there it was a pair — Asim deciding what to change, Ben typing — plus eight prompts Asim typed himself: tank drive, the strafe fix, the spitting-balls pair, a whole experimental autonomous with three rounds of tuning. The point for the room: the person who understands the robot drives the prompt, whoever's hands are on the keys. Two things make the experiment honest, and say both: Ben CAN write Java, so choosing to describe instead of type was a choice; Asim can't, and made most of the changes anyway. The quotes are verbatim, typos and all. The screenshot is the 'spitting balls out' prompt exactly as typed, with Gemini's answer. If there's time, play docs/video/scrimmage-match3-auto.mp4 from the laptop here.</a:t>
             </a:r>
             <a:endParaRPr lang="en-US" dirty="0"/>
           </a:p>
@@ -3806,7 +3806,7 @@
                   <a:schemeClr val="accent1"/>
                 </a:solidFill>
               </a:rPr>
-              <a:t>Real — called out from over the robot, verbatim</a:t>
+              <a:t>Real — Sep 19 session, verbatim</a:t>
             </a:r>
             <a:endParaRPr lang="en-US" sz="1800" dirty="0"/>
           </a:p>
@@ -3842,7 +3842,7 @@
                   <a:schemeClr val="tx1"/>
                 </a:solidFill>
               </a:rPr>
-              <a:t>“When I start up the flywheel, I want the process to continue to do the reverse function. But then I don't want the intake to resume. I want the intake to stop (whether it was stopped or running).”</a:t>
+              <a:t>“When I start up the flywheel, I want the process to continue to do the reverse function. But then I don't want the intake to resume. I want the intake to stop (whether it was stopped or running). Does that make sense?”</a:t>
             </a:r>
             <a:endParaRPr lang="en-US" sz="1350" dirty="0"/>
           </a:p>
@@ -3878,7 +3878,7 @@
                   <a:schemeClr val="tx2"/>
                 </a:solidFill>
               </a:rPr>
-              <a:t>No code words. A sequence. One-line fix in Intake.java.</a:t>
+              <a:t>No code words. A sequence. A few lines changed in Intake.java.</a:t>
             </a:r>
             <a:endParaRPr lang="en-US" sz="1200" dirty="0"/>
           </a:p>
@@ -6634,7 +6634,7 @@
                   <a:schemeClr val="tx1"/>
                 </a:solidFill>
               </a:rPr>
-              <a:t>A laptop that runs Android Studio (Windows, Mac or Linux; 8 GB RAM minimum, 16 better)</a:t>
+              <a:t>A laptop that runs Android Studio (Windows, Mac or Linux)</a:t>
             </a:r>
             <a:endParaRPr lang="en-US" sz="1600" dirty="0"/>
           </a:p>
@@ -7799,7 +7799,7 @@
                   <a:schemeClr val="tx2"/>
                 </a:solidFill>
               </a:rPr>
-              <a:t>The mentor robot, scrimmage day</a:t>
+              <a:t>The mentor robot in a match</a:t>
             </a:r>
             <a:endParaRPr lang="en-US" sz="1000" dirty="0"/>
           </a:p>
@@ -8558,7 +8558,7 @@
         <p:spPr>
           <a:xfrm>
             <a:off x="960120" y="1371600"/>
-            <a:ext cx="1188720" cy="274320"/>
+            <a:ext cx="1325880" cy="274320"/>
           </a:xfrm>
           <a:prstGeom prst="rect">
             <a:avLst/>
@@ -8579,7 +8579,7 @@
                   <a:schemeClr val="accent1"/>
                 </a:solidFill>
               </a:rPr>
-              <a:t>Wed 10:26 PM</a:t>
+              <a:t>Sep 17, 10:26 PM</a:t>
             </a:r>
             <a:endParaRPr lang="en-US" sz="1100" dirty="0"/>
           </a:p>
@@ -8593,8 +8593,8 @@
         </p:nvSpPr>
         <p:spPr>
           <a:xfrm>
-            <a:off x="2148840" y="1371600"/>
-            <a:ext cx="4343400" cy="530352"/>
+            <a:off x="2286000" y="1371600"/>
+            <a:ext cx="4206240" cy="530352"/>
           </a:xfrm>
           <a:prstGeom prst="rect">
             <a:avLst/>
@@ -8615,7 +8615,7 @@
                   <a:schemeClr val="tx2"/>
                 </a:solidFill>
               </a:rPr>
-              <a:t>Ben (coordinator) describes the whole robot → working TeleOp, subsystem classes</a:t>
+              <a:t>Ben (coordinator) describes the whole robot → working TeleOp that night, subsystem classes</a:t>
             </a:r>
             <a:endParaRPr lang="en-US" sz="1100" dirty="0"/>
           </a:p>
@@ -8655,7 +8655,7 @@
         <p:spPr>
           <a:xfrm>
             <a:off x="960120" y="1901952"/>
-            <a:ext cx="1188720" cy="274320"/>
+            <a:ext cx="1325880" cy="274320"/>
           </a:xfrm>
           <a:prstGeom prst="rect">
             <a:avLst/>
@@ -8676,7 +8676,7 @@
                   <a:schemeClr val="accent1"/>
                 </a:solidFill>
               </a:rPr>
-              <a:t>Thu 9:50 PM</a:t>
+              <a:t>Sep 18, ~9:50 PM</a:t>
             </a:r>
             <a:endParaRPr lang="en-US" sz="1100" dirty="0"/>
           </a:p>
@@ -8690,8 +8690,8 @@
         </p:nvSpPr>
         <p:spPr>
           <a:xfrm>
-            <a:off x="2148840" y="1901952"/>
-            <a:ext cx="4343400" cy="530352"/>
+            <a:off x="2286000" y="1901952"/>
+            <a:ext cx="4206240" cy="530352"/>
           </a:xfrm>
           <a:prstGeom prst="rect">
             <a:avLst/>
@@ -8712,7 +8712,7 @@
                   <a:schemeClr val="tx2"/>
                 </a:solidFill>
               </a:rPr>
-              <a:t>First autonomous state machines: Shoot First / Shoot Delayed</a:t>
+              <a:t>First autonomous state machines, Shoot First / Shoot Delayed — Asim's design, called out at the robot, typed by Ben</a:t>
             </a:r>
             <a:endParaRPr lang="en-US" sz="1100" dirty="0"/>
           </a:p>
@@ -8752,7 +8752,7 @@
         <p:spPr>
           <a:xfrm>
             <a:off x="960120" y="2432304"/>
-            <a:ext cx="1188720" cy="274320"/>
+            <a:ext cx="1325880" cy="274320"/>
           </a:xfrm>
           <a:prstGeom prst="rect">
             <a:avLst/>
@@ -8773,7 +8773,7 @@
                   <a:schemeClr val="accent1"/>
                 </a:solidFill>
               </a:rPr>
-              <a:t>Fri 8:29 AM</a:t>
+              <a:t>Sep 19, 8:29 AM</a:t>
             </a:r>
             <a:endParaRPr lang="en-US" sz="1100" dirty="0"/>
           </a:p>
@@ -8787,8 +8787,8 @@
         </p:nvSpPr>
         <p:spPr>
           <a:xfrm>
-            <a:off x="2148840" y="2432304"/>
-            <a:ext cx="4343400" cy="530352"/>
+            <a:off x="2286000" y="2432304"/>
+            <a:ext cx="4206240" cy="530352"/>
           </a:xfrm>
           <a:prstGeom prst="rect">
             <a:avLst/>
@@ -8809,7 +8809,7 @@
                   <a:schemeClr val="tx2"/>
                 </a:solidFill>
               </a:rPr>
-              <a:t>Asim (mechanical): “holding both joysticks left made the robot strafe right, and vice versa. please fix”</a:t>
+              <a:t>Asim (mechanical), at the keyboard: “holding both joysticks left made the robot strafe right, and vice versa. please fix”</a:t>
             </a:r>
             <a:endParaRPr lang="en-US" sz="1100" dirty="0"/>
           </a:p>
@@ -8849,7 +8849,7 @@
         <p:spPr>
           <a:xfrm>
             <a:off x="960120" y="2962656"/>
-            <a:ext cx="1188720" cy="274320"/>
+            <a:ext cx="1325880" cy="274320"/>
           </a:xfrm>
           <a:prstGeom prst="rect">
             <a:avLst/>
@@ -8870,7 +8870,7 @@
                   <a:schemeClr val="accent1"/>
                 </a:solidFill>
               </a:rPr>
-              <a:t>Fri 8:36 AM</a:t>
+              <a:t>8:36 AM</a:t>
             </a:r>
             <a:endParaRPr lang="en-US" sz="1100" dirty="0"/>
           </a:p>
@@ -8884,8 +8884,8 @@
         </p:nvSpPr>
         <p:spPr>
           <a:xfrm>
-            <a:off x="2148840" y="2962656"/>
-            <a:ext cx="4343400" cy="530352"/>
+            <a:off x="2286000" y="2962656"/>
+            <a:ext cx="4206240" cy="530352"/>
           </a:xfrm>
           <a:prstGeom prst="rect">
             <a:avLst/>
@@ -8946,7 +8946,7 @@
         <p:spPr>
           <a:xfrm>
             <a:off x="960120" y="3493008"/>
-            <a:ext cx="1188720" cy="274320"/>
+            <a:ext cx="1325880" cy="274320"/>
           </a:xfrm>
           <a:prstGeom prst="rect">
             <a:avLst/>
@@ -8967,7 +8967,7 @@
                   <a:schemeClr val="accent1"/>
                 </a:solidFill>
               </a:rPr>
-              <a:t>Fri 8:40 AM</a:t>
+              <a:t>8:40 AM</a:t>
             </a:r>
             <a:endParaRPr lang="en-US" sz="1100" dirty="0"/>
           </a:p>
@@ -8981,8 +8981,8 @@
         </p:nvSpPr>
         <p:spPr>
           <a:xfrm>
-            <a:off x="2148840" y="3493008"/>
-            <a:ext cx="4343400" cy="530352"/>
+            <a:off x="2286000" y="3493008"/>
+            <a:ext cx="4206240" cy="530352"/>
           </a:xfrm>
           <a:prstGeom prst="rect">
             <a:avLst/>
@@ -9043,7 +9043,7 @@
         <p:spPr>
           <a:xfrm>
             <a:off x="960120" y="4023360"/>
-            <a:ext cx="1188720" cy="274320"/>
+            <a:ext cx="1325880" cy="274320"/>
           </a:xfrm>
           <a:prstGeom prst="rect">
             <a:avLst/>
@@ -9064,7 +9064,7 @@
                   <a:schemeClr val="accent1"/>
                 </a:solidFill>
               </a:rPr>
-              <a:t>Fri 11:35 AM</a:t>
+              <a:t>11:35 AM</a:t>
             </a:r>
             <a:endParaRPr lang="en-US" sz="1100" dirty="0"/>
           </a:p>
@@ -9078,8 +9078,8 @@
         </p:nvSpPr>
         <p:spPr>
           <a:xfrm>
-            <a:off x="2148840" y="4023360"/>
-            <a:ext cx="4343400" cy="530352"/>
+            <a:off x="2286000" y="4023360"/>
+            <a:ext cx="4206240" cy="530352"/>
           </a:xfrm>
           <a:prstGeom prst="rect">
             <a:avLst/>
@@ -9140,7 +9140,7 @@
         <p:spPr>
           <a:xfrm>
             <a:off x="960120" y="4553712"/>
-            <a:ext cx="1188720" cy="274320"/>
+            <a:ext cx="1325880" cy="274320"/>
           </a:xfrm>
           <a:prstGeom prst="rect">
             <a:avLst/>
@@ -9161,7 +9161,7 @@
                   <a:schemeClr val="accent1"/>
                 </a:solidFill>
               </a:rPr>
-              <a:t>Fri 11:37 AM</a:t>
+              <a:t>11:37 AM</a:t>
             </a:r>
             <a:endParaRPr lang="en-US" sz="1100" dirty="0"/>
           </a:p>
@@ -9175,8 +9175,8 @@
         </p:nvSpPr>
         <p:spPr>
           <a:xfrm>
-            <a:off x="2148840" y="4553712"/>
-            <a:ext cx="4343400" cy="530352"/>
+            <a:off x="2286000" y="4553712"/>
+            <a:ext cx="4206240" cy="530352"/>
           </a:xfrm>
           <a:prstGeom prst="rect">
             <a:avLst/>
@@ -9237,7 +9237,7 @@
         <p:spPr>
           <a:xfrm>
             <a:off x="960120" y="5084064"/>
-            <a:ext cx="1188720" cy="274320"/>
+            <a:ext cx="1325880" cy="274320"/>
           </a:xfrm>
           <a:prstGeom prst="rect">
             <a:avLst/>
@@ -9258,7 +9258,7 @@
                   <a:schemeClr val="accent1"/>
                 </a:solidFill>
               </a:rPr>
-              <a:t>Fri 2:57 PM</a:t>
+              <a:t>2:57 PM</a:t>
             </a:r>
             <a:endParaRPr lang="en-US" sz="1100" dirty="0"/>
           </a:p>
@@ -9272,8 +9272,8 @@
         </p:nvSpPr>
         <p:spPr>
           <a:xfrm>
-            <a:off x="2148840" y="5084064"/>
-            <a:ext cx="4343400" cy="530352"/>
+            <a:off x="2286000" y="5084064"/>
+            <a:ext cx="4206240" cy="530352"/>
           </a:xfrm>
           <a:prstGeom prst="rect">
             <a:avLst/>
@@ -9294,7 +9294,7 @@
                   <a:schemeClr val="tx1"/>
                 </a:solidFill>
               </a:rPr>
-              <a:t>“Let's set the default speed to 0.95” — tuned value baked in</a:t>
+              <a:t>“Let's set the default speed to 0.95” — default changed from 1.0</a:t>
             </a:r>
             <a:endParaRPr lang="en-US" sz="1100" dirty="0"/>
           </a:p>
@@ -9334,7 +9334,7 @@
         <p:spPr>
           <a:xfrm>
             <a:off x="960120" y="5614416"/>
-            <a:ext cx="1188720" cy="274320"/>
+            <a:ext cx="1325880" cy="274320"/>
           </a:xfrm>
           <a:prstGeom prst="rect">
             <a:avLst/>
@@ -9355,7 +9355,7 @@
                   <a:schemeClr val="accent1"/>
                 </a:solidFill>
               </a:rPr>
-              <a:t>Sat</a:t>
+              <a:t>Scrimmage</a:t>
             </a:r>
             <a:endParaRPr lang="en-US" sz="1100" dirty="0"/>
           </a:p>
@@ -9369,8 +9369,8 @@
         </p:nvSpPr>
         <p:spPr>
           <a:xfrm>
-            <a:off x="2148840" y="5614416"/>
-            <a:ext cx="4343400" cy="530352"/>
+            <a:off x="2286000" y="5614416"/>
+            <a:ext cx="4206240" cy="530352"/>
           </a:xfrm>
           <a:prstGeom prst="rect">
             <a:avLst/>
@@ -9391,7 +9391,7 @@
                   <a:schemeClr val="tx2"/>
                 </a:solidFill>
               </a:rPr>
-              <a:t>Scrimmage. Autonomous scored; TeleOp drove.</a:t>
+              <a:t>Autonomous scored; TeleOp drove.</a:t>
             </a:r>
             <a:endParaRPr lang="en-US" sz="1100" dirty="0"/>
           </a:p>
@@ -9451,7 +9451,7 @@
                   <a:schemeClr val="tx2"/>
                 </a:solidFill>
               </a:rPr>
-              <a:t>Fri 8:36 AM, as typed — and Gemini's reply: it reports the numbers (200 ms at −0.5, 300 ms pause) and offers two options before changing anything.</a:t>
+              <a:t>Sep 19, 8:36 AM, as typed — and Gemini's reply: it reports the numbers (200 ms at −0.5, 300 ms pause), offers two options, then changes both at once. The next prompt put the power back.</a:t>
             </a:r>
             <a:endParaRPr lang="en-US" sz="1100" dirty="0"/>
           </a:p>
@@ -9487,7 +9487,7 @@
                   <a:schemeClr val="accent1"/>
                 </a:solidFill>
               </a:rPr>
-              <a:t>74 prompts over three days. 0 lines of Java typed.</a:t>
+              <a:t>67 prompts over three days. 0 lines of Java typed.</a:t>
             </a:r>
             <a:endParaRPr lang="en-US" sz="2000" dirty="0"/>
           </a:p>
@@ -10043,7 +10043,7 @@
                   <a:schemeClr val="tx1"/>
                 </a:solidFill>
               </a:rPr>
-              <a:t>74 prompts over three days; working TeleOp on night one</a:t>
+              <a:t>67 prompts over three days; working TeleOp on night one</a:t>
             </a:r>
             <a:endParaRPr lang="en-US" sz="1300" dirty="0"/>
           </a:p>
@@ -10169,7 +10169,7 @@
                   <a:schemeClr val="tx1"/>
                 </a:solidFill>
               </a:rPr>
-              <a:t>Mechanical mentor fixed strafe, flywheel bump, controls — in English, from over the robot</a:t>
+              <a:t>Mechanical mentor fixed strafe, flywheel bump and controls — in English, no Java</a:t>
             </a:r>
             <a:endParaRPr lang="en-US" sz="1300" dirty="0"/>
           </a:p>
@@ -10295,7 +10295,7 @@
                   <a:schemeClr val="tx1"/>
                 </a:solidFill>
               </a:rPr>
-              <a:t>Transfer servos pulled Sep 18, 7:50 PM; code reworked that night by describing the new design</a:t>
+              <a:t>Firewheel transfer servos came out Sep 18 (reported 7:50 PM); code reworked that night by describing the new design</a:t>
             </a:r>
             <a:endParaRPr lang="en-US" sz="1300" dirty="0"/>
           </a:p>

</xml_diff>

<commit_message>
Drop the prompt-publishing promise; retitle slide 4; Royd's role
Co-Authored-By: Claude Fable 5.1 <noreply@anthropic.com>
Claude-Session: https://claude.ai/code/session_01RMpvKd2BDz6WMMLBDDy1nT
</commit_message>
<xml_diff>
--- a/slides/kickoff.pptx
+++ b/slides/kickoff.pptx
@@ -1490,7 +1490,7 @@
           <a:p>
             <a:r>
               <a:rPr lang="en-US" dirty="0"/>
-              <a:t>Say every line plainly; this room suspects mentors do our work. Line 1: our students hand-coded our robot this year — no AI. Line 2: the AI experiment was the mentors', on a separate robot, for the mentor competition. Line 3: we're here to hand over what it showed, and we'll publish every prompt our students type when we do use it. Don't argue the rumor; state the facts and move on.</a:t>
+              <a:t>Say every line plainly; this room suspects mentors do our work. Line 1: our students hand-coded our robot this year — no AI. Line 2: the AI experiment was the mentors', on a separate robot, for the mentor competition. Line 3: we're here to hand over what it showed. Don't argue the rumor; state the facts and move on.</a:t>
             </a:r>
             <a:endParaRPr lang="en-US" dirty="0"/>
           </a:p>
@@ -1578,7 +1578,7 @@
           <a:p>
             <a:r>
               <a:rPr lang="en-US" dirty="0"/>
-              <a:t>Read the names. The point of the slide is that the people are named and the AI is named — the same way we're asking every team to credit its code. Royd's role: [Ben: fill in].</a:t>
+              <a:t>Read the names. The point of the slide is that the people are named and the AI is named — the same way we're asking every team to credit its code. Royd is the team's second coach and a mechanical engineer.</a:t>
             </a:r>
             <a:endParaRPr lang="en-US" dirty="0"/>
           </a:p>
@@ -11137,7 +11137,7 @@
                   <a:schemeClr val="tx1"/>
                 </a:solidFill>
               </a:rPr>
-              <a:t>We watched both. This is what the experiment showed, what we'd do with it, and how you can use it — with the receipts.</a:t>
+              <a:t>We watched both. This is what the experiment showed, what we'd do with it, and how you can use it.</a:t>
             </a:r>
             <a:endParaRPr lang="en-US" sz="1800" dirty="0"/>
           </a:p>
@@ -11621,7 +11621,7 @@
                   <a:schemeClr val="accent1"/>
                 </a:solidFill>
               </a:rPr>
-              <a:t>Royd</a:t>
+              <a:t>Royd — coach and mechanical engineer</a:t>
             </a:r>
             <a:endParaRPr lang="en-US" sz="1700" dirty="0"/>
           </a:p>
@@ -11657,7 +11657,7 @@
                   <a:schemeClr val="tx2"/>
                 </a:solidFill>
               </a:rPr>
-              <a:t>[Ben: Royd's role]</a:t>
+              <a:t>Second coach on The Hive.</a:t>
             </a:r>
             <a:endParaRPr lang="en-US" sz="1300" dirty="0"/>
           </a:p>
@@ -12732,7 +12732,7 @@
                   <a:schemeClr val="accent1"/>
                 </a:solidFill>
               </a:rPr>
-              <a:t>AI can make you dumber. Or smarter.</a:t>
+              <a:t>AI can shrink your skills. Or multiply them.</a:t>
             </a:r>
             <a:endParaRPr lang="en-US" sz="3200" dirty="0"/>
           </a:p>

</xml_diff>

<commit_message>
The Hive's own week on the comparison slide; mentors' span is two days and an evening
Co-Authored-By: Claude Fable 5.1 <noreply@anthropic.com>
Claude-Session: https://claude.ai/code/session_01RMpvKd2BDz6WMMLBDDy1nT
</commit_message>
<xml_diff>
--- a/slides/kickoff.pptx
+++ b/slides/kickoff.pptx
@@ -2282,7 +2282,7 @@
           <a:p>
             <a:r>
               <a:rPr lang="en-US" dirty="0"/>
-              <a:t>This is the slide that's ours. The right column is from the mentor transcript (docs/verbatim-transcript.md); the left column is yours to fill from your own week — be concrete and be fair to both. The honest comparison is not 'AI was faster': it's WHERE THE BOTTLENECK WAS. On our robot every change went through whoever could type Java. On the mentor robot the bottleneck moved to describing precisely — and that's a skill the mechanical people already had. That's the thing we want every Utah team to hear.</a:t>
+              <a:t>This is the slide that's ours, and the left column is our real week. Four days of coding, three of us who could code the robot, and we were siloed: Tom wrote TeleOp, Sophi wrote autonomous. The bug: an autonomous borrowed from the FtcRobotController samples only powered two wheels, and Tom found it the morning of the competition, reading Sophi's code without knowing what she had done. Say the thing we'd do differently: AI could have given Tom a summary of the autonomous and he could have questioned it to find the bug. The grunt work: adding one state to the autonomous meant copying the same surrounding code again — 10 to 20 minutes for a new programmer, every time. Our process: the programmer works while a mechanical teammate waits, then sets up the robot and both watch the test; mechanical problems get fixed if quick or go on the to-do list; often it's one programmer doing all of it and kludging around mechanical problems in code. The honest comparison is not 'AI was faster': it's where the bottleneck was. On our robot every change went through whoever could type Java. On the mentor robot the bottleneck moved to describing precisely — and that's a skill the mechanical people already had. The right column is from the mentor transcript: the Sep 17 session was 25 minutes and 5 prompts, then the 18th and the 19th.</a:t>
             </a:r>
             <a:endParaRPr lang="en-US" dirty="0"/>
           </a:p>
@@ -14752,7 +14752,7 @@
                   <a:schemeClr val="tx2"/>
                 </a:solidFill>
               </a:rPr>
-              <a:t>Ben (coordinator) describes the whole robot → working TeleOp that night, subsystem classes</a:t>
+              <a:t>Ben (coordinator) describes the whole robot → working TeleOp that night, subsystem classes (25 minutes, 5 prompts)</a:t>
             </a:r>
             <a:endParaRPr lang="en-US" sz="1100" dirty="0"/>
           </a:p>
@@ -15624,7 +15624,7 @@
                   <a:schemeClr val="accent1"/>
                 </a:solidFill>
               </a:rPr>
-              <a:t>67 prompts over three days. 0 lines of Java typed.</a:t>
+              <a:t>67 prompts, two days and an evening. 0 lines of Java typed.</a:t>
             </a:r>
             <a:endParaRPr lang="en-US" sz="2000" dirty="0"/>
           </a:p>
@@ -16013,14 +16013,14 @@
               <a:buNone/>
             </a:pPr>
             <a:r>
-              <a:rPr lang="en-US" sz="1300" i="1" dirty="0">
-                <a:solidFill>
-                  <a:schemeClr val="tx2"/>
-                </a:solidFill>
-              </a:rPr>
-              <a:t>[THE HIVE: how many of us could write the code?]</a:t>
-            </a:r>
-            <a:endParaRPr lang="en-US" sz="1300" dirty="0"/>
+              <a:rPr lang="en-US" sz="1150" dirty="0">
+                <a:solidFill>
+                  <a:schemeClr val="tx1"/>
+                </a:solidFill>
+              </a:rPr>
+              <a:t>3 of us could code it: Tom, Sophi, Sadiqah. Siloed — Tom wrote TeleOp, Sophi wrote autonomous</a:t>
+            </a:r>
+            <a:endParaRPr lang="en-US" sz="1150" dirty="0"/>
           </a:p>
         </p:txBody>
       </p:sp>
@@ -16049,14 +16049,14 @@
               <a:buNone/>
             </a:pPr>
             <a:r>
-              <a:rPr lang="en-US" sz="1300" dirty="0">
+              <a:rPr lang="en-US" sz="1150" dirty="0">
                 <a:solidFill>
                   <a:schemeClr val="tx1"/>
                 </a:solidFill>
               </a:rPr>
               <a:t>2 people wrote prompts — one writes Java, one doesn't</a:t>
             </a:r>
-            <a:endParaRPr lang="en-US" sz="1300" dirty="0"/>
+            <a:endParaRPr lang="en-US" sz="1150" dirty="0"/>
           </a:p>
         </p:txBody>
       </p:sp>
@@ -16139,14 +16139,14 @@
               <a:buNone/>
             </a:pPr>
             <a:r>
-              <a:rPr lang="en-US" sz="1300" i="1" dirty="0">
-                <a:solidFill>
-                  <a:schemeClr val="tx2"/>
-                </a:solidFill>
-              </a:rPr>
-              <a:t>[THE HIVE: hours spent coding during the week]</a:t>
-            </a:r>
-            <a:endParaRPr lang="en-US" sz="1300" dirty="0"/>
+              <a:rPr lang="en-US" sz="1150" dirty="0">
+                <a:solidFill>
+                  <a:schemeClr val="tx1"/>
+                </a:solidFill>
+              </a:rPr>
+              <a:t>4 days of coding</a:t>
+            </a:r>
+            <a:endParaRPr lang="en-US" sz="1150" dirty="0"/>
           </a:p>
         </p:txBody>
       </p:sp>
@@ -16175,14 +16175,14 @@
               <a:buNone/>
             </a:pPr>
             <a:r>
-              <a:rPr lang="en-US" sz="1300" dirty="0">
+              <a:rPr lang="en-US" sz="1150" dirty="0">
                 <a:solidFill>
                   <a:schemeClr val="tx1"/>
                 </a:solidFill>
               </a:rPr>
-              <a:t>67 prompts over three days; working TeleOp on night one</a:t>
-            </a:r>
-            <a:endParaRPr lang="en-US" sz="1300" dirty="0"/>
+              <a:t>67 prompts over two days and an evening; working TeleOp the first night</a:t>
+            </a:r>
+            <a:endParaRPr lang="en-US" sz="1150" dirty="0"/>
           </a:p>
         </p:txBody>
       </p:sp>
@@ -16265,14 +16265,14 @@
               <a:buNone/>
             </a:pPr>
             <a:r>
-              <a:rPr lang="en-US" sz="1300" i="1" dirty="0">
-                <a:solidFill>
-                  <a:schemeClr val="tx2"/>
-                </a:solidFill>
-              </a:rPr>
-              <a:t>[THE HIVE: what broke, and who could fix it]</a:t>
-            </a:r>
-            <a:endParaRPr lang="en-US" sz="1300" dirty="0"/>
+              <a:rPr lang="en-US" sz="1150" dirty="0">
+                <a:solidFill>
+                  <a:schemeClr val="tx1"/>
+                </a:solidFill>
+              </a:rPr>
+              <a:t>A borrowed sample autonomous only powered two wheels. Tom found it the morning of the competition, reading Sophi's code cold</a:t>
+            </a:r>
+            <a:endParaRPr lang="en-US" sz="1150" dirty="0"/>
           </a:p>
         </p:txBody>
       </p:sp>
@@ -16301,14 +16301,14 @@
               <a:buNone/>
             </a:pPr>
             <a:r>
-              <a:rPr lang="en-US" sz="1300" dirty="0">
+              <a:rPr lang="en-US" sz="1150" dirty="0">
                 <a:solidFill>
                   <a:schemeClr val="tx1"/>
                 </a:solidFill>
               </a:rPr>
               <a:t>Mechanical mentor fixed strafe, flywheel bump and controls — in English, no Java</a:t>
             </a:r>
-            <a:endParaRPr lang="en-US" sz="1300" dirty="0"/>
+            <a:endParaRPr lang="en-US" sz="1150" dirty="0"/>
           </a:p>
         </p:txBody>
       </p:sp>
@@ -16391,14 +16391,14 @@
               <a:buNone/>
             </a:pPr>
             <a:r>
-              <a:rPr lang="en-US" sz="1300" i="1" dirty="0">
-                <a:solidFill>
-                  <a:schemeClr val="tx2"/>
-                </a:solidFill>
-              </a:rPr>
-              <a:t>[THE HIVE: how a mechanical change reached the code]</a:t>
-            </a:r>
-            <a:endParaRPr lang="en-US" sz="1300" dirty="0"/>
+              <a:rPr lang="en-US" sz="1150" dirty="0">
+                <a:solidFill>
+                  <a:schemeClr val="tx1"/>
+                </a:solidFill>
+              </a:rPr>
+              <a:t>Programmer codes while the mechanical teammate waits; often one programmer does it all and kludges around mechanical problems. One new autonomous state: 10–20 minutes of boilerplate</a:t>
+            </a:r>
+            <a:endParaRPr lang="en-US" sz="1150" dirty="0"/>
           </a:p>
         </p:txBody>
       </p:sp>
@@ -16427,14 +16427,14 @@
               <a:buNone/>
             </a:pPr>
             <a:r>
-              <a:rPr lang="en-US" sz="1300" dirty="0">
+              <a:rPr lang="en-US" sz="1150" dirty="0">
                 <a:solidFill>
                   <a:schemeClr val="tx1"/>
                 </a:solidFill>
               </a:rPr>
               <a:t>Firewheel transfer servos came out Sep 18 (reported 7:50 PM); code reworked that night by describing the new design</a:t>
             </a:r>
-            <a:endParaRPr lang="en-US" sz="1300" dirty="0"/>
+            <a:endParaRPr lang="en-US" sz="1150" dirty="0"/>
           </a:p>
         </p:txBody>
       </p:sp>
@@ -16517,14 +16517,14 @@
               <a:buNone/>
             </a:pPr>
             <a:r>
-              <a:rPr lang="en-US" sz="1300" i="1" dirty="0">
-                <a:solidFill>
-                  <a:schemeClr val="tx2"/>
-                </a:solidFill>
-              </a:rPr>
-              <a:t>[THE HIVE: what we understood about our code]</a:t>
-            </a:r>
-            <a:endParaRPr lang="en-US" sz="1300" dirty="0"/>
+              <a:rPr lang="en-US" sz="1150" dirty="0">
+                <a:solidFill>
+                  <a:schemeClr val="tx1"/>
+                </a:solidFill>
+              </a:rPr>
+              <a:t>Each of us understood our own file. Nobody could summarize the other's</a:t>
+            </a:r>
+            <a:endParaRPr lang="en-US" sz="1150" dirty="0"/>
           </a:p>
         </p:txBody>
       </p:sp>
@@ -16553,14 +16553,14 @@
               <a:buNone/>
             </a:pPr>
             <a:r>
-              <a:rPr lang="en-US" sz="1300" dirty="0">
+              <a:rPr lang="en-US" sz="1150" dirty="0">
                 <a:solidFill>
                   <a:schemeClr val="tx1"/>
                 </a:solidFill>
               </a:rPr>
               <a:t>Someone still has to read what Gemini wrote — the Reader role</a:t>
             </a:r>
-            <a:endParaRPr lang="en-US" sz="1300" dirty="0"/>
+            <a:endParaRPr lang="en-US" sz="1150" dirty="0"/>
           </a:p>
         </p:txBody>
       </p:sp>

</xml_diff>

<commit_message>
Two-wheel autonomous: the robot crawled first, then the code
Co-Authored-By: Claude Fable 5.1 <noreply@anthropic.com>
Claude-Session: https://claude.ai/code/session_01RMpvKd2BDz6WMMLBDDy1nT
</commit_message>
<xml_diff>
--- a/slides/kickoff.pptx
+++ b/slides/kickoff.pptx
@@ -2282,7 +2282,7 @@
           <a:p>
             <a:r>
               <a:rPr lang="en-US" dirty="0"/>
-              <a:t>This is the slide that's ours, and the left column is our real week. Four days of coding, three of us who could code the robot, and we were siloed: Tom wrote TeleOp, Sophi wrote autonomous. The bug: an autonomous borrowed from the FtcRobotController samples only powered two wheels, and Tom found it the morning of the competition, reading Sophi's code without knowing what she had done. Say the thing we'd do differently: AI could have given Tom a summary of the autonomous and he could have questioned it to find the bug. The grunt work: adding one state to the autonomous meant copying the same surrounding code again — 10 to 20 minutes for a new programmer, every time. Our process: the programmer works while a mechanical teammate waits, then sets up the robot and both watch the test; mechanical problems get fixed if quick or go on the to-do list; often it's one programmer doing all of it and kludging around mechanical problems in code. The honest comparison is not 'AI was faster': it's where the bottleneck was. On our robot every change went through whoever could type Java. On the mentor robot the bottleneck moved to describing precisely — and that's a skill the mechanical people already had. The right column is from the mentor transcript: the Sep 17 session was 25 minutes and 5 prompts, then the 18th and the 19th.</a:t>
+              <a:t>This is the slide that's ours, and the left column is our real week. Four days of coding, three of us who could code the robot, and we were siloed: Tom wrote TeleOp, Sophi wrote autonomous. The bug: an autonomous borrowed from the FtcRobotController samples only powered two wheels, and the other two were set to brake at zero power — so the robot crawled. Tom saw it in testing the morning of the competition, then had to read Sophi's code cold, without knowing what she had done, to find why. Say the thing we'd do differently: AI could have given Tom a summary of the autonomous and he could have questioned it to find the bug. The grunt work: adding one state to the autonomous meant copying the same surrounding code again — 10 to 20 minutes for a new programmer, every time. Our process: the programmer works while a mechanical teammate waits, then sets up the robot and both watch the test; mechanical problems get fixed if quick or go on the to-do list; often it's one programmer doing all of it and kludging around mechanical problems in code. The honest comparison is not 'AI was faster': it's where the bottleneck was. On our robot every change went through whoever could type Java. On the mentor robot the bottleneck moved to describing precisely — and that's a skill the mechanical people already had. The right column is from the mentor transcript: the Sep 17 session was 25 minutes and 5 prompts, then the 18th and the 19th.</a:t>
             </a:r>
             <a:endParaRPr lang="en-US" dirty="0"/>
           </a:p>
@@ -16270,7 +16270,7 @@
                   <a:schemeClr val="tx1"/>
                 </a:solidFill>
               </a:rPr>
-              <a:t>A borrowed sample autonomous only powered two wheels. Tom found it the morning of the competition, reading Sophi's code cold</a:t>
+              <a:t>A borrowed sample autonomous only powered two wheels — the other two were braking. Tom saw the robot crawl in morning testing, then had to read Sophi's code cold to find why</a:t>
             </a:r>
             <a:endParaRPr lang="en-US" sz="1150" dirty="0"/>
           </a:p>

</xml_diff>

<commit_message>
Credits: name the students in the heading
Co-Authored-By: Claude Fable 5.1 <noreply@anthropic.com>
Claude-Session: https://claude.ai/code/session_01RMpvKd2BDz6WMMLBDDy1nT
</commit_message>
<xml_diff>
--- a/slides/kickoff.pptx
+++ b/slides/kickoff.pptx
@@ -12276,7 +12276,7 @@
                   <a:schemeClr val="accent1"/>
                 </a:solidFill>
               </a:rPr>
-              <a:t>The Hive's students</a:t>
+              <a:t>Tom, Sophi and Sadiqah — The Hive's programmers</a:t>
             </a:r>
             <a:endParaRPr lang="en-US" sz="1700" dirty="0"/>
           </a:p>
@@ -12312,7 +12312,7 @@
                   <a:schemeClr val="tx2"/>
                 </a:solidFill>
               </a:rPr>
-              <a:t>Hand-coded the team's own robot this season. Tom, Sophi and Sadiqah present this workshop and narrate the videos.</a:t>
+              <a:t>Hand-coded the team's own robot this season. Present this workshop and narrate the videos.</a:t>
             </a:r>
             <a:endParaRPr lang="en-US" sz="1300" dirty="0"/>
           </a:p>

</xml_diff>

<commit_message>
Credits: Claude's line shortened to compilation
Co-Authored-By: Claude Fable 5.1 <noreply@anthropic.com>
Claude-Session: https://claude.ai/code/session_01RMpvKd2BDz6WMMLBDDy1nT
</commit_message>
<xml_diff>
--- a/slides/kickoff.pptx
+++ b/slides/kickoff.pptx
@@ -12664,7 +12664,7 @@
                   <a:schemeClr val="tx2"/>
                 </a:solidFill>
               </a:rPr>
-              <a:t>Drafted the guide, deck, scripts and research from the real transcript; every claim refuter-checked against sources.</a:t>
+              <a:t>Compiled the transcript, guide and slides from the team's material.</a:t>
             </a:r>
             <a:endParaRPr lang="en-US" sz="1300" dirty="0"/>
           </a:p>
@@ -12772,7 +12772,7 @@
                   <a:schemeClr val="accent1"/>
                 </a:solidFill>
               </a:rPr>
-              <a:t>This workshop was made the way it teaches: described, generated, tested, refined — with the prompts kept.</a:t>
+              <a:t>Made the way it teaches: described by the team, generated, tested, refined.</a:t>
             </a:r>
             <a:endParaRPr lang="en-US" sz="1500" dirty="0"/>
           </a:p>

</xml_diff>

<commit_message>
Two Sources slides, linked; PDFs rebuilt
Co-Authored-By: Claude Fable 5.1 <noreply@anthropic.com>
Claude-Session: https://claude.ai/code/session_01RMpvKd2BDz6WMMLBDDy1nT
</commit_message>
<xml_diff>
--- a/slides/kickoff.pptx
+++ b/slides/kickoff.pptx
@@ -27,9 +27,11 @@
     <p:sldId id="275" r:id="rId21"/>
     <p:sldId id="276" r:id="rId22"/>
     <p:sldId id="277" r:id="rId23"/>
+    <p:sldId id="278" r:id="rId24"/>
+    <p:sldId id="279" r:id="rId25"/>
   </p:sldIdLst>
   <p:notesMasterIdLst>
-    <p:notesMasterId r:id="rId24"/>
+    <p:notesMasterId r:id="rId26"/>
   </p:notesMasterIdLst>
   <p:sldSz cx="12192000" cy="6858000"/>
   <p:notesSz cx="6858000" cy="12192000"/>
@@ -1779,6 +1781,182 @@
             <a:fld id="{F7021451-1387-4CA6-816F-3879F97B5CBC}" type="slidenum">
               <a:rPr lang="en-US"/>
               <a:t>22</a:t>
+            </a:fld>
+            <a:endParaRPr lang="en-US"/>
+          </a:p>
+        </p:txBody>
+      </p:sp>
+    </p:spTree>
+    <p:extLst>
+      <p:ext uri="{BB962C8B-B14F-4D97-AF65-F5344CB8AC3E}">
+        <p14:creationId xmlns:p14="http://schemas.microsoft.com/office/powerpoint/2010/main" val="1024086991"/>
+      </p:ext>
+    </p:extLst>
+  </p:cSld>
+  <p:clrMapOvr>
+    <a:masterClrMapping/>
+  </p:clrMapOvr>
+</p:notes>
+</file>
+
+<file path=ppt/notesSlides/notesSlide23.xml><?xml version="1.0" encoding="utf-8"?>
+<p:notes xmlns:a="http://schemas.openxmlformats.org/drawingml/2006/main" xmlns:r="http://schemas.openxmlformats.org/officeDocument/2006/relationships" xmlns:p="http://schemas.openxmlformats.org/presentationml/2006/main">
+  <p:cSld>
+    <p:spTree>
+      <p:nvGrpSpPr>
+        <p:cNvPr id="1" name=""/>
+        <p:cNvGrpSpPr/>
+        <p:nvPr/>
+      </p:nvGrpSpPr>
+      <p:grpSpPr>
+        <a:xfrm>
+          <a:off x="0" y="0"/>
+          <a:ext cx="0" cy="0"/>
+          <a:chOff x="0" y="0"/>
+          <a:chExt cx="0" cy="0"/>
+        </a:xfrm>
+      </p:grpSpPr>
+      <p:sp>
+        <p:nvSpPr>
+          <p:cNvPr id="2" name="Slide Image Placeholder 1"/>
+          <p:cNvSpPr>
+            <a:spLocks noGrp="1" noRot="1" noChangeAspect="1"/>
+          </p:cNvSpPr>
+          <p:nvPr>
+            <p:ph type="sldImg"/>
+          </p:nvPr>
+        </p:nvSpPr>
+        <p:spPr/>
+      </p:sp>
+      <p:sp>
+        <p:nvSpPr>
+          <p:cNvPr id="3" name="Notes Placeholder 2"/>
+          <p:cNvSpPr>
+            <a:spLocks noGrp="1"/>
+          </p:cNvSpPr>
+          <p:nvPr>
+            <p:ph type="body" idx="1"/>
+          </p:nvPr>
+        </p:nvSpPr>
+        <p:spPr/>
+        <p:txBody>
+          <a:bodyPr/>
+          <a:lstStyle/>
+          <a:p>
+            <a:r>
+              <a:rPr lang="en-US" dirty="0"/>
+              <a:t>Slides 5–7. Every title is a live link in the PDF and the .pptx. The caveats on each item are in docs/research-ai-skills-case.md; the 'must not repeat' table there is the one to read before you present.</a:t>
+            </a:r>
+            <a:endParaRPr lang="en-US" dirty="0"/>
+          </a:p>
+        </p:txBody>
+      </p:sp>
+      <p:sp>
+        <p:nvSpPr>
+          <p:cNvPr id="4" name="Slide Number Placeholder 3"/>
+          <p:cNvSpPr>
+            <a:spLocks noGrp="1"/>
+          </p:cNvSpPr>
+          <p:nvPr>
+            <p:ph type="sldNum" sz="quarter" idx="10"/>
+          </p:nvPr>
+        </p:nvSpPr>
+        <p:spPr/>
+        <p:txBody>
+          <a:bodyPr/>
+          <a:lstStyle/>
+          <a:p>
+            <a:fld id="{F7021451-1387-4CA6-816F-3879F97B5CBC}" type="slidenum">
+              <a:rPr lang="en-US"/>
+              <a:t>23</a:t>
+            </a:fld>
+            <a:endParaRPr lang="en-US"/>
+          </a:p>
+        </p:txBody>
+      </p:sp>
+    </p:spTree>
+    <p:extLst>
+      <p:ext uri="{BB962C8B-B14F-4D97-AF65-F5344CB8AC3E}">
+        <p14:creationId xmlns:p14="http://schemas.microsoft.com/office/powerpoint/2010/main" val="1024086991"/>
+      </p:ext>
+    </p:extLst>
+  </p:cSld>
+  <p:clrMapOvr>
+    <a:masterClrMapping/>
+  </p:clrMapOvr>
+</p:notes>
+</file>
+
+<file path=ppt/notesSlides/notesSlide24.xml><?xml version="1.0" encoding="utf-8"?>
+<p:notes xmlns:a="http://schemas.openxmlformats.org/drawingml/2006/main" xmlns:r="http://schemas.openxmlformats.org/officeDocument/2006/relationships" xmlns:p="http://schemas.openxmlformats.org/presentationml/2006/main">
+  <p:cSld>
+    <p:spTree>
+      <p:nvGrpSpPr>
+        <p:cNvPr id="1" name=""/>
+        <p:cNvGrpSpPr/>
+        <p:nvPr/>
+      </p:nvGrpSpPr>
+      <p:grpSpPr>
+        <a:xfrm>
+          <a:off x="0" y="0"/>
+          <a:ext cx="0" cy="0"/>
+          <a:chOff x="0" y="0"/>
+          <a:chExt cx="0" cy="0"/>
+        </a:xfrm>
+      </p:grpSpPr>
+      <p:sp>
+        <p:nvSpPr>
+          <p:cNvPr id="2" name="Slide Image Placeholder 1"/>
+          <p:cNvSpPr>
+            <a:spLocks noGrp="1" noRot="1" noChangeAspect="1"/>
+          </p:cNvSpPr>
+          <p:nvPr>
+            <p:ph type="sldImg"/>
+          </p:nvPr>
+        </p:nvSpPr>
+        <p:spPr/>
+      </p:sp>
+      <p:sp>
+        <p:nvSpPr>
+          <p:cNvPr id="3" name="Notes Placeholder 2"/>
+          <p:cNvSpPr>
+            <a:spLocks noGrp="1"/>
+          </p:cNvSpPr>
+          <p:nvPr>
+            <p:ph type="body" idx="1"/>
+          </p:nvPr>
+        </p:nvSpPr>
+        <p:spPr/>
+        <p:txBody>
+          <a:bodyPr/>
+          <a:lstStyle/>
+          <a:p>
+            <a:r>
+              <a:rPr lang="en-US" dirty="0"/>
+              <a:t>Slides 15–16 and the team's own records. Job postings expire: re-open the Podium links the morning of the talk. PwC and Lightcast sell AI-related services; their wage figures are advertised-pay correlations, not controlled comparisons.</a:t>
+            </a:r>
+            <a:endParaRPr lang="en-US" dirty="0"/>
+          </a:p>
+        </p:txBody>
+      </p:sp>
+      <p:sp>
+        <p:nvSpPr>
+          <p:cNvPr id="4" name="Slide Number Placeholder 3"/>
+          <p:cNvSpPr>
+            <a:spLocks noGrp="1"/>
+          </p:cNvSpPr>
+          <p:nvPr>
+            <p:ph type="sldNum" sz="quarter" idx="10"/>
+          </p:nvPr>
+        </p:nvSpPr>
+        <p:spPr/>
+        <p:txBody>
+          <a:bodyPr/>
+          <a:lstStyle/>
+          <a:p>
+            <a:fld id="{F7021451-1387-4CA6-816F-3879F97B5CBC}" type="slidenum">
+              <a:rPr lang="en-US"/>
+              <a:t>24</a:t>
             </a:fld>
             <a:endParaRPr lang="en-US"/>
           </a:p>
@@ -13030,6 +13208,1818 @@
 </p:sld>
 </file>
 
+<file path=ppt/slides/slide23.xml><?xml version="1.0" encoding="utf-8"?>
+<p:sld xmlns:a="http://schemas.openxmlformats.org/drawingml/2006/main" xmlns:r="http://schemas.openxmlformats.org/officeDocument/2006/relationships" xmlns:p="http://schemas.openxmlformats.org/presentationml/2006/main">
+  <p:cSld name="Slide 23">
+    <p:spTree>
+      <p:nvGrpSpPr>
+        <p:cNvPr id="1" name=""/>
+        <p:cNvGrpSpPr/>
+        <p:nvPr/>
+      </p:nvGrpSpPr>
+      <p:grpSpPr>
+        <a:xfrm>
+          <a:off x="0" y="0"/>
+          <a:ext cx="0" cy="0"/>
+          <a:chOff x="0" y="0"/>
+          <a:chExt cx="0" cy="0"/>
+        </a:xfrm>
+      </p:grpSpPr>
+      <p:sp>
+        <p:nvSpPr>
+          <p:cNvPr id="2" name="Text 1"/>
+          <p:cNvSpPr/>
+          <p:nvPr>
+            <p:ph idx="102" type="title" hasCustomPrompt="1"/>
+          </p:nvPr>
+        </p:nvSpPr>
+        <p:spPr>
+          <a:xfrm>
+            <a:off x="457200" y="365760"/>
+            <a:ext cx="11274552" cy="822960"/>
+          </a:xfrm>
+          <a:prstGeom prst="rect">
+            <a:avLst/>
+          </a:prstGeom>
+          <a:noFill/>
+          <a:ln/>
+        </p:spPr>
+        <p:txBody>
+          <a:bodyPr wrap="square" lIns="0" tIns="0" rIns="0" bIns="0" rtlCol="0" anchor="ctr"/>
+          <a:lstStyle/>
+          <a:p>
+            <a:pPr algn="l" indent="0" marL="0">
+              <a:buNone/>
+            </a:pPr>
+            <a:r>
+              <a:rPr lang="en-US" sz="3200" b="1" dirty="0">
+                <a:solidFill>
+                  <a:schemeClr val="accent1"/>
+                </a:solidFill>
+              </a:rPr>
+              <a:t>Sources — studies, rules, history</a:t>
+            </a:r>
+            <a:endParaRPr lang="en-US" sz="3200" dirty="0"/>
+          </a:p>
+        </p:txBody>
+      </p:sp>
+      <p:sp>
+        <p:nvSpPr>
+          <p:cNvPr id="4" name="source 0"/>
+          <p:cNvSpPr txBox="1"/>
+          <p:nvPr/>
+        </p:nvSpPr>
+        <p:spPr>
+          <a:xfrm>
+            <a:off x="457200" y="1280160"/>
+            <a:ext cx="5486400" cy="548640"/>
+          </a:xfrm>
+          <a:prstGeom prst="rect">
+            <a:avLst/>
+          </a:prstGeom>
+          <a:noFill/>
+          <a:ln/>
+        </p:spPr>
+        <p:txBody>
+          <a:bodyPr wrap="square" lIns="0" tIns="0" rIns="0" bIns="0" rtlCol="0" anchor="t"/>
+          <a:lstStyle/>
+          <a:p>
+            <a:pPr indent="0" marL="0">
+              <a:buNone/>
+            </a:pPr>
+            <a:r>
+              <a:rPr lang="en-US" sz="1100" b="1" u="sng" dirty="0">
+                <a:solidFill>
+                  <a:schemeClr val="accent1"/>
+                </a:solidFill>
+                <a:hlinkClick r:id="rId1" invalidUrl="" action="" tgtFrame="" tooltip="" history="1" highlightClick="0" endSnd="0">
+                  <a:extLst>
+                    <a:ext uri="{A12FA001-AC4F-418D-AE19-62706E023703}">
+                      <ahyp:hlinkClr xmlns:ahyp="http://schemas.microsoft.com/office/drawing/2018/hyperlinkcolor" val="tx"/>
+                    </a:ext>
+                  </a:extLst>
+                </a:hlinkClick>
+              </a:rPr>
+              <a:t>Bastani et al., PNAS 2025</a:t>
+            </a:r>
+            <a:endParaRPr lang="en-US" sz="1100" dirty="0"/>
+          </a:p>
+          <a:p>
+            <a:pPr indent="0" marL="0">
+              <a:buNone/>
+            </a:pPr>
+            <a:r>
+              <a:rPr lang="en-US" sz="1100" dirty="0">
+                <a:solidFill>
+                  <a:schemeClr val="tx2"/>
+                </a:solidFill>
+              </a:rPr>
+              <a:t>Generative AI can harm learning — ~1,000 HS students  ·  scale.stanford.edu/publications/generative-ai-can-harm-learning</a:t>
+            </a:r>
+            <a:endParaRPr lang="en-US" sz="1100" dirty="0"/>
+          </a:p>
+        </p:txBody>
+      </p:sp>
+      <p:sp>
+        <p:nvSpPr>
+          <p:cNvPr id="5" name="source 1"/>
+          <p:cNvSpPr txBox="1"/>
+          <p:nvPr/>
+        </p:nvSpPr>
+        <p:spPr>
+          <a:xfrm>
+            <a:off x="457200" y="1883664"/>
+            <a:ext cx="5486400" cy="548640"/>
+          </a:xfrm>
+          <a:prstGeom prst="rect">
+            <a:avLst/>
+          </a:prstGeom>
+          <a:noFill/>
+          <a:ln/>
+        </p:spPr>
+        <p:txBody>
+          <a:bodyPr wrap="square" lIns="0" tIns="0" rIns="0" bIns="0" rtlCol="0" anchor="t"/>
+          <a:lstStyle/>
+          <a:p>
+            <a:pPr indent="0" marL="0">
+              <a:buNone/>
+            </a:pPr>
+            <a:r>
+              <a:rPr lang="en-US" sz="1100" b="1" u="sng" dirty="0">
+                <a:solidFill>
+                  <a:schemeClr val="accent1"/>
+                </a:solidFill>
+                <a:hlinkClick r:id="rId2" invalidUrl="" action="" tgtFrame="" tooltip="" history="1" highlightClick="0" endSnd="0">
+                  <a:extLst>
+                    <a:ext uri="{A12FA001-AC4F-418D-AE19-62706E023703}">
+                      <ahyp:hlinkClr xmlns:ahyp="http://schemas.microsoft.com/office/drawing/2018/hyperlinkcolor" val="tx"/>
+                    </a:ext>
+                  </a:extLst>
+                </a:hlinkClick>
+              </a:rPr>
+              <a:t>Becker et al., METR, Jul 2025</a:t>
+            </a:r>
+            <a:endParaRPr lang="en-US" sz="1100" dirty="0"/>
+          </a:p>
+          <a:p>
+            <a:pPr indent="0" marL="0">
+              <a:buNone/>
+            </a:pPr>
+            <a:r>
+              <a:rPr lang="en-US" sz="1100" dirty="0">
+                <a:solidFill>
+                  <a:schemeClr val="tx2"/>
+                </a:solidFill>
+              </a:rPr>
+              <a:t>16 expert developers 19% slower with AI  ·  arxiv.org/abs/2507.09089</a:t>
+            </a:r>
+            <a:endParaRPr lang="en-US" sz="1100" dirty="0"/>
+          </a:p>
+        </p:txBody>
+      </p:sp>
+      <p:sp>
+        <p:nvSpPr>
+          <p:cNvPr id="6" name="source 2"/>
+          <p:cNvSpPr txBox="1"/>
+          <p:nvPr/>
+        </p:nvSpPr>
+        <p:spPr>
+          <a:xfrm>
+            <a:off x="457200" y="2487168"/>
+            <a:ext cx="5486400" cy="548640"/>
+          </a:xfrm>
+          <a:prstGeom prst="rect">
+            <a:avLst/>
+          </a:prstGeom>
+          <a:noFill/>
+          <a:ln/>
+        </p:spPr>
+        <p:txBody>
+          <a:bodyPr wrap="square" lIns="0" tIns="0" rIns="0" bIns="0" rtlCol="0" anchor="t"/>
+          <a:lstStyle/>
+          <a:p>
+            <a:pPr indent="0" marL="0">
+              <a:buNone/>
+            </a:pPr>
+            <a:r>
+              <a:rPr lang="en-US" sz="1100" b="1" u="sng" dirty="0">
+                <a:solidFill>
+                  <a:schemeClr val="accent1"/>
+                </a:solidFill>
+                <a:hlinkClick r:id="rId3" invalidUrl="" action="" tgtFrame="" tooltip="" history="1" highlightClick="0" endSnd="0">
+                  <a:extLst>
+                    <a:ext uri="{A12FA001-AC4F-418D-AE19-62706E023703}">
+                      <ahyp:hlinkClr xmlns:ahyp="http://schemas.microsoft.com/office/drawing/2018/hyperlinkcolor" val="tx"/>
+                    </a:ext>
+                  </a:extLst>
+                </a:hlinkClick>
+              </a:rPr>
+              <a:t>Anthropic, Jan 2026</a:t>
+            </a:r>
+            <a:endParaRPr lang="en-US" sz="1100" dirty="0"/>
+          </a:p>
+          <a:p>
+            <a:pPr indent="0" marL="0">
+              <a:buNone/>
+            </a:pPr>
+            <a:r>
+              <a:rPr lang="en-US" sz="1100" dirty="0">
+                <a:solidFill>
+                  <a:schemeClr val="tx2"/>
+                </a:solidFill>
+              </a:rPr>
+              <a:t>AI assistance and coding skill formation (vendor study)  ·  anthropic.com/news/AI-assistance-coding-skills</a:t>
+            </a:r>
+            <a:endParaRPr lang="en-US" sz="1100" dirty="0"/>
+          </a:p>
+        </p:txBody>
+      </p:sp>
+      <p:sp>
+        <p:nvSpPr>
+          <p:cNvPr id="7" name="source 3"/>
+          <p:cNvSpPr txBox="1"/>
+          <p:nvPr/>
+        </p:nvSpPr>
+        <p:spPr>
+          <a:xfrm>
+            <a:off x="457200" y="3090672"/>
+            <a:ext cx="5486400" cy="548640"/>
+          </a:xfrm>
+          <a:prstGeom prst="rect">
+            <a:avLst/>
+          </a:prstGeom>
+          <a:noFill/>
+          <a:ln/>
+        </p:spPr>
+        <p:txBody>
+          <a:bodyPr wrap="square" lIns="0" tIns="0" rIns="0" bIns="0" rtlCol="0" anchor="t"/>
+          <a:lstStyle/>
+          <a:p>
+            <a:pPr indent="0" marL="0">
+              <a:buNone/>
+            </a:pPr>
+            <a:r>
+              <a:rPr lang="en-US" sz="1100" b="1" u="sng" dirty="0">
+                <a:solidFill>
+                  <a:schemeClr val="accent1"/>
+                </a:solidFill>
+                <a:hlinkClick r:id="rId4" invalidUrl="" action="" tgtFrame="" tooltip="" history="1" highlightClick="0" endSnd="0">
+                  <a:extLst>
+                    <a:ext uri="{A12FA001-AC4F-418D-AE19-62706E023703}">
+                      <ahyp:hlinkClr xmlns:ahyp="http://schemas.microsoft.com/office/drawing/2018/hyperlinkcolor" val="tx"/>
+                    </a:ext>
+                  </a:extLst>
+                </a:hlinkClick>
+              </a:rPr>
+              <a:t>College Board, AP CS Principles</a:t>
+            </a:r>
+            <a:endParaRPr lang="en-US" sz="1100" dirty="0"/>
+          </a:p>
+          <a:p>
+            <a:pPr indent="0" marL="0">
+              <a:buNone/>
+            </a:pPr>
+            <a:r>
+              <a:rPr lang="en-US" sz="1100" dirty="0">
+                <a:solidFill>
+                  <a:schemeClr val="tx2"/>
+                </a:solidFill>
+              </a:rPr>
+              <a:t>Create task directions — AI use and attribution  ·  apcentral.collegeboard.org/media/pdf/ap-csp-student-task-directions.pd</a:t>
+            </a:r>
+            <a:endParaRPr lang="en-US" sz="1100" dirty="0"/>
+          </a:p>
+        </p:txBody>
+      </p:sp>
+      <p:sp>
+        <p:nvSpPr>
+          <p:cNvPr id="8" name="source 4"/>
+          <p:cNvSpPr txBox="1"/>
+          <p:nvPr/>
+        </p:nvSpPr>
+        <p:spPr>
+          <a:xfrm>
+            <a:off x="457200" y="3694176"/>
+            <a:ext cx="5486400" cy="548640"/>
+          </a:xfrm>
+          <a:prstGeom prst="rect">
+            <a:avLst/>
+          </a:prstGeom>
+          <a:noFill/>
+          <a:ln/>
+        </p:spPr>
+        <p:txBody>
+          <a:bodyPr wrap="square" lIns="0" tIns="0" rIns="0" bIns="0" rtlCol="0" anchor="t"/>
+          <a:lstStyle/>
+          <a:p>
+            <a:pPr indent="0" marL="0">
+              <a:buNone/>
+            </a:pPr>
+            <a:r>
+              <a:rPr lang="en-US" sz="1100" b="1" u="sng" dirty="0">
+                <a:solidFill>
+                  <a:schemeClr val="accent1"/>
+                </a:solidFill>
+                <a:hlinkClick r:id="rId5" invalidUrl="" action="" tgtFrame="" tooltip="" history="1" highlightClick="0" endSnd="0">
+                  <a:extLst>
+                    <a:ext uri="{A12FA001-AC4F-418D-AE19-62706E023703}">
+                      <ahyp:hlinkClr xmlns:ahyp="http://schemas.microsoft.com/office/drawing/2018/hyperlinkcolor" val="tx"/>
+                    </a:ext>
+                  </a:extLst>
+                </a:hlinkClick>
+              </a:rPr>
+              <a:t>FTC Competition Manual 2026–27</a:t>
+            </a:r>
+            <a:endParaRPr lang="en-US" sz="1100" dirty="0"/>
+          </a:p>
+          <a:p>
+            <a:pPr indent="0" marL="0">
+              <a:buNone/>
+            </a:pPr>
+            <a:r>
+              <a:rPr lang="en-US" sz="1100" dirty="0">
+                <a:solidFill>
+                  <a:schemeClr val="tx2"/>
+                </a:solidFill>
+              </a:rPr>
+              <a:t>Awards section: A201, A204, A208  ·  ftc-resources.firstinspires.org/ftc/game/manual-06</a:t>
+            </a:r>
+            <a:endParaRPr lang="en-US" sz="1100" dirty="0"/>
+          </a:p>
+        </p:txBody>
+      </p:sp>
+      <p:sp>
+        <p:nvSpPr>
+          <p:cNvPr id="9" name="source 5"/>
+          <p:cNvSpPr txBox="1"/>
+          <p:nvPr/>
+        </p:nvSpPr>
+        <p:spPr>
+          <a:xfrm>
+            <a:off x="457200" y="4297680"/>
+            <a:ext cx="5486400" cy="548640"/>
+          </a:xfrm>
+          <a:prstGeom prst="rect">
+            <a:avLst/>
+          </a:prstGeom>
+          <a:noFill/>
+          <a:ln/>
+        </p:spPr>
+        <p:txBody>
+          <a:bodyPr wrap="square" lIns="0" tIns="0" rIns="0" bIns="0" rtlCol="0" anchor="t"/>
+          <a:lstStyle/>
+          <a:p>
+            <a:pPr indent="0" marL="0">
+              <a:buNone/>
+            </a:pPr>
+            <a:r>
+              <a:rPr lang="en-US" sz="1100" b="1" u="sng" dirty="0">
+                <a:solidFill>
+                  <a:schemeClr val="accent1"/>
+                </a:solidFill>
+                <a:hlinkClick r:id="rId6" invalidUrl="" action="" tgtFrame="" tooltip="" history="1" highlightClick="0" endSnd="0">
+                  <a:extLst>
+                    <a:ext uri="{A12FA001-AC4F-418D-AE19-62706E023703}">
+                      <ahyp:hlinkClr xmlns:ahyp="http://schemas.microsoft.com/office/drawing/2018/hyperlinkcolor" val="tx"/>
+                    </a:ext>
+                  </a:extLst>
+                </a:hlinkClick>
+              </a:rPr>
+              <a:t>FIRST blog: Expanding the toolbox with AI</a:t>
+            </a:r>
+            <a:endParaRPr lang="en-US" sz="1100" dirty="0"/>
+          </a:p>
+          <a:p>
+            <a:pPr indent="0" marL="0">
+              <a:buNone/>
+            </a:pPr>
+            <a:r>
+              <a:rPr lang="en-US" sz="1100" dirty="0">
+                <a:solidFill>
+                  <a:schemeClr val="tx2"/>
+                </a:solidFill>
+              </a:rPr>
+              <a:t>“The answer is yes!” — credit convention  ·  community.firstinspires.org/expanding-the-first-toolbox-with-artificia</a:t>
+            </a:r>
+            <a:endParaRPr lang="en-US" sz="1100" dirty="0"/>
+          </a:p>
+        </p:txBody>
+      </p:sp>
+      <p:sp>
+        <p:nvSpPr>
+          <p:cNvPr id="10" name="source 6"/>
+          <p:cNvSpPr txBox="1"/>
+          <p:nvPr/>
+        </p:nvSpPr>
+        <p:spPr>
+          <a:xfrm>
+            <a:off x="457200" y="4901184"/>
+            <a:ext cx="5486400" cy="548640"/>
+          </a:xfrm>
+          <a:prstGeom prst="rect">
+            <a:avLst/>
+          </a:prstGeom>
+          <a:noFill/>
+          <a:ln/>
+        </p:spPr>
+        <p:txBody>
+          <a:bodyPr wrap="square" lIns="0" tIns="0" rIns="0" bIns="0" rtlCol="0" anchor="t"/>
+          <a:lstStyle/>
+          <a:p>
+            <a:pPr indent="0" marL="0">
+              <a:buNone/>
+            </a:pPr>
+            <a:r>
+              <a:rPr lang="en-US" sz="1100" b="1" u="sng" dirty="0">
+                <a:solidFill>
+                  <a:schemeClr val="accent1"/>
+                </a:solidFill>
+                <a:hlinkClick r:id="rId7" invalidUrl="" action="" tgtFrame="" tooltip="" history="1" highlightClick="0" endSnd="0">
+                  <a:extLst>
+                    <a:ext uri="{A12FA001-AC4F-418D-AE19-62706E023703}">
+                      <ahyp:hlinkClr xmlns:ahyp="http://schemas.microsoft.com/office/drawing/2018/hyperlinkcolor" val="tx"/>
+                    </a:ext>
+                  </a:extLst>
+                </a:hlinkClick>
+              </a:rPr>
+              <a:t>Learn Java for FTC (Alan Smith)</a:t>
+            </a:r>
+            <a:endParaRPr lang="en-US" sz="1100" dirty="0"/>
+          </a:p>
+          <a:p>
+            <a:pPr indent="0" marL="0">
+              <a:buNone/>
+            </a:pPr>
+            <a:r>
+              <a:rPr lang="en-US" sz="1100" dirty="0">
+                <a:solidFill>
+                  <a:schemeClr val="tx2"/>
+                </a:solidFill>
+              </a:rPr>
+              <a:t>The textbook in The Hive's checklist  ·  raw.githubusercontent.com/alan412/LearnJavaForFTC/master/LearnJavaForF</a:t>
+            </a:r>
+            <a:endParaRPr lang="en-US" sz="1100" dirty="0"/>
+          </a:p>
+        </p:txBody>
+      </p:sp>
+      <p:sp>
+        <p:nvSpPr>
+          <p:cNvPr id="11" name="source 7"/>
+          <p:cNvSpPr txBox="1"/>
+          <p:nvPr/>
+        </p:nvSpPr>
+        <p:spPr>
+          <a:xfrm>
+            <a:off x="6217920" y="1280160"/>
+            <a:ext cx="5486400" cy="548640"/>
+          </a:xfrm>
+          <a:prstGeom prst="rect">
+            <a:avLst/>
+          </a:prstGeom>
+          <a:noFill/>
+          <a:ln/>
+        </p:spPr>
+        <p:txBody>
+          <a:bodyPr wrap="square" lIns="0" tIns="0" rIns="0" bIns="0" rtlCol="0" anchor="t"/>
+          <a:lstStyle/>
+          <a:p>
+            <a:pPr indent="0" marL="0">
+              <a:buNone/>
+            </a:pPr>
+            <a:r>
+              <a:rPr lang="en-US" sz="1100" b="1" u="sng" dirty="0">
+                <a:solidFill>
+                  <a:schemeClr val="accent1"/>
+                </a:solidFill>
+                <a:hlinkClick r:id="rId8" invalidUrl="" action="" tgtFrame="" tooltip="" history="1" highlightClick="0" endSnd="0">
+                  <a:extLst>
+                    <a:ext uri="{A12FA001-AC4F-418D-AE19-62706E023703}">
+                      <ahyp:hlinkClr xmlns:ahyp="http://schemas.microsoft.com/office/drawing/2018/hyperlinkcolor" val="tx"/>
+                    </a:ext>
+                  </a:extLst>
+                </a:hlinkClick>
+              </a:rPr>
+              <a:t>Backus, 1978</a:t>
+            </a:r>
+            <a:endParaRPr lang="en-US" sz="1100" dirty="0"/>
+          </a:p>
+          <a:p>
+            <a:pPr indent="0" marL="0">
+              <a:buNone/>
+            </a:pPr>
+            <a:r>
+              <a:rPr lang="en-US" sz="1100" dirty="0">
+                <a:solidFill>
+                  <a:schemeClr val="tx2"/>
+                </a:solidFill>
+              </a:rPr>
+              <a:t>The History of FORTRAN I, II, and III (HOPL)  ·  softwarepreservation.computerhistory.org/FORTRAN/paper/p165-backus.pdf</a:t>
+            </a:r>
+            <a:endParaRPr lang="en-US" sz="1100" dirty="0"/>
+          </a:p>
+        </p:txBody>
+      </p:sp>
+      <p:sp>
+        <p:nvSpPr>
+          <p:cNvPr id="12" name="source 8"/>
+          <p:cNvSpPr txBox="1"/>
+          <p:nvPr/>
+        </p:nvSpPr>
+        <p:spPr>
+          <a:xfrm>
+            <a:off x="6217920" y="1883664"/>
+            <a:ext cx="5486400" cy="548640"/>
+          </a:xfrm>
+          <a:prstGeom prst="rect">
+            <a:avLst/>
+          </a:prstGeom>
+          <a:noFill/>
+          <a:ln/>
+        </p:spPr>
+        <p:txBody>
+          <a:bodyPr wrap="square" lIns="0" tIns="0" rIns="0" bIns="0" rtlCol="0" anchor="t"/>
+          <a:lstStyle/>
+          <a:p>
+            <a:pPr indent="0" marL="0">
+              <a:buNone/>
+            </a:pPr>
+            <a:r>
+              <a:rPr lang="en-US" sz="1100" b="1" u="sng" dirty="0">
+                <a:solidFill>
+                  <a:schemeClr val="accent1"/>
+                </a:solidFill>
+                <a:hlinkClick r:id="rId9" invalidUrl="" action="" tgtFrame="" tooltip="" history="1" highlightClick="0" endSnd="0">
+                  <a:extLst>
+                    <a:ext uri="{A12FA001-AC4F-418D-AE19-62706E023703}">
+                      <ahyp:hlinkClr xmlns:ahyp="http://schemas.microsoft.com/office/drawing/2018/hyperlinkcolor" val="tx"/>
+                    </a:ext>
+                  </a:extLst>
+                </a:hlinkClick>
+              </a:rPr>
+              <a:t>Post, 1983</a:t>
+            </a:r>
+            <a:endParaRPr lang="en-US" sz="1100" dirty="0"/>
+          </a:p>
+          <a:p>
+            <a:pPr indent="0" marL="0">
+              <a:buNone/>
+            </a:pPr>
+            <a:r>
+              <a:rPr lang="en-US" sz="1100" dirty="0">
+                <a:solidFill>
+                  <a:schemeClr val="tx2"/>
+                </a:solidFill>
+              </a:rPr>
+              <a:t>Real Programmers Don't Use Pascal  ·  ee.torontomu.ca/~elf/hack/realmen.html</a:t>
+            </a:r>
+            <a:endParaRPr lang="en-US" sz="1100" dirty="0"/>
+          </a:p>
+        </p:txBody>
+      </p:sp>
+      <p:sp>
+        <p:nvSpPr>
+          <p:cNvPr id="13" name="source 9"/>
+          <p:cNvSpPr txBox="1"/>
+          <p:nvPr/>
+        </p:nvSpPr>
+        <p:spPr>
+          <a:xfrm>
+            <a:off x="6217920" y="2487168"/>
+            <a:ext cx="5486400" cy="548640"/>
+          </a:xfrm>
+          <a:prstGeom prst="rect">
+            <a:avLst/>
+          </a:prstGeom>
+          <a:noFill/>
+          <a:ln/>
+        </p:spPr>
+        <p:txBody>
+          <a:bodyPr wrap="square" lIns="0" tIns="0" rIns="0" bIns="0" rtlCol="0" anchor="t"/>
+          <a:lstStyle/>
+          <a:p>
+            <a:pPr indent="0" marL="0">
+              <a:buNone/>
+            </a:pPr>
+            <a:r>
+              <a:rPr lang="en-US" sz="1100" b="1" u="sng" dirty="0">
+                <a:solidFill>
+                  <a:schemeClr val="accent1"/>
+                </a:solidFill>
+                <a:hlinkClick r:id="rId10" invalidUrl="" action="" tgtFrame="" tooltip="" history="1" highlightClick="0" endSnd="0">
+                  <a:extLst>
+                    <a:ext uri="{A12FA001-AC4F-418D-AE19-62706E023703}">
+                      <ahyp:hlinkClr xmlns:ahyp="http://schemas.microsoft.com/office/drawing/2018/hyperlinkcolor" val="tx"/>
+                    </a:ext>
+                  </a:extLst>
+                </a:hlinkClick>
+              </a:rPr>
+              <a:t>Petzold, 2005</a:t>
+            </a:r>
+            <a:endParaRPr lang="en-US" sz="1100" dirty="0"/>
+          </a:p>
+          <a:p>
+            <a:pPr indent="0" marL="0">
+              <a:buNone/>
+            </a:pPr>
+            <a:r>
+              <a:rPr lang="en-US" sz="1100" dirty="0">
+                <a:solidFill>
+                  <a:schemeClr val="tx2"/>
+                </a:solidFill>
+              </a:rPr>
+              <a:t>Does Visual Studio Rot the Mind?  ·  charlespetzold.com/etc/DoesVisualStudioRotTheMind.html</a:t>
+            </a:r>
+            <a:endParaRPr lang="en-US" sz="1100" dirty="0"/>
+          </a:p>
+        </p:txBody>
+      </p:sp>
+      <p:sp>
+        <p:nvSpPr>
+          <p:cNvPr id="14" name="source 10"/>
+          <p:cNvSpPr txBox="1"/>
+          <p:nvPr/>
+        </p:nvSpPr>
+        <p:spPr>
+          <a:xfrm>
+            <a:off x="6217920" y="3090672"/>
+            <a:ext cx="5486400" cy="548640"/>
+          </a:xfrm>
+          <a:prstGeom prst="rect">
+            <a:avLst/>
+          </a:prstGeom>
+          <a:noFill/>
+          <a:ln/>
+        </p:spPr>
+        <p:txBody>
+          <a:bodyPr wrap="square" lIns="0" tIns="0" rIns="0" bIns="0" rtlCol="0" anchor="t"/>
+          <a:lstStyle/>
+          <a:p>
+            <a:pPr indent="0" marL="0">
+              <a:buNone/>
+            </a:pPr>
+            <a:r>
+              <a:rPr lang="en-US" sz="1100" b="1" u="sng" dirty="0">
+                <a:solidFill>
+                  <a:schemeClr val="accent1"/>
+                </a:solidFill>
+                <a:hlinkClick r:id="rId11" invalidUrl="" action="" tgtFrame="" tooltip="" history="1" highlightClick="0" endSnd="0">
+                  <a:extLst>
+                    <a:ext uri="{A12FA001-AC4F-418D-AE19-62706E023703}">
+                      <ahyp:hlinkClr xmlns:ahyp="http://schemas.microsoft.com/office/drawing/2018/hyperlinkcolor" val="tx"/>
+                    </a:ext>
+                  </a:extLst>
+                </a:hlinkClick>
+              </a:rPr>
+              <a:t>Fischer et al., IEEE S&amp;P 2017</a:t>
+            </a:r>
+            <a:endParaRPr lang="en-US" sz="1100" dirty="0"/>
+          </a:p>
+          <a:p>
+            <a:pPr indent="0" marL="0">
+              <a:buNone/>
+            </a:pPr>
+            <a:r>
+              <a:rPr lang="en-US" sz="1100" dirty="0">
+                <a:solidFill>
+                  <a:schemeClr val="tx2"/>
+                </a:solidFill>
+              </a:rPr>
+              <a:t>Stack Overflow Considered Harmful?  ·  arxiv.org/abs/1710.03135</a:t>
+            </a:r>
+            <a:endParaRPr lang="en-US" sz="1100" dirty="0"/>
+          </a:p>
+        </p:txBody>
+      </p:sp>
+      <p:sp>
+        <p:nvSpPr>
+          <p:cNvPr id="15" name="source 11"/>
+          <p:cNvSpPr txBox="1"/>
+          <p:nvPr/>
+        </p:nvSpPr>
+        <p:spPr>
+          <a:xfrm>
+            <a:off x="6217920" y="3694176"/>
+            <a:ext cx="5486400" cy="548640"/>
+          </a:xfrm>
+          <a:prstGeom prst="rect">
+            <a:avLst/>
+          </a:prstGeom>
+          <a:noFill/>
+          <a:ln/>
+        </p:spPr>
+        <p:txBody>
+          <a:bodyPr wrap="square" lIns="0" tIns="0" rIns="0" bIns="0" rtlCol="0" anchor="t"/>
+          <a:lstStyle/>
+          <a:p>
+            <a:pPr indent="0" marL="0">
+              <a:buNone/>
+            </a:pPr>
+            <a:r>
+              <a:rPr lang="en-US" sz="1100" b="1" u="sng" dirty="0">
+                <a:solidFill>
+                  <a:schemeClr val="accent1"/>
+                </a:solidFill>
+                <a:hlinkClick r:id="rId12" invalidUrl="" action="" tgtFrame="" tooltip="" history="1" highlightClick="0" endSnd="0">
+                  <a:extLst>
+                    <a:ext uri="{A12FA001-AC4F-418D-AE19-62706E023703}">
+                      <ahyp:hlinkClr xmlns:ahyp="http://schemas.microsoft.com/office/drawing/2018/hyperlinkcolor" val="tx"/>
+                    </a:ext>
+                  </a:extLst>
+                </a:hlinkClick>
+              </a:rPr>
+              <a:t>Brooks, 1987</a:t>
+            </a:r>
+            <a:endParaRPr lang="en-US" sz="1100" dirty="0"/>
+          </a:p>
+          <a:p>
+            <a:pPr indent="0" marL="0">
+              <a:buNone/>
+            </a:pPr>
+            <a:r>
+              <a:rPr lang="en-US" sz="1100" dirty="0">
+                <a:solidFill>
+                  <a:schemeClr val="tx2"/>
+                </a:solidFill>
+              </a:rPr>
+              <a:t>No Silver Bullet  ·  worrydream.com/refs/Brooks-NoSilverBullet.pdf</a:t>
+            </a:r>
+            <a:endParaRPr lang="en-US" sz="1100" dirty="0"/>
+          </a:p>
+        </p:txBody>
+      </p:sp>
+      <p:sp>
+        <p:nvSpPr>
+          <p:cNvPr id="16" name="source 12"/>
+          <p:cNvSpPr txBox="1"/>
+          <p:nvPr/>
+        </p:nvSpPr>
+        <p:spPr>
+          <a:xfrm>
+            <a:off x="6217920" y="4297680"/>
+            <a:ext cx="5486400" cy="548640"/>
+          </a:xfrm>
+          <a:prstGeom prst="rect">
+            <a:avLst/>
+          </a:prstGeom>
+          <a:noFill/>
+          <a:ln/>
+        </p:spPr>
+        <p:txBody>
+          <a:bodyPr wrap="square" lIns="0" tIns="0" rIns="0" bIns="0" rtlCol="0" anchor="t"/>
+          <a:lstStyle/>
+          <a:p>
+            <a:pPr indent="0" marL="0">
+              <a:buNone/>
+            </a:pPr>
+            <a:r>
+              <a:rPr lang="en-US" sz="1100" b="1" u="sng" dirty="0">
+                <a:solidFill>
+                  <a:schemeClr val="accent1"/>
+                </a:solidFill>
+                <a:hlinkClick r:id="rId13" invalidUrl="" action="" tgtFrame="" tooltip="" history="1" highlightClick="0" endSnd="0">
+                  <a:extLst>
+                    <a:ext uri="{A12FA001-AC4F-418D-AE19-62706E023703}">
+                      <ahyp:hlinkClr xmlns:ahyp="http://schemas.microsoft.com/office/drawing/2018/hyperlinkcolor" val="tx"/>
+                    </a:ext>
+                  </a:extLst>
+                </a:hlinkClick>
+              </a:rPr>
+              <a:t>Fowler, 2025</a:t>
+            </a:r>
+            <a:endParaRPr lang="en-US" sz="1100" dirty="0"/>
+          </a:p>
+          <a:p>
+            <a:pPr indent="0" marL="0">
+              <a:buNone/>
+            </a:pPr>
+            <a:r>
+              <a:rPr lang="en-US" sz="1100" dirty="0">
+                <a:solidFill>
+                  <a:schemeClr val="tx2"/>
+                </a:solidFill>
+              </a:rPr>
+              <a:t>LLMs bring new nature of abstraction  ·  martinfowler.com/articles/2025-nature-abstraction.html</a:t>
+            </a:r>
+            <a:endParaRPr lang="en-US" sz="1100" dirty="0"/>
+          </a:p>
+        </p:txBody>
+      </p:sp>
+      <p:sp>
+        <p:nvSpPr>
+          <p:cNvPr id="25" name="Slide Number Placeholder 0"/>
+          <p:cNvSpPr>
+            <a:spLocks noGrp="1"/>
+          </p:cNvSpPr>
+          <p:nvPr>
+            <p:ph type="sldNum" sz="quarter" idx="4294967295"/>
+          </p:nvPr>
+        </p:nvSpPr>
+        <p:spPr>
+          <a:xfrm>
+            <a:off x="11247120" y="6263640"/>
+            <a:ext cx="548640" cy="393192"/>
+          </a:xfrm>
+          <a:prstGeom prst="rect">
+            <a:avLst/>
+          </a:prstGeom>
+          <a:extLst>
+            <a:ext uri="{C572A759-6A51-4108-AA02-DFA0A04FC94B}">
+              <ma14:wrappingTextBoxFlag xmlns:ma14="http://schemas.microsoft.com/office/mac/drawingml/2011/main" val="0"/>
+            </a:ext>
+          </a:extLst>
+        </p:spPr>
+        <p:txBody>
+          <a:bodyPr/>
+          <a:lstStyle>
+            <a:lvl1pPr>
+              <a:defRPr sz="1000">
+                <a:solidFill>
+                  <a:schemeClr val="tx2"/>
+                </a:solidFill>
+              </a:defRPr>
+            </a:lvl1pPr>
+          </a:lstStyle>
+          <a:p>
+            <a:pPr algn="r"/>
+            <a:fld id="{F7021451-1387-4CA6-816F-3879F97B5CBC}" type="slidenum">
+              <a:rPr b="0" lang="en-US"/>
+              <a:t>23</a:t>
+            </a:fld>
+            <a:endParaRPr lang="en-US"/>
+          </a:p>
+        </p:txBody>
+      </p:sp>
+    </p:spTree>
+  </p:cSld>
+  <p:clrMapOvr>
+    <a:masterClrMapping/>
+  </p:clrMapOvr>
+</p:sld>
+</file>
+
+<file path=ppt/slides/slide24.xml><?xml version="1.0" encoding="utf-8"?>
+<p:sld xmlns:a="http://schemas.openxmlformats.org/drawingml/2006/main" xmlns:r="http://schemas.openxmlformats.org/officeDocument/2006/relationships" xmlns:p="http://schemas.openxmlformats.org/presentationml/2006/main">
+  <p:cSld name="Slide 24">
+    <p:spTree>
+      <p:nvGrpSpPr>
+        <p:cNvPr id="1" name=""/>
+        <p:cNvGrpSpPr/>
+        <p:nvPr/>
+      </p:nvGrpSpPr>
+      <p:grpSpPr>
+        <a:xfrm>
+          <a:off x="0" y="0"/>
+          <a:ext cx="0" cy="0"/>
+          <a:chOff x="0" y="0"/>
+          <a:chExt cx="0" cy="0"/>
+        </a:xfrm>
+      </p:grpSpPr>
+      <p:sp>
+        <p:nvSpPr>
+          <p:cNvPr id="2" name="Text 1"/>
+          <p:cNvSpPr/>
+          <p:nvPr>
+            <p:ph idx="102" type="title" hasCustomPrompt="1"/>
+          </p:nvPr>
+        </p:nvSpPr>
+        <p:spPr>
+          <a:xfrm>
+            <a:off x="457200" y="365760"/>
+            <a:ext cx="11274552" cy="822960"/>
+          </a:xfrm>
+          <a:prstGeom prst="rect">
+            <a:avLst/>
+          </a:prstGeom>
+          <a:noFill/>
+          <a:ln/>
+        </p:spPr>
+        <p:txBody>
+          <a:bodyPr wrap="square" lIns="0" tIns="0" rIns="0" bIns="0" rtlCol="0" anchor="ctr"/>
+          <a:lstStyle/>
+          <a:p>
+            <a:pPr algn="l" indent="0" marL="0">
+              <a:buNone/>
+            </a:pPr>
+            <a:r>
+              <a:rPr lang="en-US" sz="3200" b="1" dirty="0">
+                <a:solidFill>
+                  <a:schemeClr val="accent1"/>
+                </a:solidFill>
+              </a:rPr>
+              <a:t>Sources — employers and the market</a:t>
+            </a:r>
+            <a:endParaRPr lang="en-US" sz="3200" dirty="0"/>
+          </a:p>
+        </p:txBody>
+      </p:sp>
+      <p:sp>
+        <p:nvSpPr>
+          <p:cNvPr id="4" name="source 0"/>
+          <p:cNvSpPr txBox="1"/>
+          <p:nvPr/>
+        </p:nvSpPr>
+        <p:spPr>
+          <a:xfrm>
+            <a:off x="457200" y="1280160"/>
+            <a:ext cx="5486400" cy="548640"/>
+          </a:xfrm>
+          <a:prstGeom prst="rect">
+            <a:avLst/>
+          </a:prstGeom>
+          <a:noFill/>
+          <a:ln/>
+        </p:spPr>
+        <p:txBody>
+          <a:bodyPr wrap="square" lIns="0" tIns="0" rIns="0" bIns="0" rtlCol="0" anchor="t"/>
+          <a:lstStyle/>
+          <a:p>
+            <a:pPr indent="0" marL="0">
+              <a:buNone/>
+            </a:pPr>
+            <a:r>
+              <a:rPr lang="en-US" sz="1100" b="1" u="sng" dirty="0">
+                <a:solidFill>
+                  <a:schemeClr val="accent1"/>
+                </a:solidFill>
+                <a:hlinkClick r:id="rId1" invalidUrl="" action="" tgtFrame="" tooltip="" history="1" highlightClick="0" endSnd="0">
+                  <a:extLst>
+                    <a:ext uri="{A12FA001-AC4F-418D-AE19-62706E023703}">
+                      <ahyp:hlinkClr xmlns:ahyp="http://schemas.microsoft.com/office/drawing/2018/hyperlinkcolor" val="tx"/>
+                    </a:ext>
+                  </a:extLst>
+                </a:hlinkClick>
+              </a:rPr>
+              <a:t>Podium — Software Engineering Intern (Lehi)</a:t>
+            </a:r>
+            <a:endParaRPr lang="en-US" sz="1100" dirty="0"/>
+          </a:p>
+          <a:p>
+            <a:pPr indent="0" marL="0">
+              <a:buNone/>
+            </a:pPr>
+            <a:r>
+              <a:rPr lang="en-US" sz="1100" dirty="0">
+                <a:solidFill>
+                  <a:schemeClr val="tx2"/>
+                </a:solidFill>
+              </a:rPr>
+              <a:t>verified Oct 3, 2026  ·  job-boards.greenhouse.io/podium81/jobs/7939921</a:t>
+            </a:r>
+            <a:endParaRPr lang="en-US" sz="1100" dirty="0"/>
+          </a:p>
+        </p:txBody>
+      </p:sp>
+      <p:sp>
+        <p:nvSpPr>
+          <p:cNvPr id="5" name="source 1"/>
+          <p:cNvSpPr txBox="1"/>
+          <p:nvPr/>
+        </p:nvSpPr>
+        <p:spPr>
+          <a:xfrm>
+            <a:off x="457200" y="1883664"/>
+            <a:ext cx="5486400" cy="548640"/>
+          </a:xfrm>
+          <a:prstGeom prst="rect">
+            <a:avLst/>
+          </a:prstGeom>
+          <a:noFill/>
+          <a:ln/>
+        </p:spPr>
+        <p:txBody>
+          <a:bodyPr wrap="square" lIns="0" tIns="0" rIns="0" bIns="0" rtlCol="0" anchor="t"/>
+          <a:lstStyle/>
+          <a:p>
+            <a:pPr indent="0" marL="0">
+              <a:buNone/>
+            </a:pPr>
+            <a:r>
+              <a:rPr lang="en-US" sz="1100" b="1" u="sng" dirty="0">
+                <a:solidFill>
+                  <a:schemeClr val="accent1"/>
+                </a:solidFill>
+                <a:hlinkClick r:id="rId2" invalidUrl="" action="" tgtFrame="" tooltip="" history="1" highlightClick="0" endSnd="0">
+                  <a:extLst>
+                    <a:ext uri="{A12FA001-AC4F-418D-AE19-62706E023703}">
+                      <ahyp:hlinkClr xmlns:ahyp="http://schemas.microsoft.com/office/drawing/2018/hyperlinkcolor" val="tx"/>
+                    </a:ext>
+                  </a:extLst>
+                </a:hlinkClick>
+              </a:rPr>
+              <a:t>Podium — Senior Software Engineer (Lehi)</a:t>
+            </a:r>
+            <a:endParaRPr lang="en-US" sz="1100" dirty="0"/>
+          </a:p>
+          <a:p>
+            <a:pPr indent="0" marL="0">
+              <a:buNone/>
+            </a:pPr>
+            <a:r>
+              <a:rPr lang="en-US" sz="1100" dirty="0">
+                <a:solidFill>
+                  <a:schemeClr val="tx2"/>
+                </a:solidFill>
+              </a:rPr>
+              <a:t>verified Oct 3, 2026  ·  job-boards.greenhouse.io/podium81/jobs/6637207</a:t>
+            </a:r>
+            <a:endParaRPr lang="en-US" sz="1100" dirty="0"/>
+          </a:p>
+        </p:txBody>
+      </p:sp>
+      <p:sp>
+        <p:nvSpPr>
+          <p:cNvPr id="6" name="source 2"/>
+          <p:cNvSpPr txBox="1"/>
+          <p:nvPr/>
+        </p:nvSpPr>
+        <p:spPr>
+          <a:xfrm>
+            <a:off x="457200" y="2487168"/>
+            <a:ext cx="5486400" cy="548640"/>
+          </a:xfrm>
+          <a:prstGeom prst="rect">
+            <a:avLst/>
+          </a:prstGeom>
+          <a:noFill/>
+          <a:ln/>
+        </p:spPr>
+        <p:txBody>
+          <a:bodyPr wrap="square" lIns="0" tIns="0" rIns="0" bIns="0" rtlCol="0" anchor="t"/>
+          <a:lstStyle/>
+          <a:p>
+            <a:pPr indent="0" marL="0">
+              <a:buNone/>
+            </a:pPr>
+            <a:r>
+              <a:rPr lang="en-US" sz="1100" b="1" u="sng" dirty="0">
+                <a:solidFill>
+                  <a:schemeClr val="accent1"/>
+                </a:solidFill>
+                <a:hlinkClick r:id="rId3" invalidUrl="" action="" tgtFrame="" tooltip="" history="1" highlightClick="0" endSnd="0">
+                  <a:extLst>
+                    <a:ext uri="{A12FA001-AC4F-418D-AE19-62706E023703}">
+                      <ahyp:hlinkClr xmlns:ahyp="http://schemas.microsoft.com/office/drawing/2018/hyperlinkcolor" val="tx"/>
+                    </a:ext>
+                  </a:extLst>
+                </a:hlinkClick>
+              </a:rPr>
+              <a:t>Affirm — Senior Software Engineer</a:t>
+            </a:r>
+            <a:endParaRPr lang="en-US" sz="1100" dirty="0"/>
+          </a:p>
+          <a:p>
+            <a:pPr indent="0" marL="0">
+              <a:buNone/>
+            </a:pPr>
+            <a:r>
+              <a:rPr lang="en-US" sz="1100" dirty="0">
+                <a:solidFill>
+                  <a:schemeClr val="tx2"/>
+                </a:solidFill>
+              </a:rPr>
+              <a:t>remote, Poland; verified Oct 3, 2026  ·  job-boards.greenhouse.io/affirm/jobs/7806681003</a:t>
+            </a:r>
+            <a:endParaRPr lang="en-US" sz="1100" dirty="0"/>
+          </a:p>
+        </p:txBody>
+      </p:sp>
+      <p:sp>
+        <p:nvSpPr>
+          <p:cNvPr id="7" name="source 3"/>
+          <p:cNvSpPr txBox="1"/>
+          <p:nvPr/>
+        </p:nvSpPr>
+        <p:spPr>
+          <a:xfrm>
+            <a:off x="457200" y="3090672"/>
+            <a:ext cx="5486400" cy="548640"/>
+          </a:xfrm>
+          <a:prstGeom prst="rect">
+            <a:avLst/>
+          </a:prstGeom>
+          <a:noFill/>
+          <a:ln/>
+        </p:spPr>
+        <p:txBody>
+          <a:bodyPr wrap="square" lIns="0" tIns="0" rIns="0" bIns="0" rtlCol="0" anchor="t"/>
+          <a:lstStyle/>
+          <a:p>
+            <a:pPr indent="0" marL="0">
+              <a:buNone/>
+            </a:pPr>
+            <a:r>
+              <a:rPr lang="en-US" sz="1100" b="1" u="sng" dirty="0">
+                <a:solidFill>
+                  <a:schemeClr val="accent1"/>
+                </a:solidFill>
+                <a:hlinkClick r:id="rId4" invalidUrl="" action="" tgtFrame="" tooltip="" history="1" highlightClick="0" endSnd="0">
+                  <a:extLst>
+                    <a:ext uri="{A12FA001-AC4F-418D-AE19-62706E023703}">
+                      <ahyp:hlinkClr xmlns:ahyp="http://schemas.microsoft.com/office/drawing/2018/hyperlinkcolor" val="tx"/>
+                    </a:ext>
+                  </a:extLst>
+                </a:hlinkClick>
+              </a:rPr>
+              <a:t>1Password — Rust Developer</a:t>
+            </a:r>
+            <a:endParaRPr lang="en-US" sz="1100" dirty="0"/>
+          </a:p>
+          <a:p>
+            <a:pPr indent="0" marL="0">
+              <a:buNone/>
+            </a:pPr>
+            <a:r>
+              <a:rPr lang="en-US" sz="1100" dirty="0">
+                <a:solidFill>
+                  <a:schemeClr val="tx2"/>
+                </a:solidFill>
+              </a:rPr>
+              <a:t>verified Oct 3, 2026  ·  jobs.ashbyhq.com/1password/c247ea98-bf31-45f0-a38b-1fe255909538</a:t>
+            </a:r>
+            <a:endParaRPr lang="en-US" sz="1100" dirty="0"/>
+          </a:p>
+        </p:txBody>
+      </p:sp>
+      <p:sp>
+        <p:nvSpPr>
+          <p:cNvPr id="8" name="source 4"/>
+          <p:cNvSpPr txBox="1"/>
+          <p:nvPr/>
+        </p:nvSpPr>
+        <p:spPr>
+          <a:xfrm>
+            <a:off x="457200" y="3694176"/>
+            <a:ext cx="5486400" cy="548640"/>
+          </a:xfrm>
+          <a:prstGeom prst="rect">
+            <a:avLst/>
+          </a:prstGeom>
+          <a:noFill/>
+          <a:ln/>
+        </p:spPr>
+        <p:txBody>
+          <a:bodyPr wrap="square" lIns="0" tIns="0" rIns="0" bIns="0" rtlCol="0" anchor="t"/>
+          <a:lstStyle/>
+          <a:p>
+            <a:pPr indent="0" marL="0">
+              <a:buNone/>
+            </a:pPr>
+            <a:r>
+              <a:rPr lang="en-US" sz="1100" b="1" u="sng" dirty="0">
+                <a:solidFill>
+                  <a:schemeClr val="accent1"/>
+                </a:solidFill>
+                <a:hlinkClick r:id="rId5" invalidUrl="" action="" tgtFrame="" tooltip="" history="1" highlightClick="0" endSnd="0">
+                  <a:extLst>
+                    <a:ext uri="{A12FA001-AC4F-418D-AE19-62706E023703}">
+                      <ahyp:hlinkClr xmlns:ahyp="http://schemas.microsoft.com/office/drawing/2018/hyperlinkcolor" val="tx"/>
+                    </a:ext>
+                  </a:extLst>
+                </a:hlinkClick>
+              </a:rPr>
+              <a:t>Shopify memo, as quoted in Business Today</a:t>
+            </a:r>
+            <a:endParaRPr lang="en-US" sz="1100" dirty="0"/>
+          </a:p>
+          <a:p>
+            <a:pPr indent="0" marL="0">
+              <a:buNone/>
+            </a:pPr>
+            <a:r>
+              <a:rPr lang="en-US" sz="1100" dirty="0">
+                <a:solidFill>
+                  <a:schemeClr val="tx2"/>
+                </a:solidFill>
+              </a:rPr>
+              <a:t>Apr 2025 (secondary)  ·  businesstoday.in/technology/news/story/ai-use-is-no-longer-optional-at</a:t>
+            </a:r>
+            <a:endParaRPr lang="en-US" sz="1100" dirty="0"/>
+          </a:p>
+        </p:txBody>
+      </p:sp>
+      <p:sp>
+        <p:nvSpPr>
+          <p:cNvPr id="9" name="source 5"/>
+          <p:cNvSpPr txBox="1"/>
+          <p:nvPr/>
+        </p:nvSpPr>
+        <p:spPr>
+          <a:xfrm>
+            <a:off x="457200" y="4297680"/>
+            <a:ext cx="5486400" cy="548640"/>
+          </a:xfrm>
+          <a:prstGeom prst="rect">
+            <a:avLst/>
+          </a:prstGeom>
+          <a:noFill/>
+          <a:ln/>
+        </p:spPr>
+        <p:txBody>
+          <a:bodyPr wrap="square" lIns="0" tIns="0" rIns="0" bIns="0" rtlCol="0" anchor="t"/>
+          <a:lstStyle/>
+          <a:p>
+            <a:pPr indent="0" marL="0">
+              <a:buNone/>
+            </a:pPr>
+            <a:r>
+              <a:rPr lang="en-US" sz="1100" b="1" u="sng" dirty="0">
+                <a:solidFill>
+                  <a:schemeClr val="accent1"/>
+                </a:solidFill>
+                <a:hlinkClick r:id="rId6" invalidUrl="" action="" tgtFrame="" tooltip="" history="1" highlightClick="0" endSnd="0">
+                  <a:extLst>
+                    <a:ext uri="{A12FA001-AC4F-418D-AE19-62706E023703}">
+                      <ahyp:hlinkClr xmlns:ahyp="http://schemas.microsoft.com/office/drawing/2018/hyperlinkcolor" val="tx"/>
+                    </a:ext>
+                  </a:extLst>
+                </a:hlinkClick>
+              </a:rPr>
+              <a:t>Stanford AI Index 2026 / Lightcast</a:t>
+            </a:r>
+            <a:endParaRPr lang="en-US" sz="1100" dirty="0"/>
+          </a:p>
+          <a:p>
+            <a:pPr indent="0" marL="0">
+              <a:buNone/>
+            </a:pPr>
+            <a:r>
+              <a:rPr lang="en-US" sz="1100" dirty="0">
+                <a:solidFill>
+                  <a:schemeClr val="tx2"/>
+                </a:solidFill>
+              </a:rPr>
+              <a:t>2.5% of US postings, +55%  ·  lightcast.io/resources/research/stanford-ai-index-2026</a:t>
+            </a:r>
+            <a:endParaRPr lang="en-US" sz="1100" dirty="0"/>
+          </a:p>
+        </p:txBody>
+      </p:sp>
+      <p:sp>
+        <p:nvSpPr>
+          <p:cNvPr id="10" name="source 6"/>
+          <p:cNvSpPr txBox="1"/>
+          <p:nvPr/>
+        </p:nvSpPr>
+        <p:spPr>
+          <a:xfrm>
+            <a:off x="457200" y="4901184"/>
+            <a:ext cx="5486400" cy="548640"/>
+          </a:xfrm>
+          <a:prstGeom prst="rect">
+            <a:avLst/>
+          </a:prstGeom>
+          <a:noFill/>
+          <a:ln/>
+        </p:spPr>
+        <p:txBody>
+          <a:bodyPr wrap="square" lIns="0" tIns="0" rIns="0" bIns="0" rtlCol="0" anchor="t"/>
+          <a:lstStyle/>
+          <a:p>
+            <a:pPr indent="0" marL="0">
+              <a:buNone/>
+            </a:pPr>
+            <a:r>
+              <a:rPr lang="en-US" sz="1100" b="1" u="sng" dirty="0">
+                <a:solidFill>
+                  <a:schemeClr val="accent1"/>
+                </a:solidFill>
+                <a:hlinkClick r:id="rId7" invalidUrl="" action="" tgtFrame="" tooltip="" history="1" highlightClick="0" endSnd="0">
+                  <a:extLst>
+                    <a:ext uri="{A12FA001-AC4F-418D-AE19-62706E023703}">
+                      <ahyp:hlinkClr xmlns:ahyp="http://schemas.microsoft.com/office/drawing/2018/hyperlinkcolor" val="tx"/>
+                    </a:ext>
+                  </a:extLst>
+                </a:hlinkClick>
+              </a:rPr>
+              <a:t>match.dev, Sep 2026</a:t>
+            </a:r>
+            <a:endParaRPr lang="en-US" sz="1100" dirty="0"/>
+          </a:p>
+          <a:p>
+            <a:pPr indent="0" marL="0">
+              <a:buNone/>
+            </a:pPr>
+            <a:r>
+              <a:rPr lang="en-US" sz="1100" dirty="0">
+                <a:solidFill>
+                  <a:schemeClr val="tx2"/>
+                </a:solidFill>
+              </a:rPr>
+              <a:t>AI coding tools in 4,820 SWE postings (one scan)  ·  match.dev/post/ai-coding-tools-in-job-postings/data/</a:t>
+            </a:r>
+            <a:endParaRPr lang="en-US" sz="1100" dirty="0"/>
+          </a:p>
+        </p:txBody>
+      </p:sp>
+      <p:sp>
+        <p:nvSpPr>
+          <p:cNvPr id="11" name="source 7"/>
+          <p:cNvSpPr txBox="1"/>
+          <p:nvPr/>
+        </p:nvSpPr>
+        <p:spPr>
+          <a:xfrm>
+            <a:off x="457200" y="5504688"/>
+            <a:ext cx="5486400" cy="548640"/>
+          </a:xfrm>
+          <a:prstGeom prst="rect">
+            <a:avLst/>
+          </a:prstGeom>
+          <a:noFill/>
+          <a:ln/>
+        </p:spPr>
+        <p:txBody>
+          <a:bodyPr wrap="square" lIns="0" tIns="0" rIns="0" bIns="0" rtlCol="0" anchor="t"/>
+          <a:lstStyle/>
+          <a:p>
+            <a:pPr indent="0" marL="0">
+              <a:buNone/>
+            </a:pPr>
+            <a:r>
+              <a:rPr lang="en-US" sz="1100" b="1" u="sng" dirty="0">
+                <a:solidFill>
+                  <a:schemeClr val="accent1"/>
+                </a:solidFill>
+                <a:hlinkClick r:id="rId8" invalidUrl="" action="" tgtFrame="" tooltip="" history="1" highlightClick="0" endSnd="0">
+                  <a:extLst>
+                    <a:ext uri="{A12FA001-AC4F-418D-AE19-62706E023703}">
+                      <ahyp:hlinkClr xmlns:ahyp="http://schemas.microsoft.com/office/drawing/2018/hyperlinkcolor" val="tx"/>
+                    </a:ext>
+                  </a:extLst>
+                </a:hlinkClick>
+              </a:rPr>
+              <a:t>PwC Global AI Jobs Barometer 2026</a:t>
+            </a:r>
+            <a:endParaRPr lang="en-US" sz="1100" dirty="0"/>
+          </a:p>
+          <a:p>
+            <a:pPr indent="0" marL="0">
+              <a:buNone/>
+            </a:pPr>
+            <a:r>
+              <a:rPr lang="en-US" sz="1100" dirty="0">
+                <a:solidFill>
+                  <a:schemeClr val="tx2"/>
+                </a:solidFill>
+              </a:rPr>
+              <a:t>62% wage premium (vendor, uncontrolled)  ·  pwc.com/gx/en/issues/artificial-intelligence/job-barometer/2026/2026-g</a:t>
+            </a:r>
+            <a:endParaRPr lang="en-US" sz="1100" dirty="0"/>
+          </a:p>
+        </p:txBody>
+      </p:sp>
+      <p:sp>
+        <p:nvSpPr>
+          <p:cNvPr id="12" name="source 8"/>
+          <p:cNvSpPr txBox="1"/>
+          <p:nvPr/>
+        </p:nvSpPr>
+        <p:spPr>
+          <a:xfrm>
+            <a:off x="6217920" y="1280160"/>
+            <a:ext cx="5486400" cy="548640"/>
+          </a:xfrm>
+          <a:prstGeom prst="rect">
+            <a:avLst/>
+          </a:prstGeom>
+          <a:noFill/>
+          <a:ln/>
+        </p:spPr>
+        <p:txBody>
+          <a:bodyPr wrap="square" lIns="0" tIns="0" rIns="0" bIns="0" rtlCol="0" anchor="t"/>
+          <a:lstStyle/>
+          <a:p>
+            <a:pPr indent="0" marL="0">
+              <a:buNone/>
+            </a:pPr>
+            <a:r>
+              <a:rPr lang="en-US" sz="1100" b="1" u="sng" dirty="0">
+                <a:solidFill>
+                  <a:schemeClr val="accent1"/>
+                </a:solidFill>
+                <a:hlinkClick r:id="rId9" invalidUrl="" action="" tgtFrame="" tooltip="" history="1" highlightClick="0" endSnd="0">
+                  <a:extLst>
+                    <a:ext uri="{A12FA001-AC4F-418D-AE19-62706E023703}">
+                      <ahyp:hlinkClr xmlns:ahyp="http://schemas.microsoft.com/office/drawing/2018/hyperlinkcolor" val="tx"/>
+                    </a:ext>
+                  </a:extLst>
+                </a:hlinkClick>
+              </a:rPr>
+              <a:t>Lightcast, Jul 2025</a:t>
+            </a:r>
+            <a:endParaRPr lang="en-US" sz="1100" dirty="0"/>
+          </a:p>
+          <a:p>
+            <a:pPr indent="0" marL="0">
+              <a:buNone/>
+            </a:pPr>
+            <a:r>
+              <a:rPr lang="en-US" sz="1100" dirty="0">
+                <a:solidFill>
+                  <a:schemeClr val="tx2"/>
+                </a:solidFill>
+              </a:rPr>
+              <a:t>28% premium; 51% of AI postings outside IT (2024 data)  ·  lightcast.io/resources/blog/beyond-the-buzz-press-release-2025-07-23</a:t>
+            </a:r>
+            <a:endParaRPr lang="en-US" sz="1100" dirty="0"/>
+          </a:p>
+        </p:txBody>
+      </p:sp>
+      <p:sp>
+        <p:nvSpPr>
+          <p:cNvPr id="13" name="source 9"/>
+          <p:cNvSpPr txBox="1"/>
+          <p:nvPr/>
+        </p:nvSpPr>
+        <p:spPr>
+          <a:xfrm>
+            <a:off x="6217920" y="1883664"/>
+            <a:ext cx="5486400" cy="548640"/>
+          </a:xfrm>
+          <a:prstGeom prst="rect">
+            <a:avLst/>
+          </a:prstGeom>
+          <a:noFill/>
+          <a:ln/>
+        </p:spPr>
+        <p:txBody>
+          <a:bodyPr wrap="square" lIns="0" tIns="0" rIns="0" bIns="0" rtlCol="0" anchor="t"/>
+          <a:lstStyle/>
+          <a:p>
+            <a:pPr indent="0" marL="0">
+              <a:buNone/>
+            </a:pPr>
+            <a:r>
+              <a:rPr lang="en-US" sz="1100" b="1" u="sng" dirty="0">
+                <a:solidFill>
+                  <a:schemeClr val="accent1"/>
+                </a:solidFill>
+                <a:hlinkClick r:id="rId10" invalidUrl="" action="" tgtFrame="" tooltip="" history="1" highlightClick="0" endSnd="0">
+                  <a:extLst>
+                    <a:ext uri="{A12FA001-AC4F-418D-AE19-62706E023703}">
+                      <ahyp:hlinkClr xmlns:ahyp="http://schemas.microsoft.com/office/drawing/2018/hyperlinkcolor" val="tx"/>
+                    </a:ext>
+                  </a:extLst>
+                </a:hlinkClick>
+              </a:rPr>
+              <a:t>Brynjolfsson, Chandar &amp; Chen, Nov 2025</a:t>
+            </a:r>
+            <a:endParaRPr lang="en-US" sz="1100" dirty="0"/>
+          </a:p>
+          <a:p>
+            <a:pPr indent="0" marL="0">
+              <a:buNone/>
+            </a:pPr>
+            <a:r>
+              <a:rPr lang="en-US" sz="1100" dirty="0">
+                <a:solidFill>
+                  <a:schemeClr val="tx2"/>
+                </a:solidFill>
+              </a:rPr>
+              <a:t>Canaries in the Coal Mine (payroll data)  ·  digitaleconomy.stanford.edu/app/uploads/2025/11/CanariesintheCoalMine_</a:t>
+            </a:r>
+            <a:endParaRPr lang="en-US" sz="1100" dirty="0"/>
+          </a:p>
+        </p:txBody>
+      </p:sp>
+      <p:sp>
+        <p:nvSpPr>
+          <p:cNvPr id="14" name="source 10"/>
+          <p:cNvSpPr txBox="1"/>
+          <p:nvPr/>
+        </p:nvSpPr>
+        <p:spPr>
+          <a:xfrm>
+            <a:off x="6217920" y="2487168"/>
+            <a:ext cx="5486400" cy="548640"/>
+          </a:xfrm>
+          <a:prstGeom prst="rect">
+            <a:avLst/>
+          </a:prstGeom>
+          <a:noFill/>
+          <a:ln/>
+        </p:spPr>
+        <p:txBody>
+          <a:bodyPr wrap="square" lIns="0" tIns="0" rIns="0" bIns="0" rtlCol="0" anchor="t"/>
+          <a:lstStyle/>
+          <a:p>
+            <a:pPr indent="0" marL="0">
+              <a:buNone/>
+            </a:pPr>
+            <a:r>
+              <a:rPr lang="en-US" sz="1100" b="1" u="sng" dirty="0">
+                <a:solidFill>
+                  <a:schemeClr val="accent1"/>
+                </a:solidFill>
+                <a:hlinkClick r:id="rId11" invalidUrl="" action="" tgtFrame="" tooltip="" history="1" highlightClick="0" endSnd="0">
+                  <a:extLst>
+                    <a:ext uri="{A12FA001-AC4F-418D-AE19-62706E023703}">
+                      <ahyp:hlinkClr xmlns:ahyp="http://schemas.microsoft.com/office/drawing/2018/hyperlinkcolor" val="tx"/>
+                    </a:ext>
+                  </a:extLst>
+                </a:hlinkClick>
+              </a:rPr>
+              <a:t>Canaries dashboard</a:t>
+            </a:r>
+            <a:endParaRPr lang="en-US" sz="1100" dirty="0"/>
+          </a:p>
+          <a:p>
+            <a:pPr indent="0" marL="0">
+              <a:buNone/>
+            </a:pPr>
+            <a:r>
+              <a:rPr lang="en-US" sz="1100" dirty="0">
+                <a:solidFill>
+                  <a:schemeClr val="tx2"/>
+                </a:solidFill>
+              </a:rPr>
+              <a:t>gap widened to 19%, Aug 2026  ·  digitaleconomy.stanford.edu/project/indicators/canaries-dashboard/</a:t>
+            </a:r>
+            <a:endParaRPr lang="en-US" sz="1100" dirty="0"/>
+          </a:p>
+        </p:txBody>
+      </p:sp>
+      <p:sp>
+        <p:nvSpPr>
+          <p:cNvPr id="15" name="source 11"/>
+          <p:cNvSpPr txBox="1"/>
+          <p:nvPr/>
+        </p:nvSpPr>
+        <p:spPr>
+          <a:xfrm>
+            <a:off x="6217920" y="3090672"/>
+            <a:ext cx="5486400" cy="548640"/>
+          </a:xfrm>
+          <a:prstGeom prst="rect">
+            <a:avLst/>
+          </a:prstGeom>
+          <a:noFill/>
+          <a:ln/>
+        </p:spPr>
+        <p:txBody>
+          <a:bodyPr wrap="square" lIns="0" tIns="0" rIns="0" bIns="0" rtlCol="0" anchor="t"/>
+          <a:lstStyle/>
+          <a:p>
+            <a:pPr indent="0" marL="0">
+              <a:buNone/>
+            </a:pPr>
+            <a:r>
+              <a:rPr lang="en-US" sz="1100" b="1" u="sng" dirty="0">
+                <a:solidFill>
+                  <a:schemeClr val="accent1"/>
+                </a:solidFill>
+                <a:hlinkClick r:id="rId12" invalidUrl="" action="" tgtFrame="" tooltip="" history="1" highlightClick="0" endSnd="0">
+                  <a:extLst>
+                    <a:ext uri="{A12FA001-AC4F-418D-AE19-62706E023703}">
+                      <ahyp:hlinkClr xmlns:ahyp="http://schemas.microsoft.com/office/drawing/2018/hyperlinkcolor" val="tx"/>
+                    </a:ext>
+                  </a:extLst>
+                </a:hlinkClick>
+              </a:rPr>
+              <a:t>NACE, spring 2026</a:t>
+            </a:r>
+            <a:endParaRPr lang="en-US" sz="1100" dirty="0"/>
+          </a:p>
+          <a:p>
+            <a:pPr indent="0" marL="0">
+              <a:buNone/>
+            </a:pPr>
+            <a:r>
+              <a:rPr lang="en-US" sz="1100" dirty="0">
+                <a:solidFill>
+                  <a:schemeClr val="tx2"/>
+                </a:solidFill>
+              </a:rPr>
+              <a:t>AI skills in entry-level jobs (185 employers)  ·  naceweb.org/job-market/trends-and-predictions/demand-for-ai-skills-in-</a:t>
+            </a:r>
+            <a:endParaRPr lang="en-US" sz="1100" dirty="0"/>
+          </a:p>
+        </p:txBody>
+      </p:sp>
+      <p:sp>
+        <p:nvSpPr>
+          <p:cNvPr id="16" name="source 12"/>
+          <p:cNvSpPr txBox="1"/>
+          <p:nvPr/>
+        </p:nvSpPr>
+        <p:spPr>
+          <a:xfrm>
+            <a:off x="6217920" y="3694176"/>
+            <a:ext cx="5486400" cy="548640"/>
+          </a:xfrm>
+          <a:prstGeom prst="rect">
+            <a:avLst/>
+          </a:prstGeom>
+          <a:noFill/>
+          <a:ln/>
+        </p:spPr>
+        <p:txBody>
+          <a:bodyPr wrap="square" lIns="0" tIns="0" rIns="0" bIns="0" rtlCol="0" anchor="t"/>
+          <a:lstStyle/>
+          <a:p>
+            <a:pPr indent="0" marL="0">
+              <a:buNone/>
+            </a:pPr>
+            <a:r>
+              <a:rPr lang="en-US" sz="1100" b="1" u="sng" dirty="0">
+                <a:solidFill>
+                  <a:schemeClr val="accent1"/>
+                </a:solidFill>
+                <a:hlinkClick r:id="rId13" invalidUrl="" action="" tgtFrame="" tooltip="" history="1" highlightClick="0" endSnd="0">
+                  <a:extLst>
+                    <a:ext uri="{A12FA001-AC4F-418D-AE19-62706E023703}">
+                      <ahyp:hlinkClr xmlns:ahyp="http://schemas.microsoft.com/office/drawing/2018/hyperlinkcolor" val="tx"/>
+                    </a:ext>
+                  </a:extLst>
+                </a:hlinkClick>
+              </a:rPr>
+              <a:t>NACE student survey, 2026</a:t>
+            </a:r>
+            <a:endParaRPr lang="en-US" sz="1100" dirty="0"/>
+          </a:p>
+          <a:p>
+            <a:pPr indent="0" marL="0">
+              <a:buNone/>
+            </a:pPr>
+            <a:r>
+              <a:rPr lang="en-US" sz="1100" dirty="0">
+                <a:solidFill>
+                  <a:schemeClr val="tx2"/>
+                </a:solidFill>
+              </a:rPr>
+              <a:t>50.5% not building AI skills  ·  naceweb.org/about-us/press/2026/ready-or-reluctant-employer-expectatio</a:t>
+            </a:r>
+            <a:endParaRPr lang="en-US" sz="1100" dirty="0"/>
+          </a:p>
+        </p:txBody>
+      </p:sp>
+      <p:sp>
+        <p:nvSpPr>
+          <p:cNvPr id="17" name="source 13"/>
+          <p:cNvSpPr txBox="1"/>
+          <p:nvPr/>
+        </p:nvSpPr>
+        <p:spPr>
+          <a:xfrm>
+            <a:off x="6217920" y="4297680"/>
+            <a:ext cx="5486400" cy="548640"/>
+          </a:xfrm>
+          <a:prstGeom prst="rect">
+            <a:avLst/>
+          </a:prstGeom>
+          <a:noFill/>
+          <a:ln/>
+        </p:spPr>
+        <p:txBody>
+          <a:bodyPr wrap="square" lIns="0" tIns="0" rIns="0" bIns="0" rtlCol="0" anchor="t"/>
+          <a:lstStyle/>
+          <a:p>
+            <a:pPr indent="0" marL="0">
+              <a:buNone/>
+            </a:pPr>
+            <a:r>
+              <a:rPr lang="en-US" sz="1100" b="1" u="sng" dirty="0">
+                <a:solidFill>
+                  <a:schemeClr val="accent1"/>
+                </a:solidFill>
+                <a:hlinkClick r:id="rId14" invalidUrl="" action="" tgtFrame="" tooltip="" history="1" highlightClick="0" endSnd="0">
+                  <a:extLst>
+                    <a:ext uri="{A12FA001-AC4F-418D-AE19-62706E023703}">
+                      <ahyp:hlinkClr xmlns:ahyp="http://schemas.microsoft.com/office/drawing/2018/hyperlinkcolor" val="tx"/>
+                    </a:ext>
+                  </a:extLst>
+                </a:hlinkClick>
+              </a:rPr>
+              <a:t>Kent Beck, Apr 2023</a:t>
+            </a:r>
+            <a:endParaRPr lang="en-US" sz="1100" dirty="0"/>
+          </a:p>
+          <a:p>
+            <a:pPr indent="0" marL="0">
+              <a:buNone/>
+            </a:pPr>
+            <a:r>
+              <a:rPr lang="en-US" sz="1100" dirty="0">
+                <a:solidFill>
+                  <a:schemeClr val="tx2"/>
+                </a:solidFill>
+              </a:rPr>
+              <a:t>90% of my skills are now worth $0  ·  tidyfirst.substack.com/p/90-of-my-skills-are-now-worth-0</a:t>
+            </a:r>
+            <a:endParaRPr lang="en-US" sz="1100" dirty="0"/>
+          </a:p>
+        </p:txBody>
+      </p:sp>
+      <p:sp>
+        <p:nvSpPr>
+          <p:cNvPr id="18" name="source 14"/>
+          <p:cNvSpPr txBox="1"/>
+          <p:nvPr/>
+        </p:nvSpPr>
+        <p:spPr>
+          <a:xfrm>
+            <a:off x="6217920" y="4901184"/>
+            <a:ext cx="5486400" cy="548640"/>
+          </a:xfrm>
+          <a:prstGeom prst="rect">
+            <a:avLst/>
+          </a:prstGeom>
+          <a:noFill/>
+          <a:ln/>
+        </p:spPr>
+        <p:txBody>
+          <a:bodyPr wrap="square" lIns="0" tIns="0" rIns="0" bIns="0" rtlCol="0" anchor="t"/>
+          <a:lstStyle/>
+          <a:p>
+            <a:pPr indent="0" marL="0">
+              <a:buNone/>
+            </a:pPr>
+            <a:r>
+              <a:rPr lang="en-US" sz="1100" b="1" u="sng" dirty="0">
+                <a:solidFill>
+                  <a:schemeClr val="accent1"/>
+                </a:solidFill>
+                <a:hlinkClick r:id="rId15" invalidUrl="" action="" tgtFrame="" tooltip="" history="1" highlightClick="0" endSnd="0">
+                  <a:extLst>
+                    <a:ext uri="{A12FA001-AC4F-418D-AE19-62706E023703}">
+                      <ahyp:hlinkClr xmlns:ahyp="http://schemas.microsoft.com/office/drawing/2018/hyperlinkcolor" val="tx"/>
+                    </a:ext>
+                  </a:extLst>
+                </a:hlinkClick>
+              </a:rPr>
+              <a:t>The Hive — verbatim transcript and research report</a:t>
+            </a:r>
+            <a:endParaRPr lang="en-US" sz="1100" dirty="0"/>
+          </a:p>
+          <a:p>
+            <a:pPr indent="0" marL="0">
+              <a:buNone/>
+            </a:pPr>
+            <a:r>
+              <a:rPr lang="en-US" sz="1100" dirty="0">
+                <a:solidFill>
+                  <a:schemeClr val="tx2"/>
+                </a:solidFill>
+              </a:rPr>
+              <a:t>every prompt, every number, with its caveats  ·  github.com/The-Hive-3747/Teaching-AI-Coding</a:t>
+            </a:r>
+            <a:endParaRPr lang="en-US" sz="1100" dirty="0"/>
+          </a:p>
+        </p:txBody>
+      </p:sp>
+      <p:sp>
+        <p:nvSpPr>
+          <p:cNvPr id="25" name="Slide Number Placeholder 0"/>
+          <p:cNvSpPr>
+            <a:spLocks noGrp="1"/>
+          </p:cNvSpPr>
+          <p:nvPr>
+            <p:ph type="sldNum" sz="quarter" idx="4294967295"/>
+          </p:nvPr>
+        </p:nvSpPr>
+        <p:spPr>
+          <a:xfrm>
+            <a:off x="11247120" y="6263640"/>
+            <a:ext cx="548640" cy="393192"/>
+          </a:xfrm>
+          <a:prstGeom prst="rect">
+            <a:avLst/>
+          </a:prstGeom>
+          <a:extLst>
+            <a:ext uri="{C572A759-6A51-4108-AA02-DFA0A04FC94B}">
+              <ma14:wrappingTextBoxFlag xmlns:ma14="http://schemas.microsoft.com/office/mac/drawingml/2011/main" val="0"/>
+            </a:ext>
+          </a:extLst>
+        </p:spPr>
+        <p:txBody>
+          <a:bodyPr/>
+          <a:lstStyle>
+            <a:lvl1pPr>
+              <a:defRPr sz="1000">
+                <a:solidFill>
+                  <a:schemeClr val="tx2"/>
+                </a:solidFill>
+              </a:defRPr>
+            </a:lvl1pPr>
+          </a:lstStyle>
+          <a:p>
+            <a:pPr algn="r"/>
+            <a:fld id="{F7021451-1387-4CA6-816F-3879F97B5CBC}" type="slidenum">
+              <a:rPr b="0" lang="en-US"/>
+              <a:t>24</a:t>
+            </a:fld>
+            <a:endParaRPr lang="en-US"/>
+          </a:p>
+        </p:txBody>
+      </p:sp>
+    </p:spTree>
+  </p:cSld>
+  <p:clrMapOvr>
+    <a:masterClrMapping/>
+  </p:clrMapOvr>
+</p:sld>
+</file>
+
 <file path=ppt/slides/slide3.xml><?xml version="1.0" encoding="utf-8"?>
 <p:sld xmlns:a="http://schemas.openxmlformats.org/drawingml/2006/main" xmlns:r="http://schemas.openxmlformats.org/officeDocument/2006/relationships" xmlns:p="http://schemas.openxmlformats.org/presentationml/2006/main">
   <p:cSld name="Slide 3">

</xml_diff>

<commit_message>
The class is announced: title, date, FTC Utah's position
Deck retitled "Don't Get Stung by Your AI: Using AI Effectively for
FTC Programming" (our line stays as the tagline). FTC Utah's October
2026 statement — no effect on judging; explain, check, credit —
quoted on the "Our rule" slide and added to the sources, with the
FTC AI Innovation Corner and Chris Rake's verified line. README gets
the class details, a calendar link and an .ics file; the Google Meet
link is a placeholder until the plain URL is in hand. Demo notes
cover the Meet audience.

Co-Authored-By: Claude Fable 5.1 <noreply@anthropic.com>
Claude-Session: https://claude.ai/code/session_01RMpvKd2BDz6WMMLBDDy1nT
</commit_message>
<xml_diff>
--- a/slides/kickoff.pptx
+++ b/slides/kickoff.pptx
@@ -1053,7 +1053,7 @@
           <a:p>
             <a:r>
               <a:rPr lang="en-US" dirty="0"/>
-              <a:t>Switch to Android Studio. One of you drives the laptop, one narrates, one handles the robot. 1) Show the Gemini panel with the robot description already there. 2) Type the mecanum drive prompt live and send it; narrate what you asked for while it generates. 3) Show the generated OpMode — point at the hardware names, they match the config. 4) Build, deploy, drive. 5) Type the real refinement: "hey, in the latest push, holding both joysticks left made the robot strafe right, and vice versa. please fix" — deploy, drive again. 6) Stop there: "That's the whole method. Everything else is more trips around the loop." If it breaks, that's the method too: say what you see, paste the error into the panel, let the room watch the refine step. Don't apologize — a live fix is a better demo than a clean run.</a:t>
+              <a:t>Switch to Android Studio. One of you drives the laptop, one narrates, one handles the robot. Virtual attendees are on Google Meet: share the Android Studio screen, and point a phone camera at the robot for the drive test. 1) Show the Gemini panel with the robot description already there. 2) Type the mecanum drive prompt live and send it; narrate what you asked for while it generates. 3) Show the generated OpMode — point at the hardware names, they match the config. 4) Build, deploy, drive. 5) Type the real refinement: "hey, in the latest push, holding both joysticks left made the robot strafe right, and vice versa. please fix" — deploy, drive again. 6) Stop there: "That's the whole method. Everything else is more trips around the loop." If it breaks, that's the method too: say what you see, paste the error into the panel, let the room watch the refine step. Don't apologize — a live fix is a better demo than a clean run.</a:t>
             </a:r>
             <a:endParaRPr lang="en-US" dirty="0"/>
           </a:p>
@@ -2285,7 +2285,7 @@
           <a:p>
             <a:r>
               <a:rPr lang="en-US" dirty="0"/>
-              <a:t>This is our onboarding checklist, verbatim. Read the whole quote out loud; it is the skeptics' own position, already in our program. Before a Hive programmer is cleared, the mentor checks off, in order, 14 of the first 15 chapters of Learn Java for FTC — the book has 25; section 9, analog sensors, is skipped, and 16–25 are extra credit, each read-and-code plus the exercise, typed into our own simulator with a real test harness — then 40 FTCSIM exercises. Then, and only then, AI as a season tool. Say 'we think' on the link between this and the studies: nobody has tested the sequence; it is our reading of them. College Board already requires the same thing for AP CS: students must be prepared to explain their code in detail. And at FTC judging the students answer — an adult may attend but may not interact or coach — so a team that can't explain its code loses the Control Award whether or not AI wrote it.</a:t>
+              <a:t>This is our onboarding checklist, verbatim. Read the whole quote out loud; it is the skeptics' own position, already in our program. Before a Hive programmer is cleared, the mentor checks off, in order, 14 of the first 15 chapters of Learn Java for FTC — the book has 25; section 9, analog sensors, is skipped, and 16–25 are extra credit, each read-and-code plus the exercise, typed into our own simulator with a real test harness — then 40 FTCSIM exercises. Then, and only then, AI as a season tool. Say 'we think' on the link between this and the studies: nobody has tested the sequence; it is our reading of them. College Board already requires the same thing for AP CS: students must be prepared to explain their code in detail. And at FTC judging the students answer — an adult may attend but may not interact or coach — so a team that can't explain its code loses the Control Award whether or not AI wrote it. FTC Utah's own statement (PDP email, Oct 2026) is the same rule in their words: no effect on judging either way; students who use AI should be able to explain how it contributed, check its output, and credit it. Quote it; it's the room's own program office saying it.</a:t>
             </a:r>
             <a:endParaRPr lang="en-US" dirty="0"/>
           </a:p>
@@ -3227,8 +3227,8 @@
         </p:nvSpPr>
         <p:spPr>
           <a:xfrm>
-            <a:off x="640080" y="1828800"/>
-            <a:ext cx="5669280" cy="2651760"/>
+            <a:off x="640080" y="1737360"/>
+            <a:ext cx="5669280" cy="1737360"/>
           </a:xfrm>
           <a:prstGeom prst="rect">
             <a:avLst/>
@@ -3244,55 +3244,99 @@
               <a:buNone/>
             </a:pPr>
             <a:r>
-              <a:rPr lang="en-US" sz="4400" b="1" dirty="0">
+              <a:rPr lang="en-US" sz="4800" b="1" dirty="0">
                 <a:solidFill>
                   <a:schemeClr val="accent1"/>
                 </a:solidFill>
               </a:rPr>
-              <a:t>Describe your robot.</a:t>
-            </a:r>
-            <a:endParaRPr lang="en-US" sz="4400" dirty="0"/>
-          </a:p>
-          <a:p>
-            <a:pPr indent="0" marL="0">
-              <a:buNone/>
-            </a:pPr>
-            <a:r>
-              <a:rPr lang="en-US" sz="4400" b="1" dirty="0">
-                <a:solidFill>
-                  <a:schemeClr val="accent1"/>
-                </a:solidFill>
-              </a:rPr>
-              <a:t>Let AI write the code.</a:t>
-            </a:r>
-            <a:endParaRPr lang="en-US" sz="4400" dirty="0"/>
-          </a:p>
-          <a:p>
-            <a:pPr indent="0" marL="0">
-              <a:buNone/>
-            </a:pPr>
-            <a:r>
-              <a:rPr lang="en-US" sz="4400" b="1" dirty="0">
-                <a:solidFill>
-                  <a:schemeClr val="accent1"/>
-                </a:solidFill>
-              </a:rPr>
-              <a:t>Test. Repeat.</a:t>
-            </a:r>
-            <a:endParaRPr lang="en-US" sz="4400" dirty="0"/>
-          </a:p>
-        </p:txBody>
-      </p:sp>
-      <p:sp>
-        <p:nvSpPr>
-          <p:cNvPr id="5" name="subtitle"/>
+              <a:t>Don't Get Stung by Your AI</a:t>
+            </a:r>
+            <a:endParaRPr lang="en-US" sz="4800" dirty="0"/>
+          </a:p>
+        </p:txBody>
+      </p:sp>
+      <p:sp>
+        <p:nvSpPr>
+          <p:cNvPr id="5" name="subtitle line"/>
+          <p:cNvSpPr txBox="1"/>
+          <p:nvPr/>
+        </p:nvSpPr>
+        <p:spPr>
+          <a:xfrm>
+            <a:off x="640080" y="3429000"/>
+            <a:ext cx="5669280" cy="548640"/>
+          </a:xfrm>
+          <a:prstGeom prst="rect">
+            <a:avLst/>
+          </a:prstGeom>
+          <a:noFill/>
+          <a:ln/>
+        </p:spPr>
+        <p:txBody>
+          <a:bodyPr wrap="square" lIns="0" tIns="0" rIns="0" bIns="0" rtlCol="0" anchor="ctr"/>
+          <a:lstStyle/>
+          <a:p>
+            <a:pPr indent="0" marL="0">
+              <a:buNone/>
+            </a:pPr>
+            <a:r>
+              <a:rPr lang="en-US" sz="2200" b="1" dirty="0">
+                <a:solidFill>
+                  <a:schemeClr val="tx1"/>
+                </a:solidFill>
+              </a:rPr>
+              <a:t>Using AI Effectively for FTC Programming</a:t>
+            </a:r>
+            <a:endParaRPr lang="en-US" sz="2200" dirty="0"/>
+          </a:p>
+        </p:txBody>
+      </p:sp>
+      <p:sp>
+        <p:nvSpPr>
+          <p:cNvPr id="6" name="tagline"/>
+          <p:cNvSpPr txBox="1"/>
+          <p:nvPr/>
+        </p:nvSpPr>
+        <p:spPr>
+          <a:xfrm>
+            <a:off x="640080" y="4023360"/>
+            <a:ext cx="5669280" cy="457200"/>
+          </a:xfrm>
+          <a:prstGeom prst="rect">
+            <a:avLst/>
+          </a:prstGeom>
+          <a:noFill/>
+          <a:ln/>
+        </p:spPr>
+        <p:txBody>
+          <a:bodyPr wrap="square" lIns="0" tIns="0" rIns="0" bIns="0" rtlCol="0" anchor="ctr"/>
+          <a:lstStyle/>
+          <a:p>
+            <a:pPr indent="0" marL="0">
+              <a:buNone/>
+            </a:pPr>
+            <a:r>
+              <a:rPr lang="en-US" sz="1600" i="1" dirty="0">
+                <a:solidFill>
+                  <a:schemeClr val="accent2"/>
+                </a:solidFill>
+              </a:rPr>
+              <a:t>Describe your robot. Let AI write the code. Test. Repeat.</a:t>
+            </a:r>
+            <a:endParaRPr lang="en-US" sz="1600" dirty="0"/>
+          </a:p>
+        </p:txBody>
+      </p:sp>
+      <p:sp>
+        <p:nvSpPr>
+          <p:cNvPr id="7" name="subtitle"/>
           <p:cNvSpPr txBox="1"/>
           <p:nvPr/>
         </p:nvSpPr>
         <p:spPr>
           <a:xfrm>
             <a:off x="640080" y="4572000"/>
-            <a:ext cx="5486400" cy="1188720"/>
+            <a:ext cx="5486400" cy="1097280"/>
           </a:xfrm>
           <a:prstGeom prst="rect">
             <a:avLst/>
@@ -3308,20 +3352,20 @@
               <a:buNone/>
             </a:pPr>
             <a:r>
-              <a:rPr lang="en-US" sz="1600" dirty="0">
+              <a:rPr lang="en-US" sz="1400" dirty="0">
                 <a:solidFill>
                   <a:schemeClr val="tx1"/>
                 </a:solidFill>
               </a:rPr>
               <a:t>What The Hive learned watching our mentors code a robot in one week with Gemini in Android Studio — and how your team can do it too.</a:t>
             </a:r>
-            <a:endParaRPr lang="en-US" sz="1600" dirty="0"/>
-          </a:p>
-        </p:txBody>
-      </p:sp>
-      <p:sp>
-        <p:nvSpPr>
-          <p:cNvPr id="6" name="footer"/>
+            <a:endParaRPr lang="en-US" sz="1400" dirty="0"/>
+          </a:p>
+        </p:txBody>
+      </p:sp>
+      <p:sp>
+        <p:nvSpPr>
+          <p:cNvPr id="8" name="footer"/>
           <p:cNvSpPr txBox="1"/>
           <p:nvPr/>
         </p:nvSpPr>
@@ -3344,14 +3388,14 @@
               <a:buNone/>
             </a:pPr>
             <a:r>
-              <a:rPr lang="en-US" sz="1400" dirty="0">
+              <a:rPr lang="en-US" sz="1300" dirty="0">
                 <a:solidFill>
                   <a:schemeClr val="tx2"/>
                 </a:solidFill>
               </a:rPr>
-              <a:t>The Hive · FTC 3747 · Beehive Academy</a:t>
-            </a:r>
-            <a:endParaRPr lang="en-US" sz="1400" dirty="0"/>
+              <a:t>The Hive · FTC 3747 · Beehive Academy · Saturday, October 24, 2026 · an FTC Utah class</a:t>
+            </a:r>
+            <a:endParaRPr lang="en-US" sz="1300" dirty="0"/>
           </a:p>
         </p:txBody>
       </p:sp>
@@ -13471,7 +13515,7 @@
                   </a:extLst>
                 </a:hlinkClick>
               </a:rPr>
-              <a:t>College Board, AP CS Principles</a:t>
+              <a:t>FTC Utah — Team A.I. Use</a:t>
             </a:r>
             <a:endParaRPr lang="en-US" sz="1100" dirty="0"/>
           </a:p>
@@ -13485,7 +13529,7 @@
                   <a:schemeClr val="tx2"/>
                 </a:solidFill>
               </a:rPr>
-              <a:t>Create task directions — AI use and attribution  ·  apcentral.collegeboard.org/media/pdf/ap-csp-student-task-directions.pd</a:t>
+              <a:t>PDP email, Oct 2026: no effect on judging; explain, check, credit  ·  firstinspires.org/robotics/ftc</a:t>
             </a:r>
             <a:endParaRPr lang="en-US" sz="1100" dirty="0"/>
           </a:p>
@@ -13528,7 +13572,7 @@
                   </a:extLst>
                 </a:hlinkClick>
               </a:rPr>
-              <a:t>FTC Competition Manual 2026–27</a:t>
+              <a:t>FTC AI Innovation Corner</a:t>
             </a:r>
             <a:endParaRPr lang="en-US" sz="1100" dirty="0"/>
           </a:p>
@@ -13542,7 +13586,7 @@
                   <a:schemeClr val="tx2"/>
                 </a:solidFill>
               </a:rPr>
-              <a:t>Awards section: A201, A204, A208  ·  ftc-resources.firstinspires.org/ftc/game/manual-06</a:t>
+              <a:t>FIRST Tech Challenge Docs  ·  ftc-docs.firstinspires.org/en/latest/ai/innovation_corner/innovation-c</a:t>
             </a:r>
             <a:endParaRPr lang="en-US" sz="1100" dirty="0"/>
           </a:p>
@@ -13585,7 +13629,7 @@
                   </a:extLst>
                 </a:hlinkClick>
               </a:rPr>
-              <a:t>FIRST blog: Expanding the toolbox with AI</a:t>
+              <a:t>College Board, AP CS Principles</a:t>
             </a:r>
             <a:endParaRPr lang="en-US" sz="1100" dirty="0"/>
           </a:p>
@@ -13599,7 +13643,7 @@
                   <a:schemeClr val="tx2"/>
                 </a:solidFill>
               </a:rPr>
-              <a:t>“The answer is yes!” — credit convention  ·  community.firstinspires.org/expanding-the-first-toolbox-with-artificia</a:t>
+              <a:t>Create task directions — AI use and attribution  ·  apcentral.collegeboard.org/media/pdf/ap-csp-student-task-directions.pd</a:t>
             </a:r>
             <a:endParaRPr lang="en-US" sz="1100" dirty="0"/>
           </a:p>
@@ -13642,7 +13686,7 @@
                   </a:extLst>
                 </a:hlinkClick>
               </a:rPr>
-              <a:t>Learn Java for FTC (Alan Smith)</a:t>
+              <a:t>FTC Competition Manual 2026–27</a:t>
             </a:r>
             <a:endParaRPr lang="en-US" sz="1100" dirty="0"/>
           </a:p>
@@ -13656,7 +13700,7 @@
                   <a:schemeClr val="tx2"/>
                 </a:solidFill>
               </a:rPr>
-              <a:t>The textbook in The Hive's checklist  ·  raw.githubusercontent.com/alan412/LearnJavaForFTC/master/LearnJavaForF</a:t>
+              <a:t>Awards section: A201, A204, A208  ·  ftc-resources.firstinspires.org/ftc/game/manual-06</a:t>
             </a:r>
             <a:endParaRPr lang="en-US" sz="1100" dirty="0"/>
           </a:p>
@@ -13670,7 +13714,7 @@
         </p:nvSpPr>
         <p:spPr>
           <a:xfrm>
-            <a:off x="6217920" y="1280160"/>
+            <a:off x="457200" y="5504688"/>
             <a:ext cx="5486400" cy="548640"/>
           </a:xfrm>
           <a:prstGeom prst="rect">
@@ -13699,7 +13743,7 @@
                   </a:extLst>
                 </a:hlinkClick>
               </a:rPr>
-              <a:t>Backus, 1978</a:t>
+              <a:t>FIRST blog: Expanding the toolbox with AI</a:t>
             </a:r>
             <a:endParaRPr lang="en-US" sz="1100" dirty="0"/>
           </a:p>
@@ -13713,7 +13757,7 @@
                   <a:schemeClr val="tx2"/>
                 </a:solidFill>
               </a:rPr>
-              <a:t>The History of FORTRAN I, II, and III (HOPL)  ·  softwarepreservation.computerhistory.org/FORTRAN/paper/p165-backus.pdf</a:t>
+              <a:t>Chris Rake, COO: “AI is just one more exciting addition to the toolbox”  ·  community.firstinspires.org/expanding-the-first-toolbox-with-artificia</a:t>
             </a:r>
             <a:endParaRPr lang="en-US" sz="1100" dirty="0"/>
           </a:p>
@@ -13727,7 +13771,7 @@
         </p:nvSpPr>
         <p:spPr>
           <a:xfrm>
-            <a:off x="6217920" y="1883664"/>
+            <a:off x="6217920" y="1280160"/>
             <a:ext cx="5486400" cy="548640"/>
           </a:xfrm>
           <a:prstGeom prst="rect">
@@ -13756,7 +13800,7 @@
                   </a:extLst>
                 </a:hlinkClick>
               </a:rPr>
-              <a:t>Post, 1983</a:t>
+              <a:t>Learn Java for FTC (Alan Smith)</a:t>
             </a:r>
             <a:endParaRPr lang="en-US" sz="1100" dirty="0"/>
           </a:p>
@@ -13770,7 +13814,7 @@
                   <a:schemeClr val="tx2"/>
                 </a:solidFill>
               </a:rPr>
-              <a:t>Real Programmers Don't Use Pascal  ·  ee.torontomu.ca/~elf/hack/realmen.html</a:t>
+              <a:t>The textbook in The Hive's checklist  ·  raw.githubusercontent.com/alan412/LearnJavaForFTC/master/LearnJavaForF</a:t>
             </a:r>
             <a:endParaRPr lang="en-US" sz="1100" dirty="0"/>
           </a:p>
@@ -13784,7 +13828,7 @@
         </p:nvSpPr>
         <p:spPr>
           <a:xfrm>
-            <a:off x="6217920" y="2487168"/>
+            <a:off x="6217920" y="1883664"/>
             <a:ext cx="5486400" cy="548640"/>
           </a:xfrm>
           <a:prstGeom prst="rect">
@@ -13813,7 +13857,7 @@
                   </a:extLst>
                 </a:hlinkClick>
               </a:rPr>
-              <a:t>Petzold, 2005</a:t>
+              <a:t>Backus, 1978</a:t>
             </a:r>
             <a:endParaRPr lang="en-US" sz="1100" dirty="0"/>
           </a:p>
@@ -13827,7 +13871,7 @@
                   <a:schemeClr val="tx2"/>
                 </a:solidFill>
               </a:rPr>
-              <a:t>Does Visual Studio Rot the Mind?  ·  charlespetzold.com/etc/DoesVisualStudioRotTheMind.html</a:t>
+              <a:t>The History of FORTRAN I, II, and III (HOPL)  ·  softwarepreservation.computerhistory.org/FORTRAN/paper/p165-backus.pdf</a:t>
             </a:r>
             <a:endParaRPr lang="en-US" sz="1100" dirty="0"/>
           </a:p>
@@ -13841,7 +13885,7 @@
         </p:nvSpPr>
         <p:spPr>
           <a:xfrm>
-            <a:off x="6217920" y="3090672"/>
+            <a:off x="6217920" y="2487168"/>
             <a:ext cx="5486400" cy="548640"/>
           </a:xfrm>
           <a:prstGeom prst="rect">
@@ -13870,7 +13914,7 @@
                   </a:extLst>
                 </a:hlinkClick>
               </a:rPr>
-              <a:t>Fischer et al., IEEE S&amp;P 2017</a:t>
+              <a:t>Post, 1983</a:t>
             </a:r>
             <a:endParaRPr lang="en-US" sz="1100" dirty="0"/>
           </a:p>
@@ -13884,7 +13928,7 @@
                   <a:schemeClr val="tx2"/>
                 </a:solidFill>
               </a:rPr>
-              <a:t>Stack Overflow Considered Harmful?  ·  arxiv.org/abs/1710.03135</a:t>
+              <a:t>Real Programmers Don't Use Pascal  ·  ee.torontomu.ca/~elf/hack/realmen.html</a:t>
             </a:r>
             <a:endParaRPr lang="en-US" sz="1100" dirty="0"/>
           </a:p>
@@ -13898,7 +13942,7 @@
         </p:nvSpPr>
         <p:spPr>
           <a:xfrm>
-            <a:off x="6217920" y="3694176"/>
+            <a:off x="6217920" y="3090672"/>
             <a:ext cx="5486400" cy="548640"/>
           </a:xfrm>
           <a:prstGeom prst="rect">
@@ -13927,7 +13971,7 @@
                   </a:extLst>
                 </a:hlinkClick>
               </a:rPr>
-              <a:t>Brooks, 1987</a:t>
+              <a:t>Petzold, 2005</a:t>
             </a:r>
             <a:endParaRPr lang="en-US" sz="1100" dirty="0"/>
           </a:p>
@@ -13941,7 +13985,7 @@
                   <a:schemeClr val="tx2"/>
                 </a:solidFill>
               </a:rPr>
-              <a:t>No Silver Bullet  ·  worrydream.com/refs/Brooks-NoSilverBullet.pdf</a:t>
+              <a:t>Does Visual Studio Rot the Mind?  ·  charlespetzold.com/etc/DoesVisualStudioRotTheMind.html</a:t>
             </a:r>
             <a:endParaRPr lang="en-US" sz="1100" dirty="0"/>
           </a:p>
@@ -13950,6 +13994,63 @@
       <p:sp>
         <p:nvSpPr>
           <p:cNvPr id="16" name="source 12"/>
+          <p:cNvSpPr txBox="1"/>
+          <p:nvPr/>
+        </p:nvSpPr>
+        <p:spPr>
+          <a:xfrm>
+            <a:off x="6217920" y="3694176"/>
+            <a:ext cx="5486400" cy="548640"/>
+          </a:xfrm>
+          <a:prstGeom prst="rect">
+            <a:avLst/>
+          </a:prstGeom>
+          <a:noFill/>
+          <a:ln/>
+        </p:spPr>
+        <p:txBody>
+          <a:bodyPr wrap="square" lIns="0" tIns="0" rIns="0" bIns="0" rtlCol="0" anchor="t"/>
+          <a:lstStyle/>
+          <a:p>
+            <a:pPr indent="0" marL="0">
+              <a:buNone/>
+            </a:pPr>
+            <a:r>
+              <a:rPr lang="en-US" sz="1100" b="1" u="sng" dirty="0">
+                <a:solidFill>
+                  <a:schemeClr val="accent1"/>
+                </a:solidFill>
+                <a:hlinkClick r:id="rId13" invalidUrl="" action="" tgtFrame="" tooltip="" history="1" highlightClick="0" endSnd="0">
+                  <a:extLst>
+                    <a:ext uri="{A12FA001-AC4F-418D-AE19-62706E023703}">
+                      <ahyp:hlinkClr xmlns:ahyp="http://schemas.microsoft.com/office/drawing/2018/hyperlinkcolor" val="tx"/>
+                    </a:ext>
+                  </a:extLst>
+                </a:hlinkClick>
+              </a:rPr>
+              <a:t>Fischer et al., IEEE S&amp;P 2017</a:t>
+            </a:r>
+            <a:endParaRPr lang="en-US" sz="1100" dirty="0"/>
+          </a:p>
+          <a:p>
+            <a:pPr indent="0" marL="0">
+              <a:buNone/>
+            </a:pPr>
+            <a:r>
+              <a:rPr lang="en-US" sz="1100" dirty="0">
+                <a:solidFill>
+                  <a:schemeClr val="tx2"/>
+                </a:solidFill>
+              </a:rPr>
+              <a:t>Stack Overflow Considered Harmful?  ·  arxiv.org/abs/1710.03135</a:t>
+            </a:r>
+            <a:endParaRPr lang="en-US" sz="1100" dirty="0"/>
+          </a:p>
+        </p:txBody>
+      </p:sp>
+      <p:sp>
+        <p:nvSpPr>
+          <p:cNvPr id="17" name="source 13"/>
           <p:cNvSpPr txBox="1"/>
           <p:nvPr/>
         </p:nvSpPr>
@@ -13976,7 +14077,64 @@
                 <a:solidFill>
                   <a:schemeClr val="accent1"/>
                 </a:solidFill>
-                <a:hlinkClick r:id="rId13" invalidUrl="" action="" tgtFrame="" tooltip="" history="1" highlightClick="0" endSnd="0">
+                <a:hlinkClick r:id="rId14" invalidUrl="" action="" tgtFrame="" tooltip="" history="1" highlightClick="0" endSnd="0">
+                  <a:extLst>
+                    <a:ext uri="{A12FA001-AC4F-418D-AE19-62706E023703}">
+                      <ahyp:hlinkClr xmlns:ahyp="http://schemas.microsoft.com/office/drawing/2018/hyperlinkcolor" val="tx"/>
+                    </a:ext>
+                  </a:extLst>
+                </a:hlinkClick>
+              </a:rPr>
+              <a:t>Brooks, 1987</a:t>
+            </a:r>
+            <a:endParaRPr lang="en-US" sz="1100" dirty="0"/>
+          </a:p>
+          <a:p>
+            <a:pPr indent="0" marL="0">
+              <a:buNone/>
+            </a:pPr>
+            <a:r>
+              <a:rPr lang="en-US" sz="1100" dirty="0">
+                <a:solidFill>
+                  <a:schemeClr val="tx2"/>
+                </a:solidFill>
+              </a:rPr>
+              <a:t>No Silver Bullet  ·  worrydream.com/refs/Brooks-NoSilverBullet.pdf</a:t>
+            </a:r>
+            <a:endParaRPr lang="en-US" sz="1100" dirty="0"/>
+          </a:p>
+        </p:txBody>
+      </p:sp>
+      <p:sp>
+        <p:nvSpPr>
+          <p:cNvPr id="18" name="source 14"/>
+          <p:cNvSpPr txBox="1"/>
+          <p:nvPr/>
+        </p:nvSpPr>
+        <p:spPr>
+          <a:xfrm>
+            <a:off x="6217920" y="4901184"/>
+            <a:ext cx="5486400" cy="548640"/>
+          </a:xfrm>
+          <a:prstGeom prst="rect">
+            <a:avLst/>
+          </a:prstGeom>
+          <a:noFill/>
+          <a:ln/>
+        </p:spPr>
+        <p:txBody>
+          <a:bodyPr wrap="square" lIns="0" tIns="0" rIns="0" bIns="0" rtlCol="0" anchor="t"/>
+          <a:lstStyle/>
+          <a:p>
+            <a:pPr indent="0" marL="0">
+              <a:buNone/>
+            </a:pPr>
+            <a:r>
+              <a:rPr lang="en-US" sz="1100" b="1" u="sng" dirty="0">
+                <a:solidFill>
+                  <a:schemeClr val="accent1"/>
+                </a:solidFill>
+                <a:hlinkClick r:id="rId15" invalidUrl="" action="" tgtFrame="" tooltip="" history="1" highlightClick="0" endSnd="0">
                   <a:extLst>
                     <a:ext uri="{A12FA001-AC4F-418D-AE19-62706E023703}">
                       <ahyp:hlinkClr xmlns:ahyp="http://schemas.microsoft.com/office/drawing/2018/hyperlinkcolor" val="tx"/>
@@ -17179,7 +17337,7 @@
         <p:spPr>
           <a:xfrm>
             <a:off x="457200" y="4526280"/>
-            <a:ext cx="11247120" cy="640080"/>
+            <a:ext cx="11247120" cy="685800"/>
           </a:xfrm>
           <a:prstGeom prst="rect">
             <a:avLst/>
@@ -17195,14 +17353,14 @@
               <a:buNone/>
             </a:pPr>
             <a:r>
-              <a:rPr lang="en-US" sz="1300" dirty="0">
+              <a:rPr lang="en-US" sz="1250" dirty="0">
                 <a:solidFill>
                   <a:schemeClr val="tx2"/>
                 </a:solidFill>
               </a:rPr>
-              <a:t>Same rule as AP Computer Science Principles: “students must be prepared to explain their code in detail.” (College Board) Same rule as FTC judging: students answer; adults may only observe.</a:t>
-            </a:r>
-            <a:endParaRPr lang="en-US" sz="1300" dirty="0"/>
+              <a:t>FTC Utah says the same: students who use AI “should be able to explain how it contributed, check its output for accuracy, and credit it appropriately” — and using it or not “will have no effect on your judging.” Same rule as AP CS Principles: “students must be prepared to explain their code in detail.”</a:t>
+            </a:r>
+            <a:endParaRPr lang="en-US" sz="1250" dirty="0"/>
           </a:p>
         </p:txBody>
       </p:sp>

</xml_diff>

<commit_message>
Rewrite all prose in plain style, no em dashes
Guide, slides (deck builder, outline, PDFs), video scripts, prompts,
docs READMEs, research report and example-code README reworded in
plain sentences. Quotations from the mentors, the checklist, the
studies and Ben's approved quote are unchanged. Facts, numbers,
names, links and code unchanged. Deck rebuilt and validated; both
PDFs regenerated.

Co-Authored-By: Claude Fable 5.1 <noreply@anthropic.com>
Claude-Session: https://claude.ai/code/session_01RMpvKd2BDz6WMMLBDDy1nT
</commit_message>
<xml_diff>
--- a/slides/kickoff.pptx
+++ b/slides/kickoff.pptx
@@ -613,7 +613,7 @@
           <a:p>
             <a:r>
               <a:rPr lang="en-US" dirty="0"/>
-              <a:t>This is the slide that's ours, and the left column is our real week. Four days of coding, three of us who could code the robot, and we were siloed: Tom wrote TeleOp, Sophi wrote autonomous. The bug: an autonomous borrowed from the FtcRobotController samples only powered two wheels, and the other two were set to brake at zero power — so the robot crawled. Tom saw it in testing the morning of the competition, then had to read Sophi's code cold, without knowing what she had done, to find why. Say the thing we'd do differently: AI could have given Tom a summary of the autonomous and he could have questioned it to find the bug. The grunt work: adding one state to the autonomous meant copying the same surrounding code again — 10 to 20 minutes for a new programmer, every time. Our process: the programmer works while a mechanical teammate waits, then sets up the robot and both watch the test; mechanical problems get fixed if quick or go on the to-do list; often it's one programmer doing all of it and kludging around mechanical problems in code. The honest comparison is not 'AI was faster': it's where the bottleneck was. On our robot every change went through whoever could type Java. On the mentor robot the bottleneck moved to describing precisely — and that's a skill the mechanical people already had. The right column is from the mentor transcript: the Sep 17 session was 25 minutes and 5 prompts, then the 18th and the 19th.</a:t>
+              <a:t>This is the slide that's ours, and the left column is our real week. Four days of coding, three of us who could code the robot, and we were siloed: Tom wrote TeleOp, Sophi wrote autonomous. The bug: an autonomous borrowed from the FtcRobotController samples only powered two wheels, and the other two were set to brake at zero power, so the robot crawled. Tom saw it in testing the morning of the competition, then had to read Sophi's code cold, without knowing what she had done, to find why. Say the thing we'd do differently: AI could have given Tom a summary of the autonomous and he could have questioned it to find the bug. The grunt work: adding one state to the autonomous meant copying the same surrounding code again, 10 to 20 minutes for a new programmer, every time. Our process: the programmer works while a mechanical teammate waits, then sets up the robot and both watch the test. Mechanical problems get fixed if quick or go on the to-do list. Often it's one programmer doing all of it and kludging around mechanical problems in code. The honest comparison is where the bottleneck was, not whether 'AI was faster'. On our robot every change went through whoever could type Java. On the mentor robot the bottleneck moved to describing precisely, and that's a skill the mechanical people already had. The right column is from the mentor transcript: the Sep 17 session was 25 minutes and 5 prompts, then the 18th and the 19th.</a:t>
             </a:r>
             <a:endParaRPr lang="en-US" dirty="0"/>
           </a:p>
@@ -789,7 +789,7 @@
           <a:p>
             <a:r>
               <a:rPr lang="en-US" dirty="0"/>
-              <a:t>Point out that 'test' comes after every step. The single biggest mistake is asking for everything at once. Small steps mean when something breaks, you know which description caused it. There's a guide page and a video per checkpoint — show the repo URL.</a:t>
+              <a:t>Point out that 'test' comes after every step. The single biggest mistake is asking for everything at once. Small steps mean when something breaks, you know which description caused it. There's a guide page and a video per checkpoint. Show the repo URL.</a:t>
             </a:r>
             <a:endParaRPr lang="en-US" dirty="0"/>
           </a:p>
@@ -877,7 +877,7 @@
           <a:p>
             <a:r>
               <a:rPr lang="en-US" dirty="0"/>
-              <a:t>Read these out. Names: exactly as in the Robot Controller config — 'front_left_drive', not 'the front left motor'. If Gemini has to guess any of the five, it will, and the guess is where the bug comes from.</a:t>
+              <a:t>Read these out. Names go exactly as in the Robot Controller config: 'front_left_drive', not 'the front left motor'. If Gemini has to guess any of the five, it will, and the guess is where the bug comes from.</a:t>
             </a:r>
             <a:endParaRPr lang="en-US" dirty="0"/>
           </a:p>
@@ -965,7 +965,7 @@
           <a:p>
             <a:r>
               <a:rPr lang="en-US" dirty="0"/>
-              <a:t>Read the vague one and ask the room what Gemini would have to guess. Then the specific one: everything it would have guessed is now stated. The third one is verbatim from the Sep 19 session — no code words at all, it describes a sequence — and that's why the fix was a few lines in Intake.java. This is the slide for the mechanical kids in the room.</a:t>
+              <a:t>Read the vague one and ask the room what Gemini would have to guess. Then the specific one: everything it would have guessed is now stated. The third one is verbatim from the Sep 19 session. No code words at all, it describes a sequence, and that's why the fix was a few lines in Intake.java. This is the slide for the mechanical kids in the room.</a:t>
             </a:r>
             <a:endParaRPr lang="en-US" dirty="0"/>
           </a:p>
@@ -1053,7 +1053,7 @@
           <a:p>
             <a:r>
               <a:rPr lang="en-US" dirty="0"/>
-              <a:t>Switch to Android Studio. One of you drives the laptop, one narrates, one handles the robot. Virtual attendees are on Google Meet: share the Android Studio screen, and point a phone camera at the robot for the drive test. 1) Show the Gemini panel with the robot description already there. 2) Type the mecanum drive prompt live and send it; narrate what you asked for while it generates. 3) Show the generated OpMode — point at the hardware names, they match the config. 4) Build, deploy, drive. 5) Type the real refinement: "hey, in the latest push, holding both joysticks left made the robot strafe right, and vice versa. please fix" — deploy, drive again. 6) Stop there: "That's the whole method. Everything else is more trips around the loop." If it breaks, that's the method too: say what you see, paste the error into the panel, let the room watch the refine step. Don't apologize — a live fix is a better demo than a clean run.</a:t>
+              <a:t>Switch to Android Studio. One of you drives the laptop, one narrates, one handles the robot. Virtual attendees are on Google Meet: share the Android Studio screen, and point a phone camera at the robot for the drive test. 1) Show the Gemini panel with the robot description already there. 2) Type the mecanum drive prompt live and send it; narrate what you asked for while it generates. 3) Show the generated OpMode and point at the hardware names, which match the config. 4) Build, deploy, drive. 5) Type the real refinement: "hey, in the latest push, holding both joysticks left made the robot strafe right, and vice versa. please fix", then deploy and drive again. 6) Stop there: "That's the whole method. Everything else is more trips around the loop." If it breaks, that's the method too: say what you see, paste the error into the panel, let the room watch the refine step. Don't apologize. A live fix is a better demo than a clean run.</a:t>
             </a:r>
             <a:endParaRPr lang="en-US" dirty="0"/>
           </a:p>
@@ -1141,7 +1141,7 @@
           <a:p>
             <a:r>
               <a:rPr lang="en-US" dirty="0"/>
-              <a:t>The italic rows and the fake-gamepad row happened on the mentor robot. The compile-error and over-30-seconds rows are the ones you'll hit first that the mentors got lucky on — their delayed auto adds up to 30.7 s on paper and the field timer let it finish. The pattern: when it's wrong, the description was missing something. Say the missing thing. The fake-gamepad row is the one Ben cares most about: the auto worked, but it was tied to the TeleOp button map because nobody said an auto was coming.</a:t>
+              <a:t>The italic rows and the fake-gamepad row happened on the mentor robot. The compile-error and over-30-seconds rows are the ones you'll hit first that the mentors got lucky on. Their delayed auto adds up to 30.7 s on paper and the field timer let it finish. The pattern: when it's wrong, the description was missing something. Say the missing thing. The fake-gamepad row is the one Ben cares most about: the auto worked, but it was tied to the TeleOp button map because nobody said an auto was coming.</a:t>
             </a:r>
             <a:endParaRPr lang="en-US" dirty="0"/>
           </a:p>
@@ -1229,7 +1229,7 @@
           <a:p>
             <a:r>
               <a:rPr lang="en-US" dirty="0"/>
-              <a:t>Lead with Podium — it's twenty minutes from here, it's an INTERN posting, and it names the tools. All four postings were verified live on Oct 3, 2026; re-open the links the morning of the talk, postings expire. Podium's senior posting uses our exact phrase: a 'genuine force multiplier, not a novelty.' Affirm's line is the sharpest — the job is now 'the reviewer's seat' (note: that posting is for a remote role based in Poland; Affirm is a US company). 1Password is the whole talk in one employer: use it daily, and interview without it. The pay numbers are vendor data and uncontrolled correlation — say 'job ads advertise', never 'you will earn' — and NEVER say 'Lightcast 56%'; that number has no source. Shopify is quoted via press, not the memo itself. Don't use Microsoft's '66% won't hire without AI skills' — 2024, self-reported, by the company selling Copilot.</a:t>
+              <a:t>Lead with Podium. It's twenty minutes from here, it's an INTERN posting, and it names the tools. All four postings were verified live on Oct 3, 2026; re-open the links the morning of the talk, postings expire. Podium's senior posting uses our exact phrase: a 'genuine force multiplier, not a novelty.' Affirm's line is the sharpest: the job is now 'the reviewer's seat' (note: that posting is for a remote role based in Poland; Affirm is a US company). 1Password asks for both: use it daily, and interview without it. The pay numbers are vendor data and uncontrolled correlation, so say 'job ads advertise', never 'you will earn'. And NEVER say 'Lightcast 56%'. That number has no source. Shopify is quoted via press, not the memo itself. Don't use Microsoft's '66% won't hire without AI skills' (2024, self-reported, by the company selling Copilot).</a:t>
             </a:r>
             <a:endParaRPr lang="en-US" dirty="0"/>
           </a:p>
@@ -1317,7 +1317,7 @@
           <a:p>
             <a:r>
               <a:rPr lang="en-US" dirty="0"/>
-              <a:t>Concede the first number completely — it's payroll data, the best in the room: software developers aged 22–25 are down nearly 20% since late 2022 (Stanford 'Canaries', Nov 2025; the gap widened to 19% by Aug 2026), and the decline is where AI AUTOMATES work rather than augments it. Be precise about what it does NOT show: it does not show that having AI skills protects any individual kid. That half is our argument, so say 'we think'. The NACE numbers are a small self-reported employer survey (185 employers, sponsored by Jobscan) — lead with 16.5%, the harder number. The Kent Beck tweet is April 18, 2023, verbatim. This-season loss is an argument from one adult mentor experiment plus studies of professional developers, not evidence on students — say that too if asked.</a:t>
+              <a:t>Concede the first number completely. It's payroll data, the best in the room: software developers aged 22 to 25 are down nearly 20% since late 2022 (Stanford 'Canaries', Nov 2025, and the gap widened to 19% by Aug 2026), and the decline is where AI AUTOMATES work rather than augments it. Be precise about what it does NOT show: it does not show that having AI skills protects any individual kid. That half is our argument, so say 'we think'. The NACE numbers are a small self-reported employer survey (185 employers, sponsored by Jobscan), so lead with 16.5%, the harder number. The Kent Beck tweet is April 18, 2023, verbatim. This-season loss is an argument from one adult mentor experiment plus studies of professional developers, not evidence on students. Say that too if asked.</a:t>
             </a:r>
             <a:endParaRPr lang="en-US" dirty="0"/>
           </a:p>
@@ -1405,7 +1405,7 @@
           <a:p>
             <a:r>
               <a:rPr lang="en-US" dirty="0"/>
-              <a:t>The Reader role is the answer to 'aren't they just cheating.' If a student can explain what the state machine does and why the timings are what they are, they learned it. Tell the room which of these roles each of you would take on The Hive. The Describer on the mentor robot was Asim, the mechanical mentor — he can't write Java, and he made most of the changes.</a:t>
+              <a:t>The Reader role is the answer to 'aren't they just cheating.' If a student can explain what the state machine does and why the timings are what they are, they learned it. Tell the room which of these roles each of you would take on The Hive. The Describer on the mentor robot was Asim, the mechanical mentor. He can't write Java, and he made most of the changes.</a:t>
             </a:r>
             <a:endParaRPr lang="en-US" dirty="0"/>
           </a:p>
@@ -1493,7 +1493,7 @@
           <a:p>
             <a:r>
               <a:rPr lang="en-US" dirty="0"/>
-              <a:t>Say every line plainly; this room suspects mentors do our work. Line 1: our students hand-coded our robot this year — no AI. Line 2: the AI experiment was the mentors', on a separate robot, for the mentor competition. Line 3: we're here to hand over what it showed. Don't argue the rumor; state the facts and move on.</a:t>
+              <a:t>Say every line plainly. This room suspects mentors do our work. Line 1: our students hand-coded our robot this year, with no AI. Line 2: the AI experiment was the mentors', on a separate robot, for the mentor competition. Line 3: we're here to hand over what it showed. Don't argue the rumor. State the facts and move on.</a:t>
             </a:r>
             <a:endParaRPr lang="en-US" dirty="0"/>
           </a:p>
@@ -1581,7 +1581,7 @@
           <a:p>
             <a:r>
               <a:rPr lang="en-US" dirty="0"/>
-              <a:t>The hardware list is the one thing to do BEFORE opening Gemini. For anyone installing tonight: during the first Gradle sync, Android Studio pops up three things. Accept the Daemon JVM toolchain migration. DECLINE the Gradle/AGP upgrade — it breaks the FTC project. On Windows, accept the Defender exclusion or builds crawl. Checkpoint 0 in the guide has all three.</a:t>
+              <a:t>The hardware list is the one thing to do BEFORE opening Gemini. For anyone installing tonight: during the first Gradle sync, Android Studio pops up three things. Accept the Daemon JVM toolchain migration. DECLINE the Gradle/AGP upgrade. It breaks the FTC project. On Windows, accept the Defender exclusion or builds crawl. Checkpoint 0 in the guide has all three.</a:t>
             </a:r>
             <a:endParaRPr lang="en-US" dirty="0"/>
           </a:p>
@@ -1669,7 +1669,7 @@
           <a:p>
             <a:r>
               <a:rPr lang="en-US" dirty="0"/>
-              <a:t>Read the names. The point of the slide is that the people are named and the AI is named — the same way we're asking every team to credit its code. Royd is the team's second coach and a mechanical engineer.</a:t>
+              <a:t>Read the names. The point of the slide is that the people are named and the AI is named, the same way we're asking every team to credit its code. Royd is the team's second coach and a mechanical engineer.</a:t>
             </a:r>
             <a:endParaRPr lang="en-US" dirty="0"/>
           </a:p>
@@ -1845,7 +1845,7 @@
           <a:p>
             <a:r>
               <a:rPr lang="en-US" dirty="0"/>
-              <a:t>Slides 5–7. Every title is a live link in the PDF and the .pptx. The caveats on each item are in docs/research-ai-skills-case.md; the 'must not repeat' table there is the one to read before you present.</a:t>
+              <a:t>Slides 5 to 7. Every title is a live link in the PDF and the .pptx. The caveats on each item are in docs/research-ai-skills-case.md; the 'must not repeat' table there is the one to read before you present.</a:t>
             </a:r>
             <a:endParaRPr lang="en-US" dirty="0"/>
           </a:p>
@@ -1933,7 +1933,7 @@
           <a:p>
             <a:r>
               <a:rPr lang="en-US" dirty="0"/>
-              <a:t>Slides 15–16 and the team's own records. Job postings expire: re-open the Podium links the morning of the talk. PwC and Lightcast sell AI-related services; their wage figures are advertised-pay correlations, not controlled comparisons.</a:t>
+              <a:t>Slides 15 and 16 and the team's own records. Job postings expire: re-open the Podium links the morning of the talk. PwC and Lightcast sell AI-related services; their wage figures are advertised-pay correlations, not controlled comparisons.</a:t>
             </a:r>
             <a:endParaRPr lang="en-US" dirty="0"/>
           </a:p>
@@ -2109,7 +2109,7 @@
           <a:p>
             <a:r>
               <a:rPr lang="en-US" dirty="0"/>
-              <a:t>This is the answer to 'AI replaces the programmer' — it doesn't; it moves them up. The programmer does the prep that makes the mechanical teammate's English land: the description, the architecture, the process. Then they review every change for drift — the two real examples are on the slide, both from the mentor robot, both verbatim in the transcript: the autonomous that drove the intake through a simulated gamepad because nobody said an autonomous was coming, and the D-pad that was doing slow mode and flywheel tuning at once ('I thought gamepad 1 dpad was slow mode, not tuning the flywheel'). What the programmer gets back is the big picture: on our robot, adding one autonomous state was 10–20 minutes of copying boilerplate. That time becomes 'what do I want vision to do,' not 'how do I parse the Limelight result.'</a:t>
+              <a:t>This is the answer to 'AI replaces the programmer'. It doesn't. The programmer moves up. The programmer does the prep that makes the mechanical teammate's English land: the description, the architecture, the process. Then they review every change for drift. The two real examples are on the slide, both from the mentor robot and both verbatim in the transcript: the autonomous that drove the intake through a simulated gamepad because nobody said an autonomous was coming, and the D-pad that was doing slow mode and flywheel tuning at once ('I thought gamepad 1 dpad was slow mode, not tuning the flywheel'). What the programmer gets back is the big picture: on our robot, adding one autonomous state was 10 to 20 minutes of copying boilerplate. That time becomes 'what do I want vision to do,' not 'how do I parse the Limelight result.'</a:t>
             </a:r>
             <a:endParaRPr lang="en-US" dirty="0"/>
           </a:p>
@@ -2197,7 +2197,7 @@
           <a:p>
             <a:r>
               <a:rPr lang="en-US" dirty="0"/>
-              <a:t>Say this before they do. These are three of the strongest negative results, including the vendor's own, and all three fit our position. PNAS 2025: about 1,000 high-school students, math, randomized; plain ChatGPT made practice 48% better and the unassisted exam 17% worse; a hints-only tutor 'largely mitigated' the harm. METR 2025: 16 expert open-source maintainers on their own repos, 246 real tasks; with AI they were 19% slower and believed they'd been 20% faster — the group that gains least couldn't even perceive it. Anthropic Jan 2026: their own tool, their own study, vendor-authored and not peer-reviewed, found harm against their own interest — 52 mostly-junior engineers learning a new library, AI group 50% vs 67% on comprehension, only about 2 minutes faster; 'delegation' hurt, asking conceptual questions didn't. What separates the harm studies from the no-harm studies is HOW the tool was used — delegate and auto-accept vs ask, read the diff, explain it. That is our rule on the next slide. If someone brings up MIT 'Your Brain on ChatGPT': essays, 18 people, criticized stats — don't lean on it either way.</a:t>
+              <a:t>Say this before they do. These are three of the strongest negative results, including the vendor's own, and all three fit our position. PNAS 2025: about 1,000 high-school students, math, randomized; plain ChatGPT made practice 48% better and the unassisted exam 17% worse. A hints-only tutor 'largely mitigated' the harm. METR 2025: 16 expert open-source maintainers on their own repos, 246 real tasks. With AI they were 19% slower and believed they'd been 20% faster, so the group that gains least couldn't even perceive it. Anthropic Jan 2026: their own tool, their own study, vendor-authored and not peer-reviewed, found harm against their own interest. 52 mostly-junior engineers learning a new library: the AI group scored 50% vs 67% on comprehension and was only about 2 minutes faster. 'Delegation' hurt. Asking conceptual questions didn't. What separates the harm studies from the no-harm studies is HOW the tool was used: delegate and auto-accept, versus ask, read the diff, explain it. That is our rule on the next slide. If someone brings up MIT 'Your Brain on ChatGPT' (essays, 18 people, criticized stats), don't lean on it either way.</a:t>
             </a:r>
             <a:endParaRPr lang="en-US" dirty="0"/>
           </a:p>
@@ -2285,7 +2285,7 @@
           <a:p>
             <a:r>
               <a:rPr lang="en-US" dirty="0"/>
-              <a:t>This is our onboarding checklist, verbatim. Read the whole quote out loud; it is the skeptics' own position, already in our program. Before a Hive programmer is cleared, the mentor checks off, in order, 14 of the first 15 chapters of Learn Java for FTC — the book has 25; section 9, analog sensors, is skipped, and 16–25 are extra credit, each read-and-code plus the exercise, typed into our own simulator with a real test harness — then 40 FTCSIM exercises. Then, and only then, AI as a season tool. Say 'we think' on the link between this and the studies: nobody has tested the sequence; it is our reading of them. College Board already requires the same thing for AP CS: students must be prepared to explain their code in detail. And at FTC judging the students answer — an adult may attend but may not interact or coach — so a team that can't explain its code loses the Control Award whether or not AI wrote it. FTC Utah's own statement (PDP email, Oct 2026) is the same rule in their words: no effect on judging either way; students who use AI should be able to explain how it contributed, check its output, and credit it. Quote it; it's the room's own program office saying it.</a:t>
+              <a:t>This is our onboarding checklist, verbatim. Read the whole quote out loud. It is the skeptics' own position, already in our program. Before a Hive programmer is cleared, the mentor checks off, in order, 14 of the first 15 chapters of Learn Java for FTC, each read-and-code plus the exercise, typed into our own simulator with a real test harness, and then 40 FTCSIM exercises. The book has 25 chapters: section 9, analog sensors, is skipped, and 16 to 25 are extra credit. Then, and only then, AI as a season tool. Say 'we think' on the link between this and the studies. Nobody has tested the sequence. It is our reading of them. College Board already requires the same thing for AP CS: students must be prepared to explain their code in detail. And at FTC judging the students answer (an adult may attend but may not interact or coach), so a team that can't explain its code loses the Control Award whether or not AI wrote it. FTC Utah's own statement (PDP email, Oct 2026) is the same rule in their words: no effect on judging either way, and students who use AI should be able to explain how it contributed, check its output, and credit it. Quote it. It's the room's own program office saying it.</a:t>
             </a:r>
             <a:endParaRPr lang="en-US" dirty="0"/>
           </a:p>
@@ -2373,7 +2373,7 @@
           <a:p>
             <a:r>
               <a:rPr lang="en-US" dirty="0"/>
-              <a:t>Most new layers of programming tools were called a crutch by the generation before — in the sources we found there's no named 1954 skeptic, only Backus remembering them, so say 'most', not 'every'. Each layer took over the typing; none took over deciding what to build, testing it, or reading what came out. Brooks said it in 1987. Fowler's honest limit (2025): this layer is non-deterministic — the same prompt doesn't give the same code twice — so reading and testing matter MORE than before, not less. Then tell the fake-gamepad story: Gemini drove our mentors' autonomous through a simulated gamepad because nobody said an autonomous was coming. It worked. A human reading the code caught it. That's the whole slide in one bug. Sources are in docs/research-ai-skills-case.md, slide 1 table.</a:t>
+              <a:t>Most new layers of programming tools were called a crutch by the generation before. In the sources we found there's no named 1954 skeptic, only Backus remembering them, so say 'most', not 'every'. Each layer took over the typing. None took over deciding what to build, testing it, or reading what came out. Brooks said it in 1987. Fowler's honest limit (2025) is that this layer is non-deterministic. The same prompt doesn't give the same code twice, so reading and testing matter MORE than before, not less. Then tell the fake-gamepad story: Gemini drove our mentors' autonomous through a simulated gamepad because nobody said an autonomous was coming. It worked, and a human reading the code caught it. Sources are in docs/research-ai-skills-case.md, slide 1 table.</a:t>
             </a:r>
             <a:endParaRPr lang="en-US" dirty="0"/>
           </a:p>
@@ -2461,7 +2461,7 @@
           <a:p>
             <a:r>
               <a:rPr lang="en-US" dirty="0"/>
-              <a:t>Tell this as a story, not a list. Be precise about who did what, because coaches will ask: Ben described the architecture on night one and built the TeleOp out over the first two days — the shooter startup sequence, the pulsed feed, the LEDs. The first autonomous was Asim's design, called out at the robot while Ben typed, and from there it was a pair — Asim deciding what to change, Ben typing — plus eight prompts Asim typed himself: tank drive, the strafe fix, the spitting-balls pair, a whole experimental autonomous with three rounds of tuning. The point for the room: the person who understands the robot drives the prompt, whoever's hands are on the keys. Two things make the experiment honest, and say both: Ben CAN write Java, so choosing to describe instead of type was a choice; Asim can't, and made most of the changes anyway. The quotes are verbatim, typos and all. The screenshot is the 'spitting balls out' prompt exactly as typed, with Gemini's answer. If there's time, play docs/video/scrimmage-match3-auto.mp4 from the laptop here.</a:t>
+              <a:t>Tell this as a story, not a list. Be precise about who did what, because coaches will ask: Ben described the architecture on night one and built the TeleOp out over the first two days: the shooter startup sequence, the pulsed feed, the LEDs. The first autonomous was Asim's design, called out at the robot while Ben typed, and from there it was a pair, Asim deciding what to change and Ben typing, plus eight prompts Asim typed himself: tank drive, the strafe fix, the spitting-balls pair, a whole experimental autonomous with three rounds of tuning. The point for the room: the person who understands the robot drives the prompt, whoever's hands are on the keys. Two things make the experiment honest, and say both. Ben CAN write Java, so choosing to describe instead of type was a choice. Asim can't, and made most of the changes anyway. The quotes are verbatim, typos and all. The screenshot is the 'spitting balls out' prompt exactly as typed, with Gemini's answer. If there's time, play docs/video/scrimmage-match3-auto.mp4 from the laptop here.</a:t>
             </a:r>
             <a:endParaRPr lang="en-US" dirty="0"/>
           </a:p>
@@ -3357,7 +3357,7 @@
                   <a:schemeClr val="tx1"/>
                 </a:solidFill>
               </a:rPr>
-              <a:t>What The Hive learned watching our mentors code a robot in one week with Gemini in Android Studio — and how your team can do it too.</a:t>
+              <a:t>What The Hive learned watching our mentors code a robot in one week with Gemini in Android Studio, and how your team can do it too.</a:t>
             </a:r>
             <a:endParaRPr lang="en-US" sz="1400" dirty="0"/>
           </a:p>
@@ -3492,7 +3492,7 @@
                   <a:schemeClr val="tx1"/>
                 </a:solidFill>
               </a:rPr>
-              <a:t>Our robot — hand-coded by us</a:t>
+              <a:t>Our robot, hand-coded by us</a:t>
             </a:r>
             <a:endParaRPr lang="en-US" sz="2000" dirty="0"/>
           </a:p>
@@ -3528,7 +3528,7 @@
                   <a:schemeClr val="accent1"/>
                 </a:solidFill>
               </a:rPr>
-              <a:t>Mentor robot — described to Gemini</a:t>
+              <a:t>Mentor robot, described to Gemini</a:t>
             </a:r>
             <a:endParaRPr lang="en-US" sz="2000" dirty="0"/>
           </a:p>
@@ -3618,7 +3618,7 @@
                   <a:schemeClr val="tx1"/>
                 </a:solidFill>
               </a:rPr>
-              <a:t>3 of us could code it: Tom, Sophi, Sadiqah. Siloed — Tom wrote TeleOp, Sophi wrote autonomous</a:t>
+              <a:t>3 of us could code it: Tom, Sophi, Sadiqah. We were siloed, Tom on TeleOp and Sophi on autonomous</a:t>
             </a:r>
             <a:endParaRPr lang="en-US" sz="1150" dirty="0"/>
           </a:p>
@@ -3654,7 +3654,7 @@
                   <a:schemeClr val="tx1"/>
                 </a:solidFill>
               </a:rPr>
-              <a:t>2 people wrote prompts — one writes Java, one doesn't</a:t>
+              <a:t>2 people wrote prompts, one who writes Java and one who doesn't</a:t>
             </a:r>
             <a:endParaRPr lang="en-US" sz="1150" dirty="0"/>
           </a:p>
@@ -3870,7 +3870,7 @@
                   <a:schemeClr val="tx1"/>
                 </a:solidFill>
               </a:rPr>
-              <a:t>A borrowed sample autonomous only powered two wheels — the other two were braking. Tom saw the robot crawl in morning testing, then had to read Sophi's code cold to find why</a:t>
+              <a:t>A borrowed sample autonomous only powered two wheels, and the other two were braking. Tom saw the robot crawl in morning testing, then had to read Sophi's code cold to find why</a:t>
             </a:r>
             <a:endParaRPr lang="en-US" sz="1150" dirty="0"/>
           </a:p>
@@ -3906,7 +3906,7 @@
                   <a:schemeClr val="tx1"/>
                 </a:solidFill>
               </a:rPr>
-              <a:t>Mechanical mentor fixed strafe, flywheel bump and controls — in English, no Java</a:t>
+              <a:t>Mechanical mentor fixed strafe, flywheel bump and controls in English, with no Java</a:t>
             </a:r>
             <a:endParaRPr lang="en-US" sz="1150" dirty="0"/>
           </a:p>
@@ -3996,7 +3996,7 @@
                   <a:schemeClr val="tx1"/>
                 </a:solidFill>
               </a:rPr>
-              <a:t>Programmer codes while the mechanical teammate waits; often one programmer does it all and kludges around mechanical problems. One new autonomous state: 10–20 minutes of boilerplate</a:t>
+              <a:t>Programmer codes while the mechanical teammate waits. Often one programmer does it all and kludges around mechanical problems. One new autonomous state: 10 to 20 minutes of boilerplate</a:t>
             </a:r>
             <a:endParaRPr lang="en-US" sz="1150" dirty="0"/>
           </a:p>
@@ -4158,7 +4158,7 @@
                   <a:schemeClr val="tx1"/>
                 </a:solidFill>
               </a:rPr>
-              <a:t>Someone still has to read what Gemini wrote — the Reader role</a:t>
+              <a:t>Someone still has to read what Gemini wrote (the Reader role)</a:t>
             </a:r>
             <a:endParaRPr lang="en-US" sz="1150" dirty="0"/>
           </a:p>
@@ -4969,7 +4969,7 @@
                   <a:schemeClr val="accent1"/>
                 </a:solidFill>
               </a:rPr>
-              <a:t>The checkpoints — one trip around the loop each</a:t>
+              <a:t>The checkpoints, one trip around the loop each</a:t>
             </a:r>
             <a:endParaRPr lang="en-US" sz="3200" dirty="0"/>
           </a:p>
@@ -6041,7 +6041,7 @@
                   <a:schemeClr val="accent1"/>
                 </a:solidFill>
               </a:rPr>
-              <a:t>github.com/The-Hive-3747/Teaching-AI-Coding — a guide page and a video per checkpoint</a:t>
+              <a:t>github.com/The-Hive-3747/Teaching-AI-Coding: a guide page and a video per checkpoint</a:t>
             </a:r>
             <a:endParaRPr lang="en-US" sz="1300" dirty="0"/>
           </a:p>
@@ -7255,7 +7255,7 @@
                   <a:schemeClr val="accent1"/>
                 </a:solidFill>
               </a:rPr>
-              <a:t>Real — Sep 19 session, verbatim</a:t>
+              <a:t>Real: Sep 19 session, verbatim</a:t>
             </a:r>
             <a:endParaRPr lang="en-US" sz="1800" dirty="0"/>
           </a:p>
@@ -7327,7 +7327,7 @@
                   <a:schemeClr val="tx2"/>
                 </a:solidFill>
               </a:rPr>
-              <a:t>No code words. A sequence. A few lines changed in Intake.java.</a:t>
+              <a:t>No code words, just a sequence, and a few lines changed in Intake.java.</a:t>
             </a:r>
             <a:endParaRPr lang="en-US" sz="1200" dirty="0"/>
           </a:p>
@@ -7733,7 +7733,7 @@
                   <a:schemeClr val="accent1"/>
                 </a:solidFill>
               </a:rPr>
-              <a:t>Where it goes wrong — and the fix</a:t>
+              <a:t>Where it goes wrong, and the fix</a:t>
             </a:r>
             <a:endParaRPr lang="en-US" sz="3200" dirty="0"/>
           </a:p>
@@ -8828,7 +8828,7 @@
                             <a:srgbClr val="FFFFFF"/>
                           </a:solidFill>
                         </a:rPr>
-                        <a:t>Say it up front: “An autonomous will use this class later — put the behavior in plain methods.” Gemini takes the expedient route unless you say what's coming.</a:t>
+                        <a:t>Say it up front: “An autonomous will use this class later, so put the behavior in plain methods.” Gemini takes the expedient route unless you say what's coming.</a:t>
                       </a:r>
                       <a:endParaRPr lang="en-US" sz="1300" dirty="0"/>
                     </a:p>
@@ -9487,7 +9487,7 @@
                   <a:schemeClr val="tx1"/>
                 </a:solidFill>
               </a:rPr>
-              <a:t>“Familiarity with AI-assisted development tools such as Cursor, Claude Code, Codex, GitHub Copilot, or similar.” — alongside “Strong programming fundamentals…”</a:t>
+              <a:t>“Familiarity with AI-assisted development tools such as Cursor, Claude Code, Codex, GitHub Copilot, or similar.” Listed alongside “Strong programming fundamentals…”</a:t>
             </a:r>
             <a:endParaRPr lang="en-US" sz="1150" dirty="0"/>
           </a:p>
@@ -9784,7 +9784,7 @@
                   <a:schemeClr val="tx1"/>
                 </a:solidFill>
               </a:rPr>
-              <a:t>“Effective at using AI tooling to accelerate development, testing, debugging…” — and the interview is run without AI</a:t>
+              <a:t>“Effective at using AI tooling to accelerate development, testing, debugging…” and the interview is run without AI</a:t>
             </a:r>
             <a:endParaRPr lang="en-US" sz="1150" dirty="0"/>
           </a:p>
@@ -9856,7 +9856,7 @@
                   <a:schemeClr val="tx2"/>
                 </a:solidFill>
               </a:rPr>
-              <a:t>of all US job postings asked for AI skills in 2025 — up 55% in one year (Stanford AI Index 2026 / Lightcast)</a:t>
+              <a:t>of all US job postings asked for AI skills in 2025, up 55% in one year (Stanford AI Index 2026 / Lightcast)</a:t>
             </a:r>
             <a:endParaRPr lang="en-US" sz="1150" dirty="0"/>
           </a:p>
@@ -10000,7 +10000,7 @@
                   <a:schemeClr val="tx2"/>
                 </a:solidFill>
               </a:rPr>
-              <a:t>“Reflexive AI usage is now a baseline expectation at Shopify.” — Tobi Lütke, CEO, Apr 2025 (as quoted in press)</a:t>
+              <a:t>Tobi Lütke, CEO, Apr 2025 (as quoted in press): “Reflexive AI usage is now a baseline expectation at Shopify.”</a:t>
             </a:r>
             <a:endParaRPr lang="en-US" sz="1150" dirty="0"/>
           </a:p>
@@ -10036,7 +10036,7 @@
                   <a:schemeClr val="tx2"/>
                 </a:solidFill>
               </a:rPr>
-              <a:t>Job ads that ask for AI skills advertise higher pay — PwC 62% within occupation (global, 2025), Lightcast 28% (US, 2024). Vendor data; correlation, not a promise.</a:t>
+              <a:t>Job ads that ask for AI skills advertise higher pay: PwC 62% within occupation (global, 2025), Lightcast 28% (US, 2024). This is vendor data and a correlation, not a promise.</a:t>
             </a:r>
             <a:endParaRPr lang="en-US" sz="1200" dirty="0"/>
           </a:p>
@@ -10243,7 +10243,7 @@
                   <a:schemeClr val="tx1"/>
                 </a:solidFill>
               </a:rPr>
-              <a:t>Software developers aged 22–25: employment down nearly 20%, late 2022 → Sep 2025 (payroll data). For young workers in AI-exposed jobs the gap widened to 19% by Aug 2026. — Stanford “Canaries in the Coal Mine”</a:t>
+              <a:t>Software developers aged 22 to 25: employment down nearly 20%, late 2022 → Sep 2025 (payroll data). For young workers in AI-exposed jobs the gap widened to 19% by Aug 2026. (Stanford “Canaries in the Coal Mine”)</a:t>
             </a:r>
             <a:endParaRPr lang="en-US" sz="1250" dirty="0"/>
           </a:p>
@@ -10342,7 +10342,7 @@
                   <a:schemeClr val="tx1"/>
                 </a:solidFill>
               </a:rPr>
-              <a:t>of entry-level job descriptions now emphasize AI skills, up from 10.5% in fall 2025; employers say over a third of entry-level jobs require them. — NACE, spring 2026 (185 employers)</a:t>
+              <a:t>of entry-level job descriptions now emphasize AI skills, up from 10.5% in fall 2025; employers say over a third of entry-level jobs require them. (NACE, spring 2026, 185 employers)</a:t>
             </a:r>
             <a:endParaRPr lang="en-US" sz="1250" dirty="0"/>
           </a:p>
@@ -10441,7 +10441,7 @@
                   <a:schemeClr val="tx1"/>
                 </a:solidFill>
               </a:rPr>
-              <a:t>of graduating seniors aren't building AI skills at all. — NACE student survey, 2026</a:t>
+              <a:t>of graduating seniors aren't building AI skills at all. (NACE student survey, 2026)</a:t>
             </a:r>
             <a:endParaRPr lang="en-US" sz="1250" dirty="0"/>
           </a:p>
@@ -10513,7 +10513,7 @@
                   <a:schemeClr val="accent1"/>
                 </a:solidFill>
               </a:rPr>
-              <a:t>— Kent Beck, creator of Extreme Programming, April 2023</a:t>
+              <a:t>Kent Beck, creator of Extreme Programming, April 2023</a:t>
             </a:r>
             <a:endParaRPr lang="en-US" sz="1200" dirty="0"/>
           </a:p>
@@ -10756,7 +10756,7 @@
                   <a:schemeClr val="tx1"/>
                 </a:solidFill>
               </a:rPr>
-              <a:t>Whoever knows the robot best says what to change. They can type it or someone else can — what matters is whose words they are.</a:t>
+              <a:t>Whoever knows the robot best says what to change. They can type it or someone else can. What matters is whose words they are.</a:t>
             </a:r>
             <a:endParaRPr lang="en-US" sz="1300" dirty="0"/>
           </a:p>
@@ -11994,7 +11994,7 @@
                   <a:schemeClr val="tx1"/>
                 </a:solidFill>
               </a:rPr>
-              <a:t>Your robot's hardware config done on the Driver Hub — names and ports</a:t>
+              <a:t>Your robot's hardware config done on the Driver Hub, with names and ports</a:t>
             </a:r>
             <a:endParaRPr lang="en-US" sz="1600" dirty="0"/>
           </a:p>
@@ -12179,7 +12179,7 @@
                   <a:schemeClr val="accent1"/>
                 </a:solidFill>
               </a:rPr>
-              <a:t>First Gradle sync — three pop-ups</a:t>
+              <a:t>First Gradle sync: three pop-ups</a:t>
             </a:r>
             <a:endParaRPr lang="en-US" sz="1500" dirty="0"/>
           </a:p>
@@ -12257,7 +12257,7 @@
                   <a:schemeClr val="tx1"/>
                 </a:solidFill>
               </a:rPr>
-              <a:t> the Gradle / AGP upgrade — it breaks the FTC project</a:t>
+              <a:t> the Gradle / AGP upgrade, which breaks the FTC project</a:t>
             </a:r>
             <a:endParaRPr lang="en-US" sz="1400" dirty="0"/>
           </a:p>
@@ -12354,7 +12354,7 @@
                   <a:schemeClr val="accent1"/>
                 </a:solidFill>
               </a:rPr>
-              <a:t>Or bring your robot to a Hive training session. We'll teach your students to prompt. You leave with a driving robot — maybe more.</a:t>
+              <a:t>Or bring your robot to a Hive training session. We'll teach your students to prompt, and you leave with a driving robot, maybe more.</a:t>
             </a:r>
             <a:endParaRPr lang="en-US" sz="1400" dirty="0"/>
           </a:p>
@@ -12498,7 +12498,7 @@
                   <a:schemeClr val="accent1"/>
                 </a:solidFill>
               </a:rPr>
-              <a:t>Tom, Sophi and Sadiqah — The Hive's programmers</a:t>
+              <a:t>Tom, Sophi and Sadiqah, The Hive's programmers</a:t>
             </a:r>
             <a:endParaRPr lang="en-US" sz="1700" dirty="0"/>
           </a:p>
@@ -12570,7 +12570,7 @@
                   <a:schemeClr val="accent1"/>
                 </a:solidFill>
               </a:rPr>
-              <a:t>Ben — coordinator</a:t>
+              <a:t>Ben, coordinator</a:t>
             </a:r>
             <a:endParaRPr lang="en-US" sz="1700" dirty="0"/>
           </a:p>
@@ -12642,7 +12642,7 @@
                   <a:schemeClr val="accent1"/>
                 </a:solidFill>
               </a:rPr>
-              <a:t>Annie — head coach</a:t>
+              <a:t>Annie, head coach</a:t>
             </a:r>
             <a:endParaRPr lang="en-US" sz="1700" dirty="0"/>
           </a:p>
@@ -12706,7 +12706,7 @@
                   <a:schemeClr val="accent1"/>
                 </a:solidFill>
               </a:rPr>
-              <a:t>Asim — mechanical mentor</a:t>
+              <a:t>Asim, mechanical mentor</a:t>
             </a:r>
             <a:endParaRPr lang="en-US" sz="1700" dirty="0"/>
           </a:p>
@@ -12742,7 +12742,7 @@
                   <a:schemeClr val="tx2"/>
                 </a:solidFill>
               </a:rPr>
-              <a:t>Built the mentor robot; authored most of the later changes in plain English, eight of them at the keyboard.</a:t>
+              <a:t>Built the mentor robot and authored most of the later changes in plain English, eight of them at the keyboard.</a:t>
             </a:r>
             <a:endParaRPr lang="en-US" sz="1300" dirty="0"/>
           </a:p>
@@ -12778,7 +12778,7 @@
                   <a:schemeClr val="accent1"/>
                 </a:solidFill>
               </a:rPr>
-              <a:t>Royd — coach and mechanical engineer</a:t>
+              <a:t>Royd, coach and mechanical engineer</a:t>
             </a:r>
             <a:endParaRPr lang="en-US" sz="1700" dirty="0"/>
           </a:p>
@@ -13224,7 +13224,7 @@
                   <a:schemeClr val="tx2"/>
                 </a:solidFill>
               </a:rPr>
-              <a:t>Guide, videos, every real prompt, and the code — all of it.</a:t>
+              <a:t>Guide, videos, every real prompt, and the code. All of it.</a:t>
             </a:r>
             <a:endParaRPr lang="en-US" sz="1600" dirty="0"/>
           </a:p>
@@ -13301,7 +13301,7 @@
                   <a:schemeClr val="accent1"/>
                 </a:solidFill>
               </a:rPr>
-              <a:t>Sources — studies, rules, history</a:t>
+              <a:t>Sources: studies, rules, history</a:t>
             </a:r>
             <a:endParaRPr lang="en-US" sz="3200" dirty="0"/>
           </a:p>
@@ -13358,7 +13358,7 @@
                   <a:schemeClr val="tx2"/>
                 </a:solidFill>
               </a:rPr>
-              <a:t>Generative AI can harm learning — ~1,000 HS students  ·  scale.stanford.edu/publications/generative-ai-can-harm-learning</a:t>
+              <a:t>Generative AI can harm learning (~1,000 HS students)  ·  scale.stanford.edu/publications/generative-ai-can-harm-learning</a:t>
             </a:r>
             <a:endParaRPr lang="en-US" sz="1100" dirty="0"/>
           </a:p>
@@ -13515,7 +13515,7 @@
                   </a:extLst>
                 </a:hlinkClick>
               </a:rPr>
-              <a:t>FTC Utah — Team A.I. Use</a:t>
+              <a:t>FTC Utah: Team A.I. Use</a:t>
             </a:r>
             <a:endParaRPr lang="en-US" sz="1100" dirty="0"/>
           </a:p>
@@ -13643,7 +13643,7 @@
                   <a:schemeClr val="tx2"/>
                 </a:solidFill>
               </a:rPr>
-              <a:t>Create task directions — AI use and attribution  ·  apcentral.collegeboard.org/media/pdf/ap-csp-student-task-directions.pd</a:t>
+              <a:t>Create task directions: AI use and attribution  ·  apcentral.collegeboard.org/media/pdf/ap-csp-student-task-directions.pd</a:t>
             </a:r>
             <a:endParaRPr lang="en-US" sz="1100" dirty="0"/>
           </a:p>
@@ -13686,7 +13686,7 @@
                   </a:extLst>
                 </a:hlinkClick>
               </a:rPr>
-              <a:t>FTC Competition Manual 2026–27</a:t>
+              <a:t>FTC Competition Manual 2026-27</a:t>
             </a:r>
             <a:endParaRPr lang="en-US" sz="1100" dirty="0"/>
           </a:p>
@@ -14264,7 +14264,7 @@
                   <a:schemeClr val="accent1"/>
                 </a:solidFill>
               </a:rPr>
-              <a:t>Sources — employers and the market</a:t>
+              <a:t>Sources: employers and the market</a:t>
             </a:r>
             <a:endParaRPr lang="en-US" sz="3200" dirty="0"/>
           </a:p>
@@ -14307,7 +14307,7 @@
                   </a:extLst>
                 </a:hlinkClick>
               </a:rPr>
-              <a:t>Podium — Software Engineering Intern (Lehi)</a:t>
+              <a:t>Podium: Software Engineering Intern (Lehi)</a:t>
             </a:r>
             <a:endParaRPr lang="en-US" sz="1100" dirty="0"/>
           </a:p>
@@ -14364,7 +14364,7 @@
                   </a:extLst>
                 </a:hlinkClick>
               </a:rPr>
-              <a:t>Podium — Senior Software Engineer (Lehi)</a:t>
+              <a:t>Podium: Senior Software Engineer (Lehi)</a:t>
             </a:r>
             <a:endParaRPr lang="en-US" sz="1100" dirty="0"/>
           </a:p>
@@ -14421,7 +14421,7 @@
                   </a:extLst>
                 </a:hlinkClick>
               </a:rPr>
-              <a:t>Affirm — Senior Software Engineer</a:t>
+              <a:t>Affirm: Senior Software Engineer</a:t>
             </a:r>
             <a:endParaRPr lang="en-US" sz="1100" dirty="0"/>
           </a:p>
@@ -14478,7 +14478,7 @@
                   </a:extLst>
                 </a:hlinkClick>
               </a:rPr>
-              <a:t>1Password — Rust Developer</a:t>
+              <a:t>1Password: Rust Developer</a:t>
             </a:r>
             <a:endParaRPr lang="en-US" sz="1100" dirty="0"/>
           </a:p>
@@ -15105,7 +15105,7 @@
                   </a:extLst>
                 </a:hlinkClick>
               </a:rPr>
-              <a:t>The Hive — verbatim transcript and research report</a:t>
+              <a:t>The Hive: verbatim transcript and research report</a:t>
             </a:r>
             <a:endParaRPr lang="en-US" sz="1100" dirty="0"/>
           </a:p>
@@ -15928,7 +15928,7 @@
                   <a:schemeClr val="tx1"/>
                 </a:solidFill>
               </a:rPr>
-              <a:t> the robot — every motor and servo, name, port, direction.</a:t>
+              <a:t> the robot: every motor and servo, name, port, direction.</a:t>
             </a:r>
             <a:endParaRPr lang="en-US" sz="1600" dirty="0"/>
           </a:p>
@@ -15956,7 +15956,7 @@
                   <a:schemeClr val="tx1"/>
                 </a:solidFill>
               </a:rPr>
-              <a:t> it — subsystems, state machines, what the autonomous will need later.</a:t>
+              <a:t> it: subsystems, state machines, what the autonomous will need later.</a:t>
             </a:r>
             <a:endParaRPr lang="en-US" sz="1600" dirty="0"/>
           </a:p>
@@ -15984,7 +15984,7 @@
                   <a:schemeClr val="tx1"/>
                 </a:solidFill>
               </a:rPr>
-              <a:t> — one change per prompt, test, commit.</a:t>
+              <a:t>: one change per prompt, test, commit.</a:t>
             </a:r>
             <a:endParaRPr lang="en-US" sz="1600" dirty="0"/>
           </a:p>
@@ -16111,7 +16111,7 @@
                   <a:schemeClr val="tx1"/>
                 </a:solidFill>
               </a:rPr>
-              <a:t> what the AI did — and catch drift.</a:t>
+              <a:t> what the AI did, and catch drift.</a:t>
             </a:r>
             <a:endParaRPr lang="en-US" sz="1600" dirty="0"/>
           </a:p>
@@ -16128,7 +16128,7 @@
                   <a:schemeClr val="tx2"/>
                 </a:solidFill>
               </a:rPr>
-              <a:t>On the mentor robot: the autonomous that drove the intake through a fake gamepad. The D-pad that ended up doing two things — slow mode and flywheel tuning — instead of one.</a:t>
+              <a:t>On the mentor robot: the autonomous that drove the intake through a fake gamepad. The D-pad that ended up doing two things (slow mode and flywheel tuning) instead of one.</a:t>
             </a:r>
             <a:endParaRPr lang="en-US" sz="1600" dirty="0"/>
           </a:p>
@@ -16142,7 +16142,7 @@
                   <a:schemeClr val="tx2"/>
                 </a:solidFill>
               </a:rPr>
-              <a:t>Both worked. Both were wrong. Only a programmer reading the code saw it.</a:t>
+              <a:t>Both worked, and both were wrong. Only a programmer reading the code saw it.</a:t>
             </a:r>
             <a:endParaRPr lang="en-US" sz="1600" dirty="0"/>
           </a:p>
@@ -16556,7 +16556,7 @@
                   <a:schemeClr val="tx1"/>
                 </a:solidFill>
               </a:rPr>
-              <a:t>METR 2025 · 16 expert maintainers on their own code, 246 tasks. With AI they took 19% longer — and believed they'd been 20% faster.</a:t>
+              <a:t>METR 2025 · 16 expert maintainers on their own code, 246 tasks. With AI they took 19% longer, and believed they'd been 20% faster.</a:t>
             </a:r>
             <a:endParaRPr lang="en-US" sz="1300" dirty="0"/>
           </a:p>
@@ -16727,7 +16727,7 @@
                   <a:schemeClr val="accent1"/>
                 </a:solidFill>
               </a:rPr>
-              <a:t>The difference is how you use it. Delegate and auto-accept: you lose understanding. Ask, read the diff, explain it: you don't. That's our rule — next slide.</a:t>
+              <a:t>The difference is how you use it. Delegate and auto-accept: you lose understanding. Ask, read the diff, explain it: you don't. That's our rule, on the next slide.</a:t>
             </a:r>
             <a:endParaRPr lang="en-US" sz="1700" dirty="0"/>
           </a:p>
@@ -16934,7 +16934,7 @@
                   <a:schemeClr val="accent1"/>
                 </a:solidFill>
               </a:rPr>
-              <a:t>— The Hive, 2026 Programming Training Checklist</a:t>
+              <a:t>The Hive, 2026 Programming Training Checklist</a:t>
             </a:r>
             <a:endParaRPr lang="en-US" sz="1200" dirty="0"/>
           </a:p>
@@ -17031,7 +17031,7 @@
                   <a:schemeClr val="tx1"/>
                 </a:solidFill>
               </a:rPr>
-              <a:t>chapters of Learn Java for FTC, by hand — read, type, do the exercise</a:t>
+              <a:t>chapters of Learn Java for FTC, by hand: read, type, do the exercise</a:t>
             </a:r>
             <a:endParaRPr lang="en-US" sz="1300" dirty="0"/>
           </a:p>
@@ -17128,7 +17128,7 @@
                   <a:schemeClr val="tx1"/>
                 </a:solidFill>
               </a:rPr>
-              <a:t>FTCSIM exercises — Intro, Movement, Sensors, Puzzles, Grabby</a:t>
+              <a:t>FTCSIM exercises: Intro, Movement, Sensors, Puzzles, Grabby</a:t>
             </a:r>
             <a:endParaRPr lang="en-US" sz="1300" dirty="0"/>
           </a:p>
@@ -17322,7 +17322,7 @@
                   <a:schemeClr val="tx1"/>
                 </a:solidFill>
               </a:rPr>
-              <a:t>AI as a season tool — and you still explain the code</a:t>
+              <a:t>AI as a season tool, and you still explain the code</a:t>
             </a:r>
             <a:endParaRPr lang="en-US" sz="1300" dirty="0"/>
           </a:p>
@@ -17358,7 +17358,7 @@
                   <a:schemeClr val="tx2"/>
                 </a:solidFill>
               </a:rPr>
-              <a:t>FTC Utah says the same: students who use AI “should be able to explain how it contributed, check its output for accuracy, and credit it appropriately” — and using it or not “will have no effect on your judging.” Same rule as AP CS Principles: “students must be prepared to explain their code in detail.”</a:t>
+              <a:t>FTC Utah says the same: students who use AI “should be able to explain how it contributed, check its output for accuracy, and credit it appropriately”, and using it or not “will have no effect on your judging.” Same rule as AP CS Principles: “students must be prepared to explain their code in detail.”</a:t>
             </a:r>
             <a:endParaRPr lang="en-US" sz="1250" dirty="0"/>
           </a:p>
@@ -17610,7 +17610,7 @@
                   <a:schemeClr val="tx2"/>
                 </a:solidFill>
               </a:rPr>
-              <a:t>“the strength of the skepticism about ‘automatic programming’… as it existed in 1954” — John Backus, who led the FORTRAN team, writing in 1978</a:t>
+              <a:t>John Backus, who led the FORTRAN team, writing in 1978: “the strength of the skepticism about ‘automatic programming’… as it existed in 1954”</a:t>
             </a:r>
             <a:endParaRPr lang="en-US" sz="1500" dirty="0"/>
           </a:p>
@@ -17718,7 +17718,7 @@
                   <a:schemeClr val="tx2"/>
                 </a:solidFill>
               </a:rPr>
-              <a:t>“Real Programmers use FORTRAN. Quiche Eaters use PASCAL.” — Ed Post</a:t>
+              <a:t>Ed Post: “Real Programmers use FORTRAN. Quiche Eaters use PASCAL.”</a:t>
             </a:r>
             <a:endParaRPr lang="en-US" sz="1500" dirty="0"/>
           </a:p>
@@ -17826,7 +17826,7 @@
                   <a:schemeClr val="tx2"/>
                 </a:solidFill>
               </a:rPr>
-              <a:t>“And I think it's making us dumber.” — Charles Petzold, on IntelliSense</a:t>
+              <a:t>Charles Petzold, on IntelliSense: “And I think it's making us dumber.”</a:t>
             </a:r>
             <a:endParaRPr lang="en-US" sz="1500" dirty="0"/>
           </a:p>
@@ -17934,7 +17934,7 @@
                   <a:schemeClr val="tx2"/>
                 </a:solidFill>
               </a:rPr>
-              <a:t>15.4% of 1.3 M Android apps contained security-related code copied from Stack Overflow; 97.9% of those had an insecure snippet — Fischer et al., IEEE S&amp;P</a:t>
+              <a:t>15.4% of 1.3 M Android apps contained security-related code copied from Stack Overflow, and 97.9% of those had an insecure snippet (Fischer et al., IEEE S&amp;P)</a:t>
             </a:r>
             <a:endParaRPr lang="en-US" sz="1500" dirty="0"/>
           </a:p>
@@ -18042,7 +18042,7 @@
                   <a:schemeClr val="tx2"/>
                 </a:solidFill>
               </a:rPr>
-              <a:t>Gemini drove our mentors' autonomous through a fake gamepad. It worked. A human reading the code caught it.</a:t>
+              <a:t>Gemini drove our mentors' autonomous through a fake gamepad. It worked, and a human reading the code caught it.</a:t>
             </a:r>
             <a:endParaRPr lang="en-US" sz="1500" dirty="0"/>
           </a:p>
@@ -18078,7 +18078,7 @@
                   <a:schemeClr val="accent1"/>
                 </a:solidFill>
               </a:rPr>
-              <a:t>Every layer took the typing. None took the architecture, the testing, or the reading. — “the hard part of building software [is] the specification, design, and testing of this conceptual construct, not the labor of representing it.” Fred Brooks, 1987</a:t>
+              <a:t>Every layer took the typing. None took the architecture, the testing, or the reading. Fred Brooks, 1987: “the hard part of building software [is] the specification, design, and testing of this conceptual construct, not the labor of representing it.”</a:t>
             </a:r>
             <a:endParaRPr lang="en-US" sz="1400" dirty="0"/>
           </a:p>
@@ -18186,7 +18186,7 @@
                   <a:schemeClr val="accent1"/>
                 </a:solidFill>
               </a:rPr>
-              <a:t>What the mentors did — the week</a:t>
+              <a:t>What the mentors did that week</a:t>
             </a:r>
             <a:endParaRPr lang="en-US" sz="3200" dirty="0"/>
           </a:p>
@@ -18403,7 +18403,7 @@
                   <a:schemeClr val="tx2"/>
                 </a:solidFill>
               </a:rPr>
-              <a:t>First autonomous state machines, Shoot First / Shoot Delayed — Asim's design, called out at the robot, typed by Ben</a:t>
+              <a:t>First autonomous state machines, Shoot First / Shoot Delayed. Asim's design, called out at the robot, typed by Ben</a:t>
             </a:r>
             <a:endParaRPr lang="en-US" sz="1100" dirty="0"/>
           </a:p>
@@ -18597,7 +18597,7 @@
                   <a:schemeClr val="tx1"/>
                 </a:solidFill>
               </a:rPr>
-              <a:t>“it is spitting balls out, so i would like to shorten it” — reverse bump 200 → 100 ms</a:t>
+              <a:t>“it is spitting balls out, so i would like to shorten it” (reverse bump 200 → 100 ms)</a:t>
             </a:r>
             <a:endParaRPr lang="en-US" sz="1100" dirty="0"/>
           </a:p>
@@ -18985,7 +18985,7 @@
                   <a:schemeClr val="tx1"/>
                 </a:solidFill>
               </a:rPr>
-              <a:t>“Let's set the default speed to 0.95” — default changed from 1.0</a:t>
+              <a:t>“Let's set the default speed to 0.95” (default changed from 1.0)</a:t>
             </a:r>
             <a:endParaRPr lang="en-US" sz="1100" dirty="0"/>
           </a:p>
@@ -19142,7 +19142,7 @@
                   <a:schemeClr val="tx2"/>
                 </a:solidFill>
               </a:rPr>
-              <a:t>Sep 19, 8:36 AM, as typed — and Gemini's reply: it reports the numbers (200 ms at −0.5, 300 ms pause), offers two options, then changes both at once. The next prompt put the power back.</a:t>
+              <a:t>Sep 19, 8:36 AM, as typed, with Gemini's reply. It reports the numbers (200 ms at −0.5, 300 ms pause), offers two options, then changes both at once. The next prompt put the power back.</a:t>
             </a:r>
             <a:endParaRPr lang="en-US" sz="1100" dirty="0"/>
           </a:p>
@@ -19347,7 +19347,7 @@
                   <a:schemeClr val="accent1"/>
                 </a:solidFill>
               </a:rPr>
-              <a:t>— Ben, our coordinator</a:t>
+              <a:t>Ben, our coordinator</a:t>
             </a:r>
             <a:endParaRPr lang="en-US" sz="1800" dirty="0"/>
           </a:p>

</xml_diff>